<commit_message>
System Design vi: sd-14-021 deck says what the run compared (review finding)
Co-Authored-By: Claude Sonnet 5.5 <noreply@anthropic.com>
Claude-Session: https://claude.ai/code/session_01WnjciXNJBLEd8jy3HrG49S
</commit_message>
<xml_diff>
--- a/system-design-101/vi/lessons/sd-14-021/slides/sd-14-021.pptx
+++ b/system-design-101/vi/lessons/sd-14-021/slides/sd-14-021.pptx
@@ -15319,7 +15319,7 @@
       </p:sp>
       <p:sp>
         <p:nvSpPr>
-          <p:cNvPr id="14" name="Connector line-1792382602736-427927234"/>
+          <p:cNvPr id="14" name="Connector line-1792384783392-924908790"/>
           <p:cNvSpPr/>
           <p:nvPr/>
         </p:nvSpPr>
@@ -15344,7 +15344,7 @@
       </p:sp>
       <p:sp>
         <p:nvSpPr>
-          <p:cNvPr id="15" name="Connector line-1792382602736-461322485"/>
+          <p:cNvPr id="15" name="Connector line-1792384783393-395786552"/>
           <p:cNvSpPr/>
           <p:nvPr/>
         </p:nvSpPr>
@@ -15468,11 +15468,11 @@
         <p:spPr>
           <a:xfrm>
             <a:off x="8915400" y="3048000"/>
-            <a:ext cx="3924300" cy="2667000"/>
+            <a:ext cx="3924300" cy="2476500"/>
           </a:xfrm>
           <a:prstGeom prst="roundRect">
             <a:avLst>
-              <a:gd name="adj" fmla="val 7857"/>
+              <a:gd name="adj" fmla="val 8462"/>
             </a:avLst>
           </a:prstGeom>
           <a:solidFill>
@@ -15549,14 +15549,14 @@
       </p:sp>
       <p:sp>
         <p:nvSpPr>
-          <p:cNvPr id="19" name="Text richtext-1792382602742-516033307"/>
+          <p:cNvPr id="19" name="Text richtext-1792384783399-720538879"/>
           <p:cNvSpPr/>
           <p:nvPr/>
         </p:nvSpPr>
         <p:spPr>
           <a:xfrm>
             <a:off x="9163050" y="3752850"/>
-            <a:ext cx="3429000" cy="1809750"/>
+            <a:ext cx="3429000" cy="1676400"/>
           </a:xfrm>
           <a:prstGeom prst="rect">
             <a:avLst/>
@@ -15756,12 +15756,12 @@
         </p:nvSpPr>
         <p:spPr>
           <a:xfrm>
-            <a:off x="8915400" y="5905500"/>
-            <a:ext cx="3924300" cy="2571750"/>
+            <a:off x="8915400" y="5715000"/>
+            <a:ext cx="3924300" cy="2762250"/>
           </a:xfrm>
           <a:prstGeom prst="roundRect">
             <a:avLst>
-              <a:gd name="adj" fmla="val 8148"/>
+              <a:gd name="adj" fmla="val 7586"/>
             </a:avLst>
           </a:prstGeom>
           <a:solidFill>
@@ -15783,8 +15783,8 @@
         </p:nvSpPr>
         <p:spPr>
           <a:xfrm>
-            <a:off x="9163050" y="6153150"/>
-            <a:ext cx="3429000" cy="285750"/>
+            <a:off x="9163050" y="5924550"/>
+            <a:ext cx="3524250" cy="285750"/>
           </a:xfrm>
           <a:prstGeom prst="rect">
             <a:avLst/>
@@ -15800,7 +15800,7 @@
               <a:buNone/>
             </a:pPr>
             <a:r>
-              <a:rPr lang="en-US" sz="1650" b="1" spc="225" kern="0" dirty="0">
+              <a:rPr lang="en-US" sz="1650" b="1" spc="222" kern="0" dirty="0">
                 <a:solidFill>
                   <a:srgbClr val="9A98A0"/>
                 </a:solidFill>
@@ -15808,10 +15808,10 @@
                 <a:ea typeface="Be Vietnam Pro" pitchFamily="34" charset="-122"/>
                 <a:cs typeface="Be Vietnam Pro" pitchFamily="34" charset="-120"/>
               </a:rPr>
-              <a:t>CHỈ</a:t>
-            </a:r>
-            <a:r>
-              <a:rPr lang="en-US" sz="1650" b="1" spc="211" kern="0" dirty="0">
+              <a:t>LẦN</a:t>
+            </a:r>
+            <a:r>
+              <a:rPr lang="en-US" sz="1650" b="1" spc="191" kern="0" dirty="0">
                 <a:solidFill>
                   <a:srgbClr val="9A98A0"/>
                 </a:solidFill>
@@ -15819,10 +15819,10 @@
                 <a:ea typeface="Be Vietnam Pro" pitchFamily="34" charset="-122"/>
                 <a:cs typeface="Be Vietnam Pro" pitchFamily="34" charset="-120"/>
               </a:rPr>
-              <a:t> KHÁC</a:t>
-            </a:r>
-            <a:r>
-              <a:rPr lang="en-US" sz="1650" b="1" spc="229" kern="0" dirty="0">
+              <a:t> CHẠY</a:t>
+            </a:r>
+            <a:r>
+              <a:rPr lang="en-US" sz="1650" b="1" spc="204" kern="0" dirty="0">
                 <a:solidFill>
                   <a:srgbClr val="9A98A0"/>
                 </a:solidFill>
@@ -15830,7 +15830,29 @@
                 <a:ea typeface="Be Vietnam Pro" pitchFamily="34" charset="-122"/>
                 <a:cs typeface="Be Vietnam Pro" pitchFamily="34" charset="-120"/>
               </a:rPr>
-              <a:t> Ở</a:t>
+              <a:t> ĐÃ</a:t>
+            </a:r>
+            <a:r>
+              <a:rPr lang="en-US" sz="1650" b="1" spc="234" kern="0" dirty="0">
+                <a:solidFill>
+                  <a:srgbClr val="9A98A0"/>
+                </a:solidFill>
+                <a:latin typeface="Be Vietnam Pro" pitchFamily="34" charset="0"/>
+                <a:ea typeface="Be Vietnam Pro" pitchFamily="34" charset="-122"/>
+                <a:cs typeface="Be Vietnam Pro" pitchFamily="34" charset="-120"/>
+              </a:rPr>
+              <a:t> SO</a:t>
+            </a:r>
+            <a:r>
+              <a:rPr lang="en-US" sz="1650" b="1" spc="215" kern="0" dirty="0">
+                <a:solidFill>
+                  <a:srgbClr val="9A98A0"/>
+                </a:solidFill>
+                <a:latin typeface="Be Vietnam Pro" pitchFamily="34" charset="0"/>
+                <a:ea typeface="Be Vietnam Pro" pitchFamily="34" charset="-122"/>
+                <a:cs typeface="Be Vietnam Pro" pitchFamily="34" charset="-120"/>
+              </a:rPr>
+              <a:t> SÁNH</a:t>
             </a:r>
             <a:endParaRPr lang="en-US" sz="1650" dirty="0"/>
           </a:p>
@@ -15844,7 +15866,7 @@
         </p:nvSpPr>
         <p:spPr>
           <a:xfrm>
-            <a:off x="9163050" y="6591300"/>
+            <a:off x="9163050" y="6305550"/>
             <a:ext cx="3429000" cy="342900"/>
           </a:xfrm>
           <a:prstGeom prst="rect">
@@ -15916,7 +15938,7 @@
         </p:nvSpPr>
         <p:spPr>
           <a:xfrm>
-            <a:off x="9163050" y="6972300"/>
+            <a:off x="9163050" y="6667500"/>
             <a:ext cx="3524250" cy="285750"/>
           </a:xfrm>
           <a:prstGeom prst="rect">
@@ -16021,7 +16043,7 @@
         </p:nvSpPr>
         <p:spPr>
           <a:xfrm>
-            <a:off x="9163050" y="7581900"/>
+            <a:off x="9163050" y="7143750"/>
             <a:ext cx="3429000" cy="342900"/>
           </a:xfrm>
           <a:prstGeom prst="rect">
@@ -16098,7 +16120,140 @@
       </p:sp>
       <p:sp>
         <p:nvSpPr>
-          <p:cNvPr id="25" name="Shape 23"/>
+          <p:cNvPr id="25" name="Text 23"/>
+          <p:cNvSpPr/>
+          <p:nvPr/>
+        </p:nvSpPr>
+        <p:spPr>
+          <a:xfrm>
+            <a:off x="9163050" y="7639050"/>
+            <a:ext cx="3429000" cy="342900"/>
+          </a:xfrm>
+          <a:prstGeom prst="rect">
+            <a:avLst/>
+          </a:prstGeom>
+          <a:noFill/>
+          <a:ln/>
+        </p:spPr>
+        <p:txBody>
+          <a:bodyPr wrap="square" lIns="0" tIns="0" rIns="0" bIns="0" rtlCol="0" anchor="t"/>
+          <a:lstStyle/>
+          <a:p>
+            <a:pPr algn="l" indent="0" marL="0">
+              <a:buNone/>
+            </a:pPr>
+            <a:r>
+              <a:rPr lang="en-US" sz="2100" b="1" dirty="0" spc="-7" kern="0">
+                <a:solidFill>
+                  <a:srgbClr val="F3EEE3"/>
+                </a:solidFill>
+                <a:latin typeface="Be Vietnam Pro" pitchFamily="34" charset="0"/>
+                <a:ea typeface="Be Vietnam Pro" pitchFamily="34" charset="-122"/>
+                <a:cs typeface="Be Vietnam Pro" pitchFamily="34" charset="-120"/>
+              </a:rPr>
+              <a:t>Khóa</a:t>
+            </a:r>
+            <a:r>
+              <a:rPr lang="en-US" sz="2100" b="1" dirty="0" spc="-10" kern="0">
+                <a:solidFill>
+                  <a:srgbClr val="F3EEE3"/>
+                </a:solidFill>
+                <a:latin typeface="Be Vietnam Pro" pitchFamily="34" charset="0"/>
+                <a:ea typeface="Be Vietnam Pro" pitchFamily="34" charset="-122"/>
+                <a:cs typeface="Be Vietnam Pro" pitchFamily="34" charset="-120"/>
+              </a:rPr>
+              <a:t> công</a:t>
+            </a:r>
+            <a:r>
+              <a:rPr lang="en-US" sz="2100" b="1" dirty="0" spc="-5" kern="0">
+                <a:solidFill>
+                  <a:srgbClr val="F3EEE3"/>
+                </a:solidFill>
+                <a:latin typeface="Be Vietnam Pro" pitchFamily="34" charset="0"/>
+                <a:ea typeface="Be Vietnam Pro" pitchFamily="34" charset="-122"/>
+                <a:cs typeface="Be Vietnam Pro" pitchFamily="34" charset="-120"/>
+              </a:rPr>
+              <a:t> khai</a:t>
+            </a:r>
+            <a:endParaRPr lang="en-US" sz="2100" dirty="0"/>
+          </a:p>
+        </p:txBody>
+      </p:sp>
+      <p:sp>
+        <p:nvSpPr>
+          <p:cNvPr id="26" name="Text 24"/>
+          <p:cNvSpPr/>
+          <p:nvPr/>
+        </p:nvSpPr>
+        <p:spPr>
+          <a:xfrm>
+            <a:off x="9163050" y="8001000"/>
+            <a:ext cx="3524250" cy="285750"/>
+          </a:xfrm>
+          <a:prstGeom prst="rect">
+            <a:avLst/>
+          </a:prstGeom>
+          <a:noFill/>
+          <a:ln/>
+        </p:spPr>
+        <p:txBody>
+          <a:bodyPr wrap="square" lIns="0" tIns="0" rIns="0" bIns="0" rtlCol="0" anchor="t"/>
+          <a:lstStyle/>
+          <a:p>
+            <a:pPr algn="l" indent="0" marL="0">
+              <a:buNone/>
+            </a:pPr>
+            <a:r>
+              <a:rPr lang="en-US" sz="1650" dirty="0" spc="1" kern="0">
+                <a:solidFill>
+                  <a:srgbClr val="9A98A0"/>
+                </a:solidFill>
+                <a:latin typeface="Be Vietnam Pro" pitchFamily="34" charset="0"/>
+                <a:ea typeface="Be Vietnam Pro" pitchFamily="34" charset="-122"/>
+                <a:cs typeface="Be Vietnam Pro" pitchFamily="34" charset="-120"/>
+              </a:rPr>
+              <a:t>phép</a:t>
+            </a:r>
+            <a:r>
+              <a:rPr lang="en-US" sz="1650" dirty="0" spc="3" kern="0">
+                <a:solidFill>
+                  <a:srgbClr val="9A98A0"/>
+                </a:solidFill>
+                <a:latin typeface="Be Vietnam Pro" pitchFamily="34" charset="0"/>
+                <a:ea typeface="Be Vietnam Pro" pitchFamily="34" charset="-122"/>
+                <a:cs typeface="Be Vietnam Pro" pitchFamily="34" charset="-120"/>
+              </a:rPr>
+              <a:t> thử</a:t>
+            </a:r>
+            <a:r>
+              <a:rPr lang="en-US" sz="1650" dirty="0" spc="0" kern="0">
+                <a:solidFill>
+                  <a:srgbClr val="9A98A0"/>
+                </a:solidFill>
+                <a:latin typeface="Be Vietnam Pro" pitchFamily="34" charset="0"/>
+                <a:ea typeface="Be Vietnam Pro" pitchFamily="34" charset="-122"/>
+                <a:cs typeface="Be Vietnam Pro" pitchFamily="34" charset="-120"/>
+              </a:rPr>
+              <a:t> ghim</a:t>
+            </a:r>
+            <a:r>
+              <a:rPr lang="en-US" sz="1650" dirty="0" spc="-1" kern="0">
+                <a:solidFill>
+                  <a:srgbClr val="9A98A0"/>
+                </a:solidFill>
+                <a:latin typeface="Be Vietnam Pro" pitchFamily="34" charset="0"/>
+                <a:ea typeface="Be Vietnam Pro" pitchFamily="34" charset="-122"/>
+                <a:cs typeface="Be Vietnam Pro" pitchFamily="34" charset="-120"/>
+              </a:rPr>
+              <a:t> khóa</a:t>
+            </a:r>
+            <a:endParaRPr lang="en-US" sz="1650" dirty="0"/>
+          </a:p>
+        </p:txBody>
+      </p:sp>
+      <p:sp>
+        <p:nvSpPr>
+          <p:cNvPr id="27" name="Shape 25"/>
           <p:cNvSpPr/>
           <p:nvPr/>
         </p:nvSpPr>
@@ -16125,7 +16280,7 @@
       </p:sp>
       <p:sp>
         <p:nvSpPr>
-          <p:cNvPr id="26" name="Text 24"/>
+          <p:cNvPr id="28" name="Text 26"/>
           <p:cNvSpPr/>
           <p:nvPr/>
         </p:nvSpPr>
@@ -16186,7 +16341,7 @@
       </p:sp>
       <p:sp>
         <p:nvSpPr>
-          <p:cNvPr id="27" name="Shape 25"/>
+          <p:cNvPr id="29" name="Shape 27"/>
           <p:cNvSpPr/>
           <p:nvPr/>
         </p:nvSpPr>
@@ -16208,7 +16363,7 @@
       </p:sp>
       <p:sp>
         <p:nvSpPr>
-          <p:cNvPr id="28" name="Shape 26"/>
+          <p:cNvPr id="30" name="Shape 28"/>
           <p:cNvSpPr/>
           <p:nvPr/>
         </p:nvSpPr>
@@ -16230,7 +16385,7 @@
       </p:sp>
       <p:sp>
         <p:nvSpPr>
-          <p:cNvPr id="29" name="Text 27"/>
+          <p:cNvPr id="31" name="Text 29"/>
           <p:cNvSpPr/>
           <p:nvPr/>
         </p:nvSpPr>
@@ -16291,7 +16446,7 @@
       </p:sp>
       <p:sp>
         <p:nvSpPr>
-          <p:cNvPr id="30" name="Shape 28"/>
+          <p:cNvPr id="32" name="Shape 30"/>
           <p:cNvSpPr/>
           <p:nvPr/>
         </p:nvSpPr>
@@ -16313,7 +16468,7 @@
       </p:sp>
       <p:sp>
         <p:nvSpPr>
-          <p:cNvPr id="31" name="Shape 29"/>
+          <p:cNvPr id="33" name="Shape 31"/>
           <p:cNvSpPr/>
           <p:nvPr/>
         </p:nvSpPr>
@@ -16335,7 +16490,7 @@
       </p:sp>
       <p:sp>
         <p:nvSpPr>
-          <p:cNvPr id="32" name="Text 30"/>
+          <p:cNvPr id="34" name="Text 32"/>
           <p:cNvSpPr/>
           <p:nvPr/>
         </p:nvSpPr>
@@ -16407,7 +16562,7 @@
       </p:sp>
       <p:sp>
         <p:nvSpPr>
-          <p:cNvPr id="33" name="Shape 31"/>
+          <p:cNvPr id="35" name="Shape 33"/>
           <p:cNvSpPr/>
           <p:nvPr/>
         </p:nvSpPr>
@@ -16429,7 +16584,7 @@
       </p:sp>
       <p:sp>
         <p:nvSpPr>
-          <p:cNvPr id="34" name="Shape 32"/>
+          <p:cNvPr id="36" name="Shape 34"/>
           <p:cNvSpPr/>
           <p:nvPr/>
         </p:nvSpPr>
@@ -16451,7 +16606,7 @@
       </p:sp>
       <p:sp>
         <p:nvSpPr>
-          <p:cNvPr id="35" name="Text 33"/>
+          <p:cNvPr id="37" name="Text 35"/>
           <p:cNvSpPr/>
           <p:nvPr/>
         </p:nvSpPr>
@@ -16523,7 +16678,7 @@
       </p:sp>
       <p:sp>
         <p:nvSpPr>
-          <p:cNvPr id="36" name="Connector line-1792382602776-646325143"/>
+          <p:cNvPr id="38" name="Connector line-1792384783434-978397602"/>
           <p:cNvSpPr/>
           <p:nvPr/>
         </p:nvSpPr>
@@ -16550,7 +16705,7 @@
       </p:sp>
       <p:sp>
         <p:nvSpPr>
-          <p:cNvPr id="37" name="Shape 35"/>
+          <p:cNvPr id="39" name="Shape 37"/>
           <p:cNvSpPr/>
           <p:nvPr/>
         </p:nvSpPr>
@@ -16570,7 +16725,7 @@
       </p:sp>
       <p:sp>
         <p:nvSpPr>
-          <p:cNvPr id="38" name="Shape 36"/>
+          <p:cNvPr id="40" name="Shape 38"/>
           <p:cNvSpPr/>
           <p:nvPr/>
         </p:nvSpPr>
@@ -16590,7 +16745,7 @@
       </p:sp>
       <p:sp>
         <p:nvSpPr>
-          <p:cNvPr id="39" name="Shape 37"/>
+          <p:cNvPr id="41" name="Shape 39"/>
           <p:cNvSpPr/>
           <p:nvPr/>
         </p:nvSpPr>
@@ -16610,7 +16765,7 @@
       </p:sp>
       <p:sp>
         <p:nvSpPr>
-          <p:cNvPr id="40" name="Shape 38"/>
+          <p:cNvPr id="42" name="Shape 40"/>
           <p:cNvSpPr/>
           <p:nvPr/>
         </p:nvSpPr>
@@ -16630,7 +16785,7 @@
       </p:sp>
       <p:sp>
         <p:nvSpPr>
-          <p:cNvPr id="41" name="Shape 39"/>
+          <p:cNvPr id="43" name="Shape 41"/>
           <p:cNvSpPr/>
           <p:nvPr/>
         </p:nvSpPr>
@@ -16650,7 +16805,7 @@
       </p:sp>
       <p:sp>
         <p:nvSpPr>
-          <p:cNvPr id="42" name="Shape 40"/>
+          <p:cNvPr id="44" name="Shape 42"/>
           <p:cNvSpPr/>
           <p:nvPr/>
         </p:nvSpPr>
@@ -16675,7 +16830,7 @@
       </p:sp>
       <p:sp>
         <p:nvSpPr>
-          <p:cNvPr id="43" name="Shape 41"/>
+          <p:cNvPr id="45" name="Shape 43"/>
           <p:cNvSpPr/>
           <p:nvPr/>
         </p:nvSpPr>
@@ -16700,7 +16855,7 @@
       </p:sp>
       <p:sp>
         <p:nvSpPr>
-          <p:cNvPr id="44" name="Shape 42"/>
+          <p:cNvPr id="46" name="Shape 44"/>
           <p:cNvSpPr/>
           <p:nvPr/>
         </p:nvSpPr>
@@ -16725,7 +16880,7 @@
       </p:sp>
       <p:sp>
         <p:nvSpPr>
-          <p:cNvPr id="45" name="Shape 43"/>
+          <p:cNvPr id="47" name="Shape 45"/>
           <p:cNvSpPr/>
           <p:nvPr/>
         </p:nvSpPr>
@@ -16750,7 +16905,7 @@
       </p:sp>
       <p:sp>
         <p:nvSpPr>
-          <p:cNvPr id="46" name="Shape 44"/>
+          <p:cNvPr id="48" name="Shape 46"/>
           <p:cNvSpPr/>
           <p:nvPr/>
         </p:nvSpPr>
@@ -16775,7 +16930,7 @@
       </p:sp>
       <p:sp>
         <p:nvSpPr>
-          <p:cNvPr id="47" name="Text 45"/>
+          <p:cNvPr id="49" name="Text 47"/>
           <p:cNvSpPr/>
           <p:nvPr/>
         </p:nvSpPr>
@@ -16880,7 +17035,7 @@
       </p:sp>
       <p:sp>
         <p:nvSpPr>
-          <p:cNvPr id="48" name="Shape 46"/>
+          <p:cNvPr id="50" name="Shape 48"/>
           <p:cNvSpPr/>
           <p:nvPr/>
         </p:nvSpPr>
@@ -16904,7 +17059,7 @@
       </p:sp>
       <p:pic>
         <p:nvPicPr>
-          <p:cNvPr id="49" name="Moda image moda-export-watermark-28215a6d-f7f5-43e8-a6b3-6540be0244d1" descr="">    </p:cNvPr>
+          <p:cNvPr id="51" name="Moda image moda-export-watermark-28215a6d-f7f5-43e8-a6b3-6540be0244d1" descr="">    </p:cNvPr>
           <p:cNvPicPr>
             <a:picLocks noChangeAspect="1"/>
           </p:cNvPicPr>
@@ -25329,7 +25484,7 @@
               <a:t> cậy:</a:t>
             </a:r>
             <a:r>
-              <a:rPr lang="en-US" sz="2100" dirty="0" spc="-1" kern="0">
+              <a:rPr lang="en-US" sz="2100" dirty="0" spc="-2" kern="0">
                 <a:solidFill>
                   <a:srgbClr val="14161C"/>
                 </a:solidFill>
@@ -25337,10 +25492,10 @@
                 <a:ea typeface="Be Vietnam Pro SemiBold" pitchFamily="34" charset="-122"/>
                 <a:cs typeface="Be Vietnam Pro SemiBold" pitchFamily="34" charset="-120"/>
               </a:rPr>
-              <a:t> chỉ</a:t>
-            </a:r>
-            <a:r>
-              <a:rPr lang="en-US" sz="2100" dirty="0" spc="-2" kern="0">
+              <a:t> khác</a:t>
+            </a:r>
+            <a:r>
+              <a:rPr lang="en-US" sz="2100" dirty="0" spc="-3" kern="0">
                 <a:solidFill>
                   <a:srgbClr val="14161C"/>
                 </a:solidFill>
@@ -25348,7 +25503,7 @@
                 <a:ea typeface="Be Vietnam Pro SemiBold" pitchFamily="34" charset="-122"/>
                 <a:cs typeface="Be Vietnam Pro SemiBold" pitchFamily="34" charset="-120"/>
               </a:rPr>
-              <a:t> khác</a:t>
+              <a:t> nhau</a:t>
             </a:r>
             <a:r>
               <a:rPr lang="en-US" sz="2100" dirty="0" spc="-1" kern="0">
@@ -25359,10 +25514,10 @@
                 <a:ea typeface="Be Vietnam Pro SemiBold" pitchFamily="34" charset="-122"/>
                 <a:cs typeface="Be Vietnam Pro SemiBold" pitchFamily="34" charset="-120"/>
               </a:rPr>
-              <a:t> sự</a:t>
-            </a:r>
-            <a:r>
-              <a:rPr lang="en-US" sz="2100" dirty="0" spc="0" kern="0">
+              <a:t> ở</a:t>
+            </a:r>
+            <a:r>
+              <a:rPr lang="en-US" sz="2100" dirty="0" spc="-2" kern="0">
                 <a:solidFill>
                   <a:srgbClr val="14161C"/>
                 </a:solidFill>
@@ -25370,10 +25525,21 @@
                 <a:ea typeface="Be Vietnam Pro SemiBold" pitchFamily="34" charset="-122"/>
                 <a:cs typeface="Be Vietnam Pro SemiBold" pitchFamily="34" charset="-120"/>
               </a:rPr>
+              <a:t> sự</a:t>
+            </a:r>
+            <a:r>
+              <a:rPr lang="en-US" sz="2100" dirty="0" spc="1" kern="0">
+                <a:solidFill>
+                  <a:srgbClr val="14161C"/>
+                </a:solidFill>
+                <a:latin typeface="Be Vietnam Pro SemiBold" pitchFamily="34" charset="0"/>
+                <a:ea typeface="Be Vietnam Pro SemiBold" pitchFamily="34" charset="-122"/>
+                <a:cs typeface="Be Vietnam Pro SemiBold" pitchFamily="34" charset="-120"/>
+              </a:rPr>
               <a:t> đồng</a:t>
             </a:r>
             <a:r>
-              <a:rPr lang="en-US" sz="2100" dirty="0" spc="-1" kern="0">
+              <a:rPr lang="en-US" sz="2100" dirty="0" spc="-2" kern="0">
                 <a:solidFill>
                   <a:srgbClr val="14161C"/>
                 </a:solidFill>

</xml_diff>

<commit_message>
System Design vi: sd-14-021, sd-14-022 and sd-14-025 decks list every glossary term on the last slide
Co-Authored-By: Claude Sonnet 5.5 <noreply@anthropic.com>
Claude-Session: https://claude.ai/code/session_01WnjciXNJBLEd8jy3HrG49S
</commit_message>
<xml_diff>
--- a/system-design-101/vi/lessons/sd-14-021/slides/sd-14-021.pptx
+++ b/system-design-101/vi/lessons/sd-14-021/slides/sd-14-021.pptx
@@ -3732,93 +3732,18 @@
       </p:sp>
       <p:sp>
         <p:nvSpPr>
-          <p:cNvPr id="3" name="Text 1"/>
-          <p:cNvSpPr/>
-          <p:nvPr/>
-        </p:nvSpPr>
-        <p:spPr>
-          <a:xfrm>
-            <a:off x="914400" y="1333500"/>
-            <a:ext cx="11430000" cy="1143000"/>
-          </a:xfrm>
-          <a:prstGeom prst="rect">
-            <a:avLst/>
-          </a:prstGeom>
-          <a:noFill/>
-          <a:ln/>
-        </p:spPr>
-        <p:txBody>
-          <a:bodyPr wrap="square" lIns="0" tIns="61341" rIns="0" bIns="-61341" rtlCol="0" anchor="t"/>
-          <a:lstStyle/>
-          <a:p>
-            <a:pPr algn="l" indent="0" marL="0">
-              <a:lnSpc>
-                <a:spcPts val="7176"/>
-              </a:lnSpc>
-              <a:buNone/>
-            </a:pPr>
-            <a:r>
-              <a:rPr lang="en-US" sz="6900" dirty="0" spc="-59" kern="0">
-                <a:solidFill>
-                  <a:srgbClr val="F3EEE3"/>
-                </a:solidFill>
-                <a:latin typeface="Bricolage Grotesque ExtraBold" pitchFamily="34" charset="0"/>
-                <a:ea typeface="Bricolage Grotesque ExtraBold" pitchFamily="34" charset="-122"/>
-                <a:cs typeface="Bricolage Grotesque ExtraBold" pitchFamily="34" charset="-120"/>
-              </a:rPr>
-              <a:t>Từ</a:t>
-            </a:r>
-            <a:r>
-              <a:rPr lang="en-US" sz="6900" dirty="0" spc="-8" kern="0">
-                <a:solidFill>
-                  <a:srgbClr val="F3EEE3"/>
-                </a:solidFill>
-                <a:latin typeface="Bricolage Grotesque ExtraBold" pitchFamily="34" charset="0"/>
-                <a:ea typeface="Bricolage Grotesque ExtraBold" pitchFamily="34" charset="-122"/>
-                <a:cs typeface="Bricolage Grotesque ExtraBold" pitchFamily="34" charset="-120"/>
-              </a:rPr>
-              <a:t> khóa</a:t>
-            </a:r>
-            <a:r>
-              <a:rPr lang="en-US" sz="6900" dirty="0" spc="-76" kern="0">
-                <a:solidFill>
-                  <a:srgbClr val="F3EEE3"/>
-                </a:solidFill>
-                <a:latin typeface="Bricolage Grotesque ExtraBold" pitchFamily="34" charset="0"/>
-                <a:ea typeface="Bricolage Grotesque ExtraBold" pitchFamily="34" charset="-122"/>
-                <a:cs typeface="Bricolage Grotesque ExtraBold" pitchFamily="34" charset="-120"/>
-              </a:rPr>
-              <a:t> và</a:t>
-            </a:r>
-            <a:r>
-              <a:rPr lang="en-US" sz="6900" dirty="0" spc="2" kern="0">
-                <a:solidFill>
-                  <a:srgbClr val="F3EEE3"/>
-                </a:solidFill>
-                <a:latin typeface="Bricolage Grotesque ExtraBold" pitchFamily="34" charset="0"/>
-                <a:ea typeface="Bricolage Grotesque ExtraBold" pitchFamily="34" charset="-122"/>
-                <a:cs typeface="Bricolage Grotesque ExtraBold" pitchFamily="34" charset="-120"/>
-              </a:rPr>
-              <a:t> nguồn</a:t>
-            </a:r>
-            <a:endParaRPr lang="en-US" sz="6900" dirty="0"/>
-          </a:p>
-        </p:txBody>
-      </p:sp>
-      <p:sp>
-        <p:nvSpPr>
-          <p:cNvPr id="4" name="Shape 2"/>
-          <p:cNvSpPr/>
-          <p:nvPr/>
-        </p:nvSpPr>
-        <p:spPr>
-          <a:xfrm>
-            <a:off x="914400" y="2628900"/>
-            <a:ext cx="3886200" cy="2247900"/>
+          <p:cNvPr id="3" name="Shape 1"/>
+          <p:cNvSpPr/>
+          <p:nvPr/>
+        </p:nvSpPr>
+        <p:spPr>
+          <a:xfrm>
+            <a:off x="914400" y="1447800"/>
+            <a:ext cx="5384768" cy="1924050"/>
           </a:xfrm>
           <a:prstGeom prst="roundRect">
             <a:avLst>
-              <a:gd name="adj" fmla="val 9322"/>
+              <a:gd name="adj" fmla="val 10891"/>
             </a:avLst>
           </a:prstGeom>
           <a:solidFill>
@@ -3834,14 +3759,14 @@
       </p:sp>
       <p:sp>
         <p:nvSpPr>
-          <p:cNvPr id="5" name="Text 3"/>
-          <p:cNvSpPr/>
-          <p:nvPr/>
-        </p:nvSpPr>
-        <p:spPr>
-          <a:xfrm>
-            <a:off x="1181100" y="2819400"/>
-            <a:ext cx="3352800" cy="571500"/>
+          <p:cNvPr id="4" name="Text 2"/>
+          <p:cNvSpPr/>
+          <p:nvPr/>
+        </p:nvSpPr>
+        <p:spPr>
+          <a:xfrm>
+            <a:off x="1181100" y="1581150"/>
+            <a:ext cx="4851368" cy="419100"/>
           </a:xfrm>
           <a:prstGeom prst="rect">
             <a:avLst/>
@@ -3857,7 +3782,7 @@
               <a:buNone/>
             </a:pPr>
             <a:r>
-              <a:rPr lang="en-US" sz="3450" dirty="0" spc="15" kern="0">
+              <a:rPr lang="en-US" sz="2550" dirty="0" spc="10" kern="0">
                 <a:solidFill>
                   <a:srgbClr val="F3EEE3"/>
                 </a:solidFill>
@@ -3867,20 +3792,20 @@
               </a:rPr>
               <a:t>HTTPS</a:t>
             </a:r>
-            <a:endParaRPr lang="en-US" sz="3450" dirty="0"/>
+            <a:endParaRPr lang="en-US" sz="2550" dirty="0"/>
           </a:p>
         </p:txBody>
       </p:sp>
       <p:sp>
         <p:nvSpPr>
-          <p:cNvPr id="6" name="Text 4"/>
-          <p:cNvSpPr/>
-          <p:nvPr/>
-        </p:nvSpPr>
-        <p:spPr>
-          <a:xfrm>
-            <a:off x="1181100" y="3429000"/>
-            <a:ext cx="3352800" cy="590550"/>
+          <p:cNvPr id="5" name="Text 3"/>
+          <p:cNvSpPr/>
+          <p:nvPr/>
+        </p:nvSpPr>
+        <p:spPr>
+          <a:xfrm>
+            <a:off x="1181100" y="2019300"/>
+            <a:ext cx="4851368" cy="552450"/>
           </a:xfrm>
           <a:prstGeom prst="rect">
             <a:avLst/>
@@ -3948,14 +3873,14 @@
       </p:sp>
       <p:sp>
         <p:nvSpPr>
-          <p:cNvPr id="7" name="Text 5"/>
-          <p:cNvSpPr/>
-          <p:nvPr/>
-        </p:nvSpPr>
-        <p:spPr>
-          <a:xfrm>
-            <a:off x="1181100" y="4095750"/>
-            <a:ext cx="3352800" cy="628650"/>
+          <p:cNvPr id="6" name="Text 4"/>
+          <p:cNvSpPr/>
+          <p:nvPr/>
+        </p:nvSpPr>
+        <p:spPr>
+          <a:xfrm>
+            <a:off x="1181100" y="2628900"/>
+            <a:ext cx="4851368" cy="571500"/>
           </a:xfrm>
           <a:prstGeom prst="rect">
             <a:avLst/>
@@ -3964,17 +3889,17 @@
           <a:ln/>
         </p:spPr>
         <p:txBody>
-          <a:bodyPr wrap="square" lIns="0" tIns="9716" rIns="0" bIns="-9716" rtlCol="0" anchor="t"/>
+          <a:bodyPr wrap="square" lIns="0" tIns="8906" rIns="0" bIns="-8906" rtlCol="0" anchor="t"/>
           <a:lstStyle/>
           <a:p>
             <a:pPr algn="l" indent="0" marL="0">
               <a:lnSpc>
-                <a:spcPts val="2340"/>
+                <a:spcPts val="2145"/>
               </a:lnSpc>
               <a:buNone/>
             </a:pPr>
             <a:r>
-              <a:rPr lang="en-US" sz="1800" dirty="0" spc="-3" kern="0">
+              <a:rPr lang="en-US" sz="1650" dirty="0" spc="-3" kern="0">
                 <a:solidFill>
                   <a:srgbClr val="D8D3C4"/>
                 </a:solidFill>
@@ -3985,7 +3910,7 @@
               <a:t>HTTP</a:t>
             </a:r>
             <a:r>
-              <a:rPr lang="en-US" sz="1800" dirty="0" spc="-5" kern="0">
+              <a:rPr lang="en-US" sz="1650" dirty="0" spc="-4" kern="0">
                 <a:solidFill>
                   <a:srgbClr val="D8D3C4"/>
                 </a:solidFill>
@@ -3996,7 +3921,7 @@
               <a:t> chạy</a:t>
             </a:r>
             <a:r>
-              <a:rPr lang="en-US" sz="1800" dirty="0" spc="-15" kern="0">
+              <a:rPr lang="en-US" sz="1650" dirty="0" spc="-11" kern="0">
                 <a:solidFill>
                   <a:srgbClr val="D8D3C4"/>
                 </a:solidFill>
@@ -4007,7 +3932,7 @@
               <a:t> trên</a:t>
             </a:r>
             <a:r>
-              <a:rPr lang="en-US" sz="1800" dirty="0" spc="-1" kern="0">
+              <a:rPr lang="en-US" sz="1650" dirty="0" spc="1" kern="0">
                 <a:solidFill>
                   <a:srgbClr val="D8D3C4"/>
                 </a:solidFill>
@@ -4018,7 +3943,7 @@
               <a:t> TLS,</a:t>
             </a:r>
             <a:r>
-              <a:rPr lang="en-US" sz="1800" dirty="0" spc="-2" kern="0">
+              <a:rPr lang="en-US" sz="1650" dirty="0" spc="-1" kern="0">
                 <a:solidFill>
                   <a:srgbClr val="D8D3C4"/>
                 </a:solidFill>
@@ -4026,10 +3951,10 @@
                 <a:ea typeface="Be Vietnam Pro" pitchFamily="34" charset="-122"/>
                 <a:cs typeface="Be Vietnam Pro" pitchFamily="34" charset="-120"/>
               </a:rPr>
-              <a:t> nội</a:t>
-            </a:r>
-            <a:r>
-              <a:rPr lang="en-US" sz="1800" dirty="0" spc="-3" kern="0">
+              <a:t> nội dung</a:t>
+            </a:r>
+            <a:r>
+              <a:rPr lang="en-US" sz="1650" dirty="0" spc="2" kern="0">
                 <a:solidFill>
                   <a:srgbClr val="D8D3C4"/>
                 </a:solidFill>
@@ -4037,10 +3962,10 @@
                 <a:ea typeface="Be Vietnam Pro" pitchFamily="34" charset="-122"/>
                 <a:cs typeface="Be Vietnam Pro" pitchFamily="34" charset="-120"/>
               </a:rPr>
-              <a:t> dung</a:t>
-            </a:r>
-            <a:r>
-              <a:rPr lang="en-US" sz="1800" dirty="0" spc="6" kern="0">
+              <a:t> mã</a:t>
+            </a:r>
+            <a:r>
+              <a:rPr lang="en-US" sz="1650" dirty="0" spc="-1" kern="0">
                 <a:solidFill>
                   <a:srgbClr val="D8D3C4"/>
                 </a:solidFill>
@@ -4048,48 +3973,26 @@
                 <a:ea typeface="Be Vietnam Pro" pitchFamily="34" charset="-122"/>
                 <a:cs typeface="Be Vietnam Pro" pitchFamily="34" charset="-120"/>
               </a:rPr>
-              <a:t> được</a:t>
-            </a:r>
-            <a:r>
-              <a:rPr lang="en-US" sz="1800" dirty="0" spc="0" kern="0">
-                <a:solidFill>
-                  <a:srgbClr val="D8D3C4"/>
-                </a:solidFill>
-                <a:latin typeface="Be Vietnam Pro" pitchFamily="34" charset="0"/>
-                <a:ea typeface="Be Vietnam Pro" pitchFamily="34" charset="-122"/>
-                <a:cs typeface="Be Vietnam Pro" pitchFamily="34" charset="-120"/>
-              </a:rPr>
-              <a:t> mã</a:t>
-            </a:r>
-            <a:r>
-              <a:rPr lang="en-US" sz="1800" dirty="0" spc="-1" kern="0">
-                <a:solidFill>
-                  <a:srgbClr val="D8D3C4"/>
-                </a:solidFill>
-                <a:latin typeface="Be Vietnam Pro" pitchFamily="34" charset="0"/>
-                <a:ea typeface="Be Vietnam Pro" pitchFamily="34" charset="-122"/>
-                <a:cs typeface="Be Vietnam Pro" pitchFamily="34" charset="-120"/>
-              </a:rPr>
               <a:t> hóa</a:t>
             </a:r>
-            <a:endParaRPr lang="en-US" sz="1800" dirty="0"/>
+            <a:endParaRPr lang="en-US" sz="1650" dirty="0"/>
           </a:p>
         </p:txBody>
       </p:sp>
       <p:sp>
         <p:nvSpPr>
-          <p:cNvPr id="8" name="Shape 6"/>
-          <p:cNvSpPr/>
-          <p:nvPr/>
-        </p:nvSpPr>
-        <p:spPr>
-          <a:xfrm>
-            <a:off x="5105400" y="2628900"/>
-            <a:ext cx="3886200" cy="2247900"/>
+          <p:cNvPr id="7" name="Shape 5"/>
+          <p:cNvSpPr/>
+          <p:nvPr/>
+        </p:nvSpPr>
+        <p:spPr>
+          <a:xfrm>
+            <a:off x="6451568" y="1447800"/>
+            <a:ext cx="5384768" cy="1924050"/>
           </a:xfrm>
           <a:prstGeom prst="roundRect">
             <a:avLst>
-              <a:gd name="adj" fmla="val 9322"/>
+              <a:gd name="adj" fmla="val 10891"/>
             </a:avLst>
           </a:prstGeom>
           <a:solidFill>
@@ -4105,14 +4008,14 @@
       </p:sp>
       <p:sp>
         <p:nvSpPr>
-          <p:cNvPr id="9" name="Text 7"/>
-          <p:cNvSpPr/>
-          <p:nvPr/>
-        </p:nvSpPr>
-        <p:spPr>
-          <a:xfrm>
-            <a:off x="5372100" y="2819400"/>
-            <a:ext cx="3352800" cy="571500"/>
+          <p:cNvPr id="8" name="Text 6"/>
+          <p:cNvSpPr/>
+          <p:nvPr/>
+        </p:nvSpPr>
+        <p:spPr>
+          <a:xfrm>
+            <a:off x="6718268" y="1581150"/>
+            <a:ext cx="4851368" cy="419100"/>
           </a:xfrm>
           <a:prstGeom prst="rect">
             <a:avLst/>
@@ -4128,7 +4031,7 @@
               <a:buNone/>
             </a:pPr>
             <a:r>
-              <a:rPr lang="en-US" sz="3450" dirty="0" spc="3" kern="0">
+              <a:rPr lang="en-US" sz="2550" dirty="0" spc="12" kern="0">
                 <a:solidFill>
                   <a:srgbClr val="F3EEE3"/>
                 </a:solidFill>
@@ -4136,22 +4039,22 @@
                 <a:ea typeface="Bricolage Grotesque ExtraBold" pitchFamily="34" charset="-122"/>
                 <a:cs typeface="Bricolage Grotesque ExtraBold" pitchFamily="34" charset="-120"/>
               </a:rPr>
-              <a:t>TLS</a:t>
-            </a:r>
-            <a:endParaRPr lang="en-US" sz="3450" dirty="0"/>
+              <a:t>HTTP</a:t>
+            </a:r>
+            <a:endParaRPr lang="en-US" sz="2550" dirty="0"/>
           </a:p>
         </p:txBody>
       </p:sp>
       <p:sp>
         <p:nvSpPr>
-          <p:cNvPr id="10" name="Text 8"/>
-          <p:cNvSpPr/>
-          <p:nvPr/>
-        </p:nvSpPr>
-        <p:spPr>
-          <a:xfrm>
-            <a:off x="5372100" y="3429000"/>
-            <a:ext cx="3352800" cy="590550"/>
+          <p:cNvPr id="9" name="Text 7"/>
+          <p:cNvSpPr/>
+          <p:nvPr/>
+        </p:nvSpPr>
+        <p:spPr>
+          <a:xfrm>
+            <a:off x="6718268" y="2019300"/>
+            <a:ext cx="4851368" cy="552450"/>
           </a:xfrm>
           <a:prstGeom prst="rect">
             <a:avLst/>
@@ -4170,7 +4073,7 @@
               <a:buNone/>
             </a:pPr>
             <a:r>
-              <a:rPr lang="en-US" sz="1650" dirty="0" spc="-22" kern="0">
+              <a:rPr lang="en-US" sz="1650" dirty="0" spc="-31" kern="0">
                 <a:solidFill>
                   <a:srgbClr val="9A98A0"/>
                 </a:solidFill>
@@ -4178,10 +4081,10 @@
                 <a:ea typeface="Be Vietnam Pro" pitchFamily="34" charset="-122"/>
                 <a:cs typeface="Be Vietnam Pro" pitchFamily="34" charset="-120"/>
               </a:rPr>
-              <a:t>Transport</a:t>
-            </a:r>
-            <a:r>
-              <a:rPr lang="en-US" sz="1650" dirty="0" spc="-25" kern="0">
+              <a:t>HyperText</a:t>
+            </a:r>
+            <a:r>
+              <a:rPr lang="en-US" sz="1650" dirty="0" spc="-27" kern="0">
                 <a:solidFill>
                   <a:srgbClr val="9A98A0"/>
                 </a:solidFill>
@@ -4189,10 +4092,10 @@
                 <a:ea typeface="Be Vietnam Pro" pitchFamily="34" charset="-122"/>
                 <a:cs typeface="Be Vietnam Pro" pitchFamily="34" charset="-120"/>
               </a:rPr>
-              <a:t> Layer</a:t>
-            </a:r>
-            <a:r>
-              <a:rPr lang="en-US" sz="1650" dirty="0" spc="1" kern="0">
+              <a:t> Transfer</a:t>
+            </a:r>
+            <a:r>
+              <a:rPr lang="en-US" sz="1650" dirty="0" spc="-14" kern="0">
                 <a:solidFill>
                   <a:srgbClr val="9A98A0"/>
                 </a:solidFill>
@@ -4200,7 +4103,7 @@
                 <a:ea typeface="Be Vietnam Pro" pitchFamily="34" charset="-122"/>
                 <a:cs typeface="Be Vietnam Pro" pitchFamily="34" charset="-120"/>
               </a:rPr>
-              <a:t> Security</a:t>
+              <a:t> Protocol</a:t>
             </a:r>
             <a:endParaRPr lang="en-US" sz="1650" dirty="0"/>
           </a:p>
@@ -4208,14 +4111,14 @@
       </p:sp>
       <p:sp>
         <p:nvSpPr>
-          <p:cNvPr id="11" name="Text 9"/>
-          <p:cNvSpPr/>
-          <p:nvPr/>
-        </p:nvSpPr>
-        <p:spPr>
-          <a:xfrm>
-            <a:off x="5372100" y="4095750"/>
-            <a:ext cx="3352800" cy="628650"/>
+          <p:cNvPr id="10" name="Text 8"/>
+          <p:cNvSpPr/>
+          <p:nvPr/>
+        </p:nvSpPr>
+        <p:spPr>
+          <a:xfrm>
+            <a:off x="6718268" y="2628900"/>
+            <a:ext cx="4851368" cy="571500"/>
           </a:xfrm>
           <a:prstGeom prst="rect">
             <a:avLst/>
@@ -4224,17 +4127,17 @@
           <a:ln/>
         </p:spPr>
         <p:txBody>
-          <a:bodyPr wrap="square" lIns="0" tIns="9716" rIns="0" bIns="-9716" rtlCol="0" anchor="t"/>
+          <a:bodyPr wrap="square" lIns="0" tIns="8906" rIns="0" bIns="-8906" rtlCol="0" anchor="t"/>
           <a:lstStyle/>
           <a:p>
             <a:pPr algn="l" indent="0" marL="0">
               <a:lnSpc>
-                <a:spcPts val="2340"/>
+                <a:spcPts val="2145"/>
               </a:lnSpc>
               <a:buNone/>
             </a:pPr>
             <a:r>
-              <a:rPr lang="en-US" sz="1800" dirty="0" spc="-2" kern="0">
+              <a:rPr lang="en-US" sz="1650" dirty="0" spc="-1" kern="0">
                 <a:solidFill>
                   <a:srgbClr val="D8D3C4"/>
                 </a:solidFill>
@@ -4242,10 +4145,10 @@
                 <a:ea typeface="Be Vietnam Pro" pitchFamily="34" charset="-122"/>
                 <a:cs typeface="Be Vietnam Pro" pitchFamily="34" charset="-120"/>
               </a:rPr>
-              <a:t>lớp</a:t>
-            </a:r>
-            <a:r>
-              <a:rPr lang="en-US" sz="1800" dirty="0" spc="-1" kern="0">
+              <a:t>quy</a:t>
+            </a:r>
+            <a:r>
+              <a:rPr lang="en-US" sz="1650" dirty="0" spc="7" kern="0">
                 <a:solidFill>
                   <a:srgbClr val="D8D3C4"/>
                 </a:solidFill>
@@ -4253,10 +4156,10 @@
                 <a:ea typeface="Be Vietnam Pro" pitchFamily="34" charset="-122"/>
                 <a:cs typeface="Be Vietnam Pro" pitchFamily="34" charset="-120"/>
               </a:rPr>
-              <a:t> mã hóa giữ</a:t>
-            </a:r>
-            <a:r>
-              <a:rPr lang="en-US" sz="1800" dirty="0" spc="-2" kern="0">
+              <a:t> ước</a:t>
+            </a:r>
+            <a:r>
+              <a:rPr lang="en-US" sz="1650" dirty="0" spc="27" kern="0">
                 <a:solidFill>
                   <a:srgbClr val="D8D3C4"/>
                 </a:solidFill>
@@ -4264,10 +4167,10 @@
                 <a:ea typeface="Be Vietnam Pro" pitchFamily="34" charset="-122"/>
                 <a:cs typeface="Be Vietnam Pro" pitchFamily="34" charset="-120"/>
               </a:rPr>
-              <a:t> kín</a:t>
-            </a:r>
-            <a:r>
-              <a:rPr lang="en-US" sz="1800" dirty="0" spc="1" kern="0">
+              <a:t> gửi</a:t>
+            </a:r>
+            <a:r>
+              <a:rPr lang="en-US" sz="1650" dirty="0" spc="-13" kern="0">
                 <a:solidFill>
                   <a:srgbClr val="D8D3C4"/>
                 </a:solidFill>
@@ -4275,10 +4178,10 @@
                 <a:ea typeface="Be Vietnam Pro" pitchFamily="34" charset="-122"/>
                 <a:cs typeface="Be Vietnam Pro" pitchFamily="34" charset="-120"/>
               </a:rPr>
-              <a:t> dữ</a:t>
-            </a:r>
-            <a:r>
-              <a:rPr lang="en-US" sz="1800" dirty="0" spc="-3" kern="0">
+              <a:t> yêu</a:t>
+            </a:r>
+            <a:r>
+              <a:rPr lang="en-US" sz="1650" dirty="0" spc="1" kern="0">
                 <a:solidFill>
                   <a:srgbClr val="D8D3C4"/>
                 </a:solidFill>
@@ -4286,10 +4189,10 @@
                 <a:ea typeface="Be Vietnam Pro" pitchFamily="34" charset="-122"/>
                 <a:cs typeface="Be Vietnam Pro" pitchFamily="34" charset="-120"/>
               </a:rPr>
-              <a:t> liệu</a:t>
-            </a:r>
-            <a:r>
-              <a:rPr lang="en-US" sz="1800" dirty="0" spc="7" kern="0">
+              <a:t> cầu</a:t>
+            </a:r>
+            <a:r>
+              <a:rPr lang="en-US" sz="1650" dirty="0" spc="-9" kern="0">
                 <a:solidFill>
                   <a:srgbClr val="D8D3C4"/>
                 </a:solidFill>
@@ -4297,10 +4200,10 @@
                 <a:ea typeface="Be Vietnam Pro" pitchFamily="34" charset="-122"/>
                 <a:cs typeface="Be Vietnam Pro" pitchFamily="34" charset="-120"/>
               </a:rPr>
-              <a:t> giữa</a:t>
-            </a:r>
-            <a:r>
-              <a:rPr lang="en-US" sz="1800" dirty="0" spc="1" kern="0">
+              <a:t> và</a:t>
+            </a:r>
+            <a:r>
+              <a:rPr lang="en-US" sz="1650" dirty="0" spc="-14" kern="0">
                 <a:solidFill>
                   <a:srgbClr val="D8D3C4"/>
                 </a:solidFill>
@@ -4308,10 +4211,10 @@
                 <a:ea typeface="Be Vietnam Pro" pitchFamily="34" charset="-122"/>
                 <a:cs typeface="Be Vietnam Pro" pitchFamily="34" charset="-120"/>
               </a:rPr>
-              <a:t> hai</a:t>
-            </a:r>
-            <a:r>
-              <a:rPr lang="en-US" sz="1800" dirty="0" spc="9" kern="0">
+              <a:t> trả</a:t>
+            </a:r>
+            <a:r>
+              <a:rPr lang="en-US" sz="1650" dirty="0" spc="0" kern="0">
                 <a:solidFill>
                   <a:srgbClr val="D8D3C4"/>
                 </a:solidFill>
@@ -4319,26 +4222,26 @@
                 <a:ea typeface="Be Vietnam Pro" pitchFamily="34" charset="-122"/>
                 <a:cs typeface="Be Vietnam Pro" pitchFamily="34" charset="-120"/>
               </a:rPr>
-              <a:t> đầu</a:t>
-            </a:r>
-            <a:endParaRPr lang="en-US" sz="1800" dirty="0"/>
+              <a:t> lời</a:t>
+            </a:r>
+            <a:endParaRPr lang="en-US" sz="1650" dirty="0"/>
           </a:p>
         </p:txBody>
       </p:sp>
       <p:sp>
         <p:nvSpPr>
-          <p:cNvPr id="12" name="Shape 10"/>
-          <p:cNvSpPr/>
-          <p:nvPr/>
-        </p:nvSpPr>
-        <p:spPr>
-          <a:xfrm>
-            <a:off x="9296400" y="2628900"/>
-            <a:ext cx="3886200" cy="2247900"/>
+          <p:cNvPr id="11" name="Shape 9"/>
+          <p:cNvSpPr/>
+          <p:nvPr/>
+        </p:nvSpPr>
+        <p:spPr>
+          <a:xfrm>
+            <a:off x="11988737" y="1447800"/>
+            <a:ext cx="5384768" cy="1924050"/>
           </a:xfrm>
           <a:prstGeom prst="roundRect">
             <a:avLst>
-              <a:gd name="adj" fmla="val 9322"/>
+              <a:gd name="adj" fmla="val 10891"/>
             </a:avLst>
           </a:prstGeom>
           <a:solidFill>
@@ -4354,14 +4257,14 @@
       </p:sp>
       <p:sp>
         <p:nvSpPr>
-          <p:cNvPr id="13" name="Text 11"/>
-          <p:cNvSpPr/>
-          <p:nvPr/>
-        </p:nvSpPr>
-        <p:spPr>
-          <a:xfrm>
-            <a:off x="9563100" y="2819400"/>
-            <a:ext cx="3352800" cy="571500"/>
+          <p:cNvPr id="12" name="Text 10"/>
+          <p:cNvSpPr/>
+          <p:nvPr/>
+        </p:nvSpPr>
+        <p:spPr>
+          <a:xfrm>
+            <a:off x="12255437" y="1581150"/>
+            <a:ext cx="4851368" cy="419100"/>
           </a:xfrm>
           <a:prstGeom prst="rect">
             <a:avLst/>
@@ -4377,7 +4280,7 @@
               <a:buNone/>
             </a:pPr>
             <a:r>
-              <a:rPr lang="en-US" sz="3450" dirty="0" spc="8" kern="0">
+              <a:rPr lang="en-US" sz="2550" dirty="0" spc="2" kern="0">
                 <a:solidFill>
                   <a:srgbClr val="F3EEE3"/>
                 </a:solidFill>
@@ -4385,22 +4288,22 @@
                 <a:ea typeface="Bricolage Grotesque ExtraBold" pitchFamily="34" charset="-122"/>
                 <a:cs typeface="Bricolage Grotesque ExtraBold" pitchFamily="34" charset="-120"/>
               </a:rPr>
-              <a:t>SSL</a:t>
-            </a:r>
-            <a:endParaRPr lang="en-US" sz="3450" dirty="0"/>
+              <a:t>TLS</a:t>
+            </a:r>
+            <a:endParaRPr lang="en-US" sz="2550" dirty="0"/>
           </a:p>
         </p:txBody>
       </p:sp>
       <p:sp>
         <p:nvSpPr>
-          <p:cNvPr id="14" name="Text 12"/>
-          <p:cNvSpPr/>
-          <p:nvPr/>
-        </p:nvSpPr>
-        <p:spPr>
-          <a:xfrm>
-            <a:off x="9563100" y="3429000"/>
-            <a:ext cx="3352800" cy="590550"/>
+          <p:cNvPr id="13" name="Text 11"/>
+          <p:cNvSpPr/>
+          <p:nvPr/>
+        </p:nvSpPr>
+        <p:spPr>
+          <a:xfrm>
+            <a:off x="12255437" y="2019300"/>
+            <a:ext cx="4851368" cy="552450"/>
           </a:xfrm>
           <a:prstGeom prst="rect">
             <a:avLst/>
@@ -4419,7 +4322,7 @@
               <a:buNone/>
             </a:pPr>
             <a:r>
-              <a:rPr lang="en-US" sz="1650" dirty="0" spc="-14" kern="0">
+              <a:rPr lang="en-US" sz="1650" dirty="0" spc="-22" kern="0">
                 <a:solidFill>
                   <a:srgbClr val="9A98A0"/>
                 </a:solidFill>
@@ -4427,10 +4330,10 @@
                 <a:ea typeface="Be Vietnam Pro" pitchFamily="34" charset="-122"/>
                 <a:cs typeface="Be Vietnam Pro" pitchFamily="34" charset="-120"/>
               </a:rPr>
-              <a:t>Secure</a:t>
-            </a:r>
-            <a:r>
-              <a:rPr lang="en-US" sz="1650" dirty="0" spc="-11" kern="0">
+              <a:t>Transport</a:t>
+            </a:r>
+            <a:r>
+              <a:rPr lang="en-US" sz="1650" dirty="0" spc="-25" kern="0">
                 <a:solidFill>
                   <a:srgbClr val="9A98A0"/>
                 </a:solidFill>
@@ -4438,10 +4341,10 @@
                 <a:ea typeface="Be Vietnam Pro" pitchFamily="34" charset="-122"/>
                 <a:cs typeface="Be Vietnam Pro" pitchFamily="34" charset="-120"/>
               </a:rPr>
-              <a:t> Sockets</a:t>
-            </a:r>
-            <a:r>
-              <a:rPr lang="en-US" sz="1650" dirty="0" spc="-24" kern="0">
+              <a:t> Layer</a:t>
+            </a:r>
+            <a:r>
+              <a:rPr lang="en-US" sz="1650" dirty="0" spc="1" kern="0">
                 <a:solidFill>
                   <a:srgbClr val="9A98A0"/>
                 </a:solidFill>
@@ -4449,7 +4352,7 @@
                 <a:ea typeface="Be Vietnam Pro" pitchFamily="34" charset="-122"/>
                 <a:cs typeface="Be Vietnam Pro" pitchFamily="34" charset="-120"/>
               </a:rPr>
-              <a:t> Layer</a:t>
+              <a:t> Security</a:t>
             </a:r>
             <a:endParaRPr lang="en-US" sz="1650" dirty="0"/>
           </a:p>
@@ -4457,14 +4360,14 @@
       </p:sp>
       <p:sp>
         <p:nvSpPr>
-          <p:cNvPr id="15" name="Text 13"/>
-          <p:cNvSpPr/>
-          <p:nvPr/>
-        </p:nvSpPr>
-        <p:spPr>
-          <a:xfrm>
-            <a:off x="9563100" y="4095750"/>
-            <a:ext cx="3352800" cy="628650"/>
+          <p:cNvPr id="14" name="Text 12"/>
+          <p:cNvSpPr/>
+          <p:nvPr/>
+        </p:nvSpPr>
+        <p:spPr>
+          <a:xfrm>
+            <a:off x="12255437" y="2628900"/>
+            <a:ext cx="4851368" cy="571500"/>
           </a:xfrm>
           <a:prstGeom prst="rect">
             <a:avLst/>
@@ -4473,17 +4376,17 @@
           <a:ln/>
         </p:spPr>
         <p:txBody>
-          <a:bodyPr wrap="square" lIns="0" tIns="9716" rIns="0" bIns="-9716" rtlCol="0" anchor="t"/>
+          <a:bodyPr wrap="square" lIns="0" tIns="8906" rIns="0" bIns="-8906" rtlCol="0" anchor="t"/>
           <a:lstStyle/>
           <a:p>
             <a:pPr algn="l" indent="0" marL="0">
               <a:lnSpc>
-                <a:spcPts val="2340"/>
+                <a:spcPts val="2145"/>
               </a:lnSpc>
               <a:buNone/>
             </a:pPr>
             <a:r>
-              <a:rPr lang="en-US" sz="1800" dirty="0" spc="-17" kern="0">
+              <a:rPr lang="en-US" sz="1650" dirty="0" spc="-1" kern="0">
                 <a:solidFill>
                   <a:srgbClr val="D8D3C4"/>
                 </a:solidFill>
@@ -4491,10 +4394,10 @@
                 <a:ea typeface="Be Vietnam Pro" pitchFamily="34" charset="-122"/>
                 <a:cs typeface="Be Vietnam Pro" pitchFamily="34" charset="-120"/>
               </a:rPr>
-              <a:t>tên</a:t>
-            </a:r>
-            <a:r>
-              <a:rPr lang="en-US" sz="1800" dirty="0" spc="2" kern="0">
+              <a:t>lớp</a:t>
+            </a:r>
+            <a:r>
+              <a:rPr lang="en-US" sz="1650" dirty="0" spc="2" kern="0">
                 <a:solidFill>
                   <a:srgbClr val="D8D3C4"/>
                 </a:solidFill>
@@ -4502,10 +4405,10 @@
                 <a:ea typeface="Be Vietnam Pro" pitchFamily="34" charset="-122"/>
                 <a:cs typeface="Be Vietnam Pro" pitchFamily="34" charset="-120"/>
               </a:rPr>
-              <a:t> cũ</a:t>
-            </a:r>
-            <a:r>
-              <a:rPr lang="en-US" sz="1800" dirty="0" spc="3" kern="0">
+              <a:t> mã</a:t>
+            </a:r>
+            <a:r>
+              <a:rPr lang="en-US" sz="1650" dirty="0" spc="-2" kern="0">
                 <a:solidFill>
                   <a:srgbClr val="D8D3C4"/>
                 </a:solidFill>
@@ -4513,10 +4416,10 @@
                 <a:ea typeface="Be Vietnam Pro" pitchFamily="34" charset="-122"/>
                 <a:cs typeface="Be Vietnam Pro" pitchFamily="34" charset="-120"/>
               </a:rPr>
-              <a:t> của</a:t>
-            </a:r>
-            <a:r>
-              <a:rPr lang="en-US" sz="1800" dirty="0" spc="-1" kern="0">
+              <a:t> hóa</a:t>
+            </a:r>
+            <a:r>
+              <a:rPr lang="en-US" sz="1650" dirty="0" spc="2" kern="0">
                 <a:solidFill>
                   <a:srgbClr val="D8D3C4"/>
                 </a:solidFill>
@@ -4524,10 +4427,10 @@
                 <a:ea typeface="Be Vietnam Pro" pitchFamily="34" charset="-122"/>
                 <a:cs typeface="Be Vietnam Pro" pitchFamily="34" charset="-120"/>
               </a:rPr>
-              <a:t> TLS,</a:t>
-            </a:r>
-            <a:r>
-              <a:rPr lang="en-US" sz="1800" dirty="0" spc="-6" kern="0">
+              <a:t> dữ</a:t>
+            </a:r>
+            <a:r>
+              <a:rPr lang="en-US" sz="1650" dirty="0" spc="0" kern="0">
                 <a:solidFill>
                   <a:srgbClr val="D8D3C4"/>
                 </a:solidFill>
@@ -4535,10 +4438,10 @@
                 <a:ea typeface="Be Vietnam Pro" pitchFamily="34" charset="-122"/>
                 <a:cs typeface="Be Vietnam Pro" pitchFamily="34" charset="-120"/>
               </a:rPr>
-              <a:t> nay</a:t>
-            </a:r>
-            <a:r>
-              <a:rPr lang="en-US" sz="1800" dirty="0" spc="13" kern="0">
+              <a:t> liệu</a:t>
+            </a:r>
+            <a:r>
+              <a:rPr lang="en-US" sz="1650" dirty="0" spc="5" kern="0">
                 <a:solidFill>
                   <a:srgbClr val="D8D3C4"/>
                 </a:solidFill>
@@ -4546,10 +4449,10 @@
                 <a:ea typeface="Be Vietnam Pro" pitchFamily="34" charset="-122"/>
                 <a:cs typeface="Be Vietnam Pro" pitchFamily="34" charset="-120"/>
               </a:rPr>
-              <a:t> đã</a:t>
-            </a:r>
-            <a:r>
-              <a:rPr lang="en-US" sz="1800" dirty="0" spc="0" kern="0">
+              <a:t> giữa</a:t>
+            </a:r>
+            <a:r>
+              <a:rPr lang="en-US" sz="1650" dirty="0" spc="-1" kern="0">
                 <a:solidFill>
                   <a:srgbClr val="D8D3C4"/>
                 </a:solidFill>
@@ -4557,10 +4460,10 @@
                 <a:ea typeface="Be Vietnam Pro" pitchFamily="34" charset="-122"/>
                 <a:cs typeface="Be Vietnam Pro" pitchFamily="34" charset="-120"/>
               </a:rPr>
-              <a:t> lỗi</a:t>
-            </a:r>
-            <a:r>
-              <a:rPr lang="en-US" sz="1800" dirty="0" spc="-1" kern="0">
+              <a:t> hai</a:t>
+            </a:r>
+            <a:r>
+              <a:rPr lang="en-US" sz="1650" dirty="0" spc="10" kern="0">
                 <a:solidFill>
                   <a:srgbClr val="D8D3C4"/>
                 </a:solidFill>
@@ -4568,26 +4471,26 @@
                 <a:ea typeface="Be Vietnam Pro" pitchFamily="34" charset="-122"/>
                 <a:cs typeface="Be Vietnam Pro" pitchFamily="34" charset="-120"/>
               </a:rPr>
-              <a:t> thời</a:t>
-            </a:r>
-            <a:endParaRPr lang="en-US" sz="1800" dirty="0"/>
+              <a:t> đầu</a:t>
+            </a:r>
+            <a:endParaRPr lang="en-US" sz="1650" dirty="0"/>
           </a:p>
         </p:txBody>
       </p:sp>
       <p:sp>
         <p:nvSpPr>
-          <p:cNvPr id="16" name="Shape 14"/>
-          <p:cNvSpPr/>
-          <p:nvPr/>
-        </p:nvSpPr>
-        <p:spPr>
-          <a:xfrm>
-            <a:off x="13487400" y="2628900"/>
-            <a:ext cx="3886200" cy="2247900"/>
+          <p:cNvPr id="15" name="Shape 13"/>
+          <p:cNvSpPr/>
+          <p:nvPr/>
+        </p:nvSpPr>
+        <p:spPr>
+          <a:xfrm>
+            <a:off x="914400" y="3524250"/>
+            <a:ext cx="5384768" cy="1924050"/>
           </a:xfrm>
           <a:prstGeom prst="roundRect">
             <a:avLst>
-              <a:gd name="adj" fmla="val 9322"/>
+              <a:gd name="adj" fmla="val 10891"/>
             </a:avLst>
           </a:prstGeom>
           <a:solidFill>
@@ -4603,14 +4506,14 @@
       </p:sp>
       <p:sp>
         <p:nvSpPr>
-          <p:cNvPr id="17" name="Text 15"/>
-          <p:cNvSpPr/>
-          <p:nvPr/>
-        </p:nvSpPr>
-        <p:spPr>
-          <a:xfrm>
-            <a:off x="13754100" y="2819400"/>
-            <a:ext cx="3352800" cy="571500"/>
+          <p:cNvPr id="16" name="Text 14"/>
+          <p:cNvSpPr/>
+          <p:nvPr/>
+        </p:nvSpPr>
+        <p:spPr>
+          <a:xfrm>
+            <a:off x="1181100" y="3657600"/>
+            <a:ext cx="4851368" cy="419100"/>
           </a:xfrm>
           <a:prstGeom prst="rect">
             <a:avLst/>
@@ -4626,7 +4529,7 @@
               <a:buNone/>
             </a:pPr>
             <a:r>
-              <a:rPr lang="en-US" sz="3450" dirty="0" spc="-41" kern="0">
+              <a:rPr lang="en-US" sz="2550" dirty="0" spc="6" kern="0">
                 <a:solidFill>
                   <a:srgbClr val="F3EEE3"/>
                 </a:solidFill>
@@ -4634,22 +4537,22 @@
                 <a:ea typeface="Bricolage Grotesque ExtraBold" pitchFamily="34" charset="-122"/>
                 <a:cs typeface="Bricolage Grotesque ExtraBold" pitchFamily="34" charset="-120"/>
               </a:rPr>
-              <a:t>CA</a:t>
-            </a:r>
-            <a:endParaRPr lang="en-US" sz="3450" dirty="0"/>
+              <a:t>SSL</a:t>
+            </a:r>
+            <a:endParaRPr lang="en-US" sz="2550" dirty="0"/>
           </a:p>
         </p:txBody>
       </p:sp>
       <p:sp>
         <p:nvSpPr>
-          <p:cNvPr id="18" name="Text 16"/>
-          <p:cNvSpPr/>
-          <p:nvPr/>
-        </p:nvSpPr>
-        <p:spPr>
-          <a:xfrm>
-            <a:off x="13754100" y="3429000"/>
-            <a:ext cx="3352800" cy="590550"/>
+          <p:cNvPr id="17" name="Text 15"/>
+          <p:cNvSpPr/>
+          <p:nvPr/>
+        </p:nvSpPr>
+        <p:spPr>
+          <a:xfrm>
+            <a:off x="1181100" y="4095750"/>
+            <a:ext cx="4851368" cy="552450"/>
           </a:xfrm>
           <a:prstGeom prst="rect">
             <a:avLst/>
@@ -4668,7 +4571,7 @@
               <a:buNone/>
             </a:pPr>
             <a:r>
-              <a:rPr lang="en-US" sz="1650" dirty="0" spc="-5" kern="0">
+              <a:rPr lang="en-US" sz="1650" dirty="0" spc="-14" kern="0">
                 <a:solidFill>
                   <a:srgbClr val="9A98A0"/>
                 </a:solidFill>
@@ -4676,10 +4579,10 @@
                 <a:ea typeface="Be Vietnam Pro" pitchFamily="34" charset="-122"/>
                 <a:cs typeface="Be Vietnam Pro" pitchFamily="34" charset="-120"/>
               </a:rPr>
-              <a:t>Certificate</a:t>
-            </a:r>
-            <a:r>
-              <a:rPr lang="en-US" sz="1650" dirty="0" spc="-1" kern="0">
+              <a:t>Secure</a:t>
+            </a:r>
+            <a:r>
+              <a:rPr lang="en-US" sz="1650" dirty="0" spc="-11" kern="0">
                 <a:solidFill>
                   <a:srgbClr val="9A98A0"/>
                 </a:solidFill>
@@ -4687,7 +4590,18 @@
                 <a:ea typeface="Be Vietnam Pro" pitchFamily="34" charset="-122"/>
                 <a:cs typeface="Be Vietnam Pro" pitchFamily="34" charset="-120"/>
               </a:rPr>
-              <a:t> Authority</a:t>
+              <a:t> Sockets</a:t>
+            </a:r>
+            <a:r>
+              <a:rPr lang="en-US" sz="1650" dirty="0" spc="-24" kern="0">
+                <a:solidFill>
+                  <a:srgbClr val="9A98A0"/>
+                </a:solidFill>
+                <a:latin typeface="Be Vietnam Pro" pitchFamily="34" charset="0"/>
+                <a:ea typeface="Be Vietnam Pro" pitchFamily="34" charset="-122"/>
+                <a:cs typeface="Be Vietnam Pro" pitchFamily="34" charset="-120"/>
+              </a:rPr>
+              <a:t> Layer</a:t>
             </a:r>
             <a:endParaRPr lang="en-US" sz="1650" dirty="0"/>
           </a:p>
@@ -4695,14 +4609,14 @@
       </p:sp>
       <p:sp>
         <p:nvSpPr>
-          <p:cNvPr id="19" name="Text 17"/>
-          <p:cNvSpPr/>
-          <p:nvPr/>
-        </p:nvSpPr>
-        <p:spPr>
-          <a:xfrm>
-            <a:off x="13754100" y="4095750"/>
-            <a:ext cx="3352800" cy="628650"/>
+          <p:cNvPr id="18" name="Text 16"/>
+          <p:cNvSpPr/>
+          <p:nvPr/>
+        </p:nvSpPr>
+        <p:spPr>
+          <a:xfrm>
+            <a:off x="1181100" y="4705350"/>
+            <a:ext cx="4851368" cy="571500"/>
           </a:xfrm>
           <a:prstGeom prst="rect">
             <a:avLst/>
@@ -4711,17 +4625,17 @@
           <a:ln/>
         </p:spPr>
         <p:txBody>
-          <a:bodyPr wrap="square" lIns="0" tIns="9716" rIns="0" bIns="-9716" rtlCol="0" anchor="t"/>
+          <a:bodyPr wrap="square" lIns="0" tIns="8906" rIns="0" bIns="-8906" rtlCol="0" anchor="t"/>
           <a:lstStyle/>
           <a:p>
             <a:pPr algn="l" indent="0" marL="0">
               <a:lnSpc>
-                <a:spcPts val="2340"/>
+                <a:spcPts val="2145"/>
               </a:lnSpc>
               <a:buNone/>
             </a:pPr>
             <a:r>
-              <a:rPr lang="en-US" sz="1800" dirty="0" spc="-7" kern="0">
+              <a:rPr lang="en-US" sz="1650" dirty="0" spc="-9" kern="0">
                 <a:solidFill>
                   <a:srgbClr val="D8D3C4"/>
                 </a:solidFill>
@@ -4729,10 +4643,10 @@
                 <a:ea typeface="Be Vietnam Pro" pitchFamily="34" charset="-122"/>
                 <a:cs typeface="Be Vietnam Pro" pitchFamily="34" charset="-120"/>
               </a:rPr>
-              <a:t>bên</a:t>
-            </a:r>
-            <a:r>
-              <a:rPr lang="en-US" sz="1800" dirty="0" spc="0" kern="0">
+              <a:t>tên</a:t>
+            </a:r>
+            <a:r>
+              <a:rPr lang="en-US" sz="1650" dirty="0" spc="1" kern="0">
                 <a:solidFill>
                   <a:srgbClr val="D8D3C4"/>
                 </a:solidFill>
@@ -4740,10 +4654,10 @@
                 <a:ea typeface="Be Vietnam Pro" pitchFamily="34" charset="-122"/>
                 <a:cs typeface="Be Vietnam Pro" pitchFamily="34" charset="-120"/>
               </a:rPr>
-              <a:t> ký</a:t>
-            </a:r>
-            <a:r>
-              <a:rPr lang="en-US" sz="1800" dirty="0" spc="-10" kern="0">
+              <a:t> cũ</a:t>
+            </a:r>
+            <a:r>
+              <a:rPr lang="en-US" sz="1650" dirty="0" spc="0" kern="0">
                 <a:solidFill>
                   <a:srgbClr val="D8D3C4"/>
                 </a:solidFill>
@@ -4751,10 +4665,10 @@
                 <a:ea typeface="Be Vietnam Pro" pitchFamily="34" charset="-122"/>
                 <a:cs typeface="Be Vietnam Pro" pitchFamily="34" charset="-120"/>
               </a:rPr>
-              <a:t> xác</a:t>
-            </a:r>
-            <a:r>
-              <a:rPr lang="en-US" sz="1800" dirty="0" spc="-3" kern="0">
+              <a:t> của</a:t>
+            </a:r>
+            <a:r>
+              <a:rPr lang="en-US" sz="1650" dirty="0" spc="1" kern="0">
                 <a:solidFill>
                   <a:srgbClr val="D8D3C4"/>
                 </a:solidFill>
@@ -4762,10 +4676,10 @@
                 <a:ea typeface="Be Vietnam Pro" pitchFamily="34" charset="-122"/>
                 <a:cs typeface="Be Vietnam Pro" pitchFamily="34" charset="-120"/>
               </a:rPr>
-              <a:t> nhận</a:t>
-            </a:r>
-            <a:r>
-              <a:rPr lang="en-US" sz="1800" dirty="0" spc="-1" kern="0">
+              <a:t> TLS,</a:t>
+            </a:r>
+            <a:r>
+              <a:rPr lang="en-US" sz="1650" dirty="0" spc="-7" kern="0">
                 <a:solidFill>
                   <a:srgbClr val="D8D3C4"/>
                 </a:solidFill>
@@ -4773,10 +4687,10 @@
                 <a:ea typeface="Be Vietnam Pro" pitchFamily="34" charset="-122"/>
                 <a:cs typeface="Be Vietnam Pro" pitchFamily="34" charset="-120"/>
               </a:rPr>
-              <a:t> khóa công</a:t>
-            </a:r>
-            <a:r>
-              <a:rPr lang="en-US" sz="1800" dirty="0" spc="1" kern="0">
+              <a:t> nay</a:t>
+            </a:r>
+            <a:r>
+              <a:rPr lang="en-US" sz="1650" dirty="0" spc="15" kern="0">
                 <a:solidFill>
                   <a:srgbClr val="D8D3C4"/>
                 </a:solidFill>
@@ -4784,10 +4698,10 @@
                 <a:ea typeface="Be Vietnam Pro" pitchFamily="34" charset="-122"/>
                 <a:cs typeface="Be Vietnam Pro" pitchFamily="34" charset="-120"/>
               </a:rPr>
-              <a:t> khai</a:t>
-            </a:r>
-            <a:r>
-              <a:rPr lang="en-US" sz="1800" dirty="0" spc="-3" kern="0">
+              <a:t> đã</a:t>
+            </a:r>
+            <a:r>
+              <a:rPr lang="en-US" sz="1650" dirty="0" spc="0" kern="0">
                 <a:solidFill>
                   <a:srgbClr val="D8D3C4"/>
                 </a:solidFill>
@@ -4795,10 +4709,10 @@
                 <a:ea typeface="Be Vietnam Pro" pitchFamily="34" charset="-122"/>
                 <a:cs typeface="Be Vietnam Pro" pitchFamily="34" charset="-120"/>
               </a:rPr>
-              <a:t> thuộc</a:t>
-            </a:r>
-            <a:r>
-              <a:rPr lang="en-US" sz="1800" dirty="0" spc="-13" kern="0">
+              <a:t> lỗi</a:t>
+            </a:r>
+            <a:r>
+              <a:rPr lang="en-US" sz="1650" dirty="0" spc="2" kern="0">
                 <a:solidFill>
                   <a:srgbClr val="D8D3C4"/>
                 </a:solidFill>
@@ -4806,48 +4720,26 @@
                 <a:ea typeface="Be Vietnam Pro" pitchFamily="34" charset="-122"/>
                 <a:cs typeface="Be Vietnam Pro" pitchFamily="34" charset="-120"/>
               </a:rPr>
-              <a:t> về</a:t>
-            </a:r>
-            <a:r>
-              <a:rPr lang="en-US" sz="1800" dirty="0" spc="-7" kern="0">
-                <a:solidFill>
-                  <a:srgbClr val="D8D3C4"/>
-                </a:solidFill>
-                <a:latin typeface="Be Vietnam Pro" pitchFamily="34" charset="0"/>
-                <a:ea typeface="Be Vietnam Pro" pitchFamily="34" charset="-122"/>
-                <a:cs typeface="Be Vietnam Pro" pitchFamily="34" charset="-120"/>
-              </a:rPr>
-              <a:t> một</a:t>
-            </a:r>
-            <a:r>
-              <a:rPr lang="en-US" sz="1800" dirty="0" spc="-12" kern="0">
-                <a:solidFill>
-                  <a:srgbClr val="D8D3C4"/>
-                </a:solidFill>
-                <a:latin typeface="Be Vietnam Pro" pitchFamily="34" charset="0"/>
-                <a:ea typeface="Be Vietnam Pro" pitchFamily="34" charset="-122"/>
-                <a:cs typeface="Be Vietnam Pro" pitchFamily="34" charset="-120"/>
-              </a:rPr>
-              <a:t> tên</a:t>
-            </a:r>
-            <a:endParaRPr lang="en-US" sz="1800" dirty="0"/>
+              <a:t> thời</a:t>
+            </a:r>
+            <a:endParaRPr lang="en-US" sz="1650" dirty="0"/>
           </a:p>
         </p:txBody>
       </p:sp>
       <p:sp>
         <p:nvSpPr>
-          <p:cNvPr id="20" name="Shape 18"/>
-          <p:cNvSpPr/>
-          <p:nvPr/>
-        </p:nvSpPr>
-        <p:spPr>
-          <a:xfrm>
-            <a:off x="914400" y="5105400"/>
-            <a:ext cx="3886200" cy="2247900"/>
+          <p:cNvPr id="19" name="Shape 17"/>
+          <p:cNvSpPr/>
+          <p:nvPr/>
+        </p:nvSpPr>
+        <p:spPr>
+          <a:xfrm>
+            <a:off x="6451568" y="3524250"/>
+            <a:ext cx="5384768" cy="1924050"/>
           </a:xfrm>
           <a:prstGeom prst="roundRect">
             <a:avLst>
-              <a:gd name="adj" fmla="val 9322"/>
+              <a:gd name="adj" fmla="val 10891"/>
             </a:avLst>
           </a:prstGeom>
           <a:solidFill>
@@ -4863,14 +4755,14 @@
       </p:sp>
       <p:sp>
         <p:nvSpPr>
-          <p:cNvPr id="21" name="Text 19"/>
-          <p:cNvSpPr/>
-          <p:nvPr/>
-        </p:nvSpPr>
-        <p:spPr>
-          <a:xfrm>
-            <a:off x="1181100" y="5295900"/>
-            <a:ext cx="3352800" cy="571500"/>
+          <p:cNvPr id="20" name="Text 18"/>
+          <p:cNvSpPr/>
+          <p:nvPr/>
+        </p:nvSpPr>
+        <p:spPr>
+          <a:xfrm>
+            <a:off x="6718268" y="3657600"/>
+            <a:ext cx="4851368" cy="419100"/>
           </a:xfrm>
           <a:prstGeom prst="rect">
             <a:avLst/>
@@ -4886,7 +4778,7 @@
               <a:buNone/>
             </a:pPr>
             <a:r>
-              <a:rPr lang="en-US" sz="3450" dirty="0" spc="-23" kern="0">
+              <a:rPr lang="en-US" sz="2550" dirty="0" spc="-30" kern="0">
                 <a:solidFill>
                   <a:srgbClr val="F3EEE3"/>
                 </a:solidFill>
@@ -4894,22 +4786,22 @@
                 <a:ea typeface="Bricolage Grotesque ExtraBold" pitchFamily="34" charset="-122"/>
                 <a:cs typeface="Bricolage Grotesque ExtraBold" pitchFamily="34" charset="-120"/>
               </a:rPr>
-              <a:t>RSA</a:t>
-            </a:r>
-            <a:endParaRPr lang="en-US" sz="3450" dirty="0"/>
+              <a:t>CA</a:t>
+            </a:r>
+            <a:endParaRPr lang="en-US" sz="2550" dirty="0"/>
           </a:p>
         </p:txBody>
       </p:sp>
       <p:sp>
         <p:nvSpPr>
-          <p:cNvPr id="22" name="Text 20"/>
-          <p:cNvSpPr/>
-          <p:nvPr/>
-        </p:nvSpPr>
-        <p:spPr>
-          <a:xfrm>
-            <a:off x="1181100" y="5905500"/>
-            <a:ext cx="3352800" cy="590550"/>
+          <p:cNvPr id="21" name="Text 19"/>
+          <p:cNvSpPr/>
+          <p:nvPr/>
+        </p:nvSpPr>
+        <p:spPr>
+          <a:xfrm>
+            <a:off x="6718268" y="4095750"/>
+            <a:ext cx="4851368" cy="552450"/>
           </a:xfrm>
           <a:prstGeom prst="rect">
             <a:avLst/>
@@ -4928,7 +4820,7 @@
               <a:buNone/>
             </a:pPr>
             <a:r>
-              <a:rPr lang="en-US" sz="1650" dirty="0" spc="-4" kern="0">
+              <a:rPr lang="en-US" sz="1650" dirty="0" spc="-5" kern="0">
                 <a:solidFill>
                   <a:srgbClr val="9A98A0"/>
                 </a:solidFill>
@@ -4936,7 +4828,18 @@
                 <a:ea typeface="Be Vietnam Pro" pitchFamily="34" charset="-122"/>
                 <a:cs typeface="Be Vietnam Pro" pitchFamily="34" charset="-120"/>
               </a:rPr>
-              <a:t>Rivest-Shamir-Adleman</a:t>
+              <a:t>Certificate</a:t>
+            </a:r>
+            <a:r>
+              <a:rPr lang="en-US" sz="1650" dirty="0" spc="-1" kern="0">
+                <a:solidFill>
+                  <a:srgbClr val="9A98A0"/>
+                </a:solidFill>
+                <a:latin typeface="Be Vietnam Pro" pitchFamily="34" charset="0"/>
+                <a:ea typeface="Be Vietnam Pro" pitchFamily="34" charset="-122"/>
+                <a:cs typeface="Be Vietnam Pro" pitchFamily="34" charset="-120"/>
+              </a:rPr>
+              <a:t> Authority</a:t>
             </a:r>
             <a:endParaRPr lang="en-US" sz="1650" dirty="0"/>
           </a:p>
@@ -4944,14 +4847,14 @@
       </p:sp>
       <p:sp>
         <p:nvSpPr>
-          <p:cNvPr id="23" name="Text 21"/>
-          <p:cNvSpPr/>
-          <p:nvPr/>
-        </p:nvSpPr>
-        <p:spPr>
-          <a:xfrm>
-            <a:off x="1181100" y="6572250"/>
-            <a:ext cx="3352800" cy="628650"/>
+          <p:cNvPr id="22" name="Text 20"/>
+          <p:cNvSpPr/>
+          <p:nvPr/>
+        </p:nvSpPr>
+        <p:spPr>
+          <a:xfrm>
+            <a:off x="6718268" y="4705350"/>
+            <a:ext cx="4851368" cy="571500"/>
           </a:xfrm>
           <a:prstGeom prst="rect">
             <a:avLst/>
@@ -4960,17 +4863,17 @@
           <a:ln/>
         </p:spPr>
         <p:txBody>
-          <a:bodyPr wrap="square" lIns="0" tIns="9716" rIns="0" bIns="-9716" rtlCol="0" anchor="t"/>
+          <a:bodyPr wrap="square" lIns="0" tIns="8906" rIns="0" bIns="-8906" rtlCol="0" anchor="t"/>
           <a:lstStyle/>
           <a:p>
             <a:pPr algn="l" indent="0" marL="0">
               <a:lnSpc>
-                <a:spcPts val="2340"/>
+                <a:spcPts val="2145"/>
               </a:lnSpc>
               <a:buNone/>
             </a:pPr>
             <a:r>
-              <a:rPr lang="en-US" sz="1800" dirty="0" spc="-10" kern="0">
+              <a:rPr lang="en-US" sz="1650" dirty="0" spc="-2" kern="0">
                 <a:solidFill>
                   <a:srgbClr val="D8D3C4"/>
                 </a:solidFill>
@@ -4978,10 +4881,10 @@
                 <a:ea typeface="Be Vietnam Pro" pitchFamily="34" charset="-122"/>
                 <a:cs typeface="Be Vietnam Pro" pitchFamily="34" charset="-120"/>
               </a:rPr>
-              <a:t>thuật toán</a:t>
-            </a:r>
-            <a:r>
-              <a:rPr lang="en-US" sz="1800" dirty="0" spc="-1" kern="0">
+              <a:t>bên</a:t>
+            </a:r>
+            <a:r>
+              <a:rPr lang="en-US" sz="1650" dirty="0" spc="2" kern="0">
                 <a:solidFill>
                   <a:srgbClr val="D8D3C4"/>
                 </a:solidFill>
@@ -4989,10 +4892,10 @@
                 <a:ea typeface="Be Vietnam Pro" pitchFamily="34" charset="-122"/>
                 <a:cs typeface="Be Vietnam Pro" pitchFamily="34" charset="-120"/>
               </a:rPr>
-              <a:t> khóa công</a:t>
-            </a:r>
-            <a:r>
-              <a:rPr lang="en-US" sz="1800" dirty="0" spc="0" kern="0">
+              <a:t> ký</a:t>
+            </a:r>
+            <a:r>
+              <a:rPr lang="en-US" sz="1650" dirty="0" spc="-12" kern="0">
                 <a:solidFill>
                   <a:srgbClr val="D8D3C4"/>
                 </a:solidFill>
@@ -5000,10 +4903,10 @@
                 <a:ea typeface="Be Vietnam Pro" pitchFamily="34" charset="-122"/>
                 <a:cs typeface="Be Vietnam Pro" pitchFamily="34" charset="-120"/>
               </a:rPr>
-              <a:t> khai,</a:t>
-            </a:r>
-            <a:r>
-              <a:rPr lang="en-US" sz="1800" dirty="0" spc="-2" kern="0">
+              <a:t> xác</a:t>
+            </a:r>
+            <a:r>
+              <a:rPr lang="en-US" sz="1650" dirty="0" spc="0" kern="0">
                 <a:solidFill>
                   <a:srgbClr val="D8D3C4"/>
                 </a:solidFill>
@@ -5011,10 +4914,10 @@
                 <a:ea typeface="Be Vietnam Pro" pitchFamily="34" charset="-122"/>
                 <a:cs typeface="Be Vietnam Pro" pitchFamily="34" charset="-120"/>
               </a:rPr>
-              <a:t> kiểu</a:t>
-            </a:r>
-            <a:r>
-              <a:rPr lang="en-US" sz="1800" dirty="0" spc="0" kern="0">
+              <a:t> nhận</a:t>
+            </a:r>
+            <a:r>
+              <a:rPr lang="en-US" sz="1650" dirty="0" spc="-1" kern="0">
                 <a:solidFill>
                   <a:srgbClr val="D8D3C4"/>
                 </a:solidFill>
@@ -5022,10 +4925,10 @@
                 <a:ea typeface="Be Vietnam Pro" pitchFamily="34" charset="-122"/>
                 <a:cs typeface="Be Vietnam Pro" pitchFamily="34" charset="-120"/>
               </a:rPr>
-              <a:t> TLS</a:t>
-            </a:r>
-            <a:r>
-              <a:rPr lang="en-US" sz="1800" dirty="0" spc="2" kern="0">
+              <a:t> khóa</a:t>
+            </a:r>
+            <a:r>
+              <a:rPr lang="en-US" sz="1650" dirty="0" spc="0" kern="0">
                 <a:solidFill>
                   <a:srgbClr val="D8D3C4"/>
                 </a:solidFill>
@@ -5033,26 +4936,48 @@
                 <a:ea typeface="Be Vietnam Pro" pitchFamily="34" charset="-122"/>
                 <a:cs typeface="Be Vietnam Pro" pitchFamily="34" charset="-120"/>
               </a:rPr>
-              <a:t> cũ</a:t>
-            </a:r>
-            <a:endParaRPr lang="en-US" sz="1800" dirty="0"/>
+              <a:t> của</a:t>
+            </a:r>
+            <a:r>
+              <a:rPr lang="en-US" sz="1650" dirty="0" spc="-1" kern="0">
+                <a:solidFill>
+                  <a:srgbClr val="D8D3C4"/>
+                </a:solidFill>
+                <a:latin typeface="Be Vietnam Pro" pitchFamily="34" charset="0"/>
+                <a:ea typeface="Be Vietnam Pro" pitchFamily="34" charset="-122"/>
+                <a:cs typeface="Be Vietnam Pro" pitchFamily="34" charset="-120"/>
+              </a:rPr>
+              <a:t> một</a:t>
+            </a:r>
+            <a:r>
+              <a:rPr lang="en-US" sz="1650" dirty="0" spc="-6" kern="0">
+                <a:solidFill>
+                  <a:srgbClr val="D8D3C4"/>
+                </a:solidFill>
+                <a:latin typeface="Be Vietnam Pro" pitchFamily="34" charset="0"/>
+                <a:ea typeface="Be Vietnam Pro" pitchFamily="34" charset="-122"/>
+                <a:cs typeface="Be Vietnam Pro" pitchFamily="34" charset="-120"/>
+              </a:rPr>
+              <a:t> tên</a:t>
+            </a:r>
+            <a:endParaRPr lang="en-US" sz="1650" dirty="0"/>
           </a:p>
         </p:txBody>
       </p:sp>
       <p:sp>
         <p:nvSpPr>
-          <p:cNvPr id="24" name="Shape 22"/>
-          <p:cNvSpPr/>
-          <p:nvPr/>
-        </p:nvSpPr>
-        <p:spPr>
-          <a:xfrm>
-            <a:off x="5105400" y="5105400"/>
-            <a:ext cx="3886200" cy="2247900"/>
+          <p:cNvPr id="23" name="Shape 21"/>
+          <p:cNvSpPr/>
+          <p:nvPr/>
+        </p:nvSpPr>
+        <p:spPr>
+          <a:xfrm>
+            <a:off x="11988737" y="3524250"/>
+            <a:ext cx="5384768" cy="1924050"/>
           </a:xfrm>
           <a:prstGeom prst="roundRect">
             <a:avLst>
-              <a:gd name="adj" fmla="val 9322"/>
+              <a:gd name="adj" fmla="val 10891"/>
             </a:avLst>
           </a:prstGeom>
           <a:solidFill>
@@ -5068,14 +4993,14 @@
       </p:sp>
       <p:sp>
         <p:nvSpPr>
-          <p:cNvPr id="25" name="Text 23"/>
-          <p:cNvSpPr/>
-          <p:nvPr/>
-        </p:nvSpPr>
-        <p:spPr>
-          <a:xfrm>
-            <a:off x="5372100" y="5295900"/>
-            <a:ext cx="3352800" cy="571500"/>
+          <p:cNvPr id="24" name="Text 22"/>
+          <p:cNvSpPr/>
+          <p:nvPr/>
+        </p:nvSpPr>
+        <p:spPr>
+          <a:xfrm>
+            <a:off x="12255437" y="3657600"/>
+            <a:ext cx="4851368" cy="419100"/>
           </a:xfrm>
           <a:prstGeom prst="rect">
             <a:avLst/>
@@ -5091,7 +5016,7 @@
               <a:buNone/>
             </a:pPr>
             <a:r>
-              <a:rPr lang="en-US" sz="3450" dirty="0" spc="-26" kern="0">
+              <a:rPr lang="en-US" sz="2550" dirty="0" spc="-12" kern="0">
                 <a:solidFill>
                   <a:srgbClr val="F3EEE3"/>
                 </a:solidFill>
@@ -5099,22 +5024,22 @@
                 <a:ea typeface="Bricolage Grotesque ExtraBold" pitchFamily="34" charset="-122"/>
                 <a:cs typeface="Bricolage Grotesque ExtraBold" pitchFamily="34" charset="-120"/>
               </a:rPr>
-              <a:t>RFC</a:t>
-            </a:r>
-            <a:endParaRPr lang="en-US" sz="3450" dirty="0"/>
+              <a:t>RSA</a:t>
+            </a:r>
+            <a:endParaRPr lang="en-US" sz="2550" dirty="0"/>
           </a:p>
         </p:txBody>
       </p:sp>
       <p:sp>
         <p:nvSpPr>
-          <p:cNvPr id="26" name="Text 24"/>
-          <p:cNvSpPr/>
-          <p:nvPr/>
-        </p:nvSpPr>
-        <p:spPr>
-          <a:xfrm>
-            <a:off x="5372100" y="5905500"/>
-            <a:ext cx="3352800" cy="590550"/>
+          <p:cNvPr id="25" name="Text 23"/>
+          <p:cNvSpPr/>
+          <p:nvPr/>
+        </p:nvSpPr>
+        <p:spPr>
+          <a:xfrm>
+            <a:off x="12255437" y="4095750"/>
+            <a:ext cx="4851368" cy="552450"/>
           </a:xfrm>
           <a:prstGeom prst="rect">
             <a:avLst/>
@@ -5133,7 +5058,7 @@
               <a:buNone/>
             </a:pPr>
             <a:r>
-              <a:rPr lang="en-US" sz="1650" dirty="0" spc="-14" kern="0">
+              <a:rPr lang="en-US" sz="1650" dirty="0" spc="-4" kern="0">
                 <a:solidFill>
                   <a:srgbClr val="9A98A0"/>
                 </a:solidFill>
@@ -5141,29 +5066,7 @@
                 <a:ea typeface="Be Vietnam Pro" pitchFamily="34" charset="-122"/>
                 <a:cs typeface="Be Vietnam Pro" pitchFamily="34" charset="-120"/>
               </a:rPr>
-              <a:t>Request</a:t>
-            </a:r>
-            <a:r>
-              <a:rPr lang="en-US" sz="1650" dirty="0" spc="-13" kern="0">
-                <a:solidFill>
-                  <a:srgbClr val="9A98A0"/>
-                </a:solidFill>
-                <a:latin typeface="Be Vietnam Pro" pitchFamily="34" charset="0"/>
-                <a:ea typeface="Be Vietnam Pro" pitchFamily="34" charset="-122"/>
-                <a:cs typeface="Be Vietnam Pro" pitchFamily="34" charset="-120"/>
-              </a:rPr>
-              <a:t> for</a:t>
-            </a:r>
-            <a:r>
-              <a:rPr lang="en-US" sz="1650" dirty="0" spc="-3" kern="0">
-                <a:solidFill>
-                  <a:srgbClr val="9A98A0"/>
-                </a:solidFill>
-                <a:latin typeface="Be Vietnam Pro" pitchFamily="34" charset="0"/>
-                <a:ea typeface="Be Vietnam Pro" pitchFamily="34" charset="-122"/>
-                <a:cs typeface="Be Vietnam Pro" pitchFamily="34" charset="-120"/>
-              </a:rPr>
-              <a:t> Comments</a:t>
+              <a:t>Rivest-Shamir-Adleman</a:t>
             </a:r>
             <a:endParaRPr lang="en-US" sz="1650" dirty="0"/>
           </a:p>
@@ -5171,14 +5074,14 @@
       </p:sp>
       <p:sp>
         <p:nvSpPr>
-          <p:cNvPr id="27" name="Text 25"/>
-          <p:cNvSpPr/>
-          <p:nvPr/>
-        </p:nvSpPr>
-        <p:spPr>
-          <a:xfrm>
-            <a:off x="5372100" y="6572250"/>
-            <a:ext cx="3352800" cy="628650"/>
+          <p:cNvPr id="26" name="Text 24"/>
+          <p:cNvSpPr/>
+          <p:nvPr/>
+        </p:nvSpPr>
+        <p:spPr>
+          <a:xfrm>
+            <a:off x="12255437" y="4705350"/>
+            <a:ext cx="4851368" cy="571500"/>
           </a:xfrm>
           <a:prstGeom prst="rect">
             <a:avLst/>
@@ -5187,17 +5090,17 @@
           <a:ln/>
         </p:spPr>
         <p:txBody>
-          <a:bodyPr wrap="square" lIns="0" tIns="9716" rIns="0" bIns="-9716" rtlCol="0" anchor="t"/>
+          <a:bodyPr wrap="square" lIns="0" tIns="8906" rIns="0" bIns="-8906" rtlCol="0" anchor="t"/>
           <a:lstStyle/>
           <a:p>
             <a:pPr algn="l" indent="0" marL="0">
               <a:lnSpc>
-                <a:spcPts val="2340"/>
+                <a:spcPts val="2145"/>
               </a:lnSpc>
               <a:buNone/>
             </a:pPr>
             <a:r>
-              <a:rPr lang="en-US" sz="1800" dirty="0" spc="-12" kern="0">
+              <a:rPr lang="en-US" sz="1650" dirty="0" spc="-4" kern="0">
                 <a:solidFill>
                   <a:srgbClr val="D8D3C4"/>
                 </a:solidFill>
@@ -5205,10 +5108,10 @@
                 <a:ea typeface="Be Vietnam Pro" pitchFamily="34" charset="-122"/>
                 <a:cs typeface="Be Vietnam Pro" pitchFamily="34" charset="-120"/>
               </a:rPr>
-              <a:t>RFC</a:t>
-            </a:r>
-            <a:r>
-              <a:rPr lang="en-US" sz="1800" dirty="0" spc="2" kern="0">
+              <a:t>thuật</a:t>
+            </a:r>
+            <a:r>
+              <a:rPr lang="en-US" sz="1650" dirty="0" spc="-8" kern="0">
                 <a:solidFill>
                   <a:srgbClr val="D8D3C4"/>
                 </a:solidFill>
@@ -5216,10 +5119,10 @@
                 <a:ea typeface="Be Vietnam Pro" pitchFamily="34" charset="-122"/>
                 <a:cs typeface="Be Vietnam Pro" pitchFamily="34" charset="-120"/>
               </a:rPr>
-              <a:t> 8446</a:t>
-            </a:r>
-            <a:r>
-              <a:rPr lang="en-US" sz="1800" dirty="0" spc="-1" kern="0">
+              <a:t> toán</a:t>
+            </a:r>
+            <a:r>
+              <a:rPr lang="en-US" sz="1650" dirty="0" spc="0" kern="0">
                 <a:solidFill>
                   <a:srgbClr val="D8D3C4"/>
                 </a:solidFill>
@@ -5227,10 +5130,10 @@
                 <a:ea typeface="Be Vietnam Pro" pitchFamily="34" charset="-122"/>
                 <a:cs typeface="Be Vietnam Pro" pitchFamily="34" charset="-120"/>
               </a:rPr>
-              <a:t> là</a:t>
-            </a:r>
-            <a:r>
-              <a:rPr lang="en-US" sz="1800" dirty="0" spc="12" kern="0">
+              <a:t> khóa</a:t>
+            </a:r>
+            <a:r>
+              <a:rPr lang="en-US" sz="1650" dirty="0" spc="-1" kern="0">
                 <a:solidFill>
                   <a:srgbClr val="D8D3C4"/>
                 </a:solidFill>
@@ -5238,10 +5141,10 @@
                 <a:ea typeface="Be Vietnam Pro" pitchFamily="34" charset="-122"/>
                 <a:cs typeface="Be Vietnam Pro" pitchFamily="34" charset="-120"/>
               </a:rPr>
-              <a:t> đặc</a:t>
-            </a:r>
-            <a:r>
-              <a:rPr lang="en-US" sz="1800" dirty="0" spc="-13" kern="0">
+              <a:t> công</a:t>
+            </a:r>
+            <a:r>
+              <a:rPr lang="en-US" sz="1650" dirty="0" spc="1" kern="0">
                 <a:solidFill>
                   <a:srgbClr val="D8D3C4"/>
                 </a:solidFill>
@@ -5249,10 +5152,10 @@
                 <a:ea typeface="Be Vietnam Pro" pitchFamily="34" charset="-122"/>
                 <a:cs typeface="Be Vietnam Pro" pitchFamily="34" charset="-120"/>
               </a:rPr>
-              <a:t> tả</a:t>
-            </a:r>
-            <a:r>
-              <a:rPr lang="en-US" sz="1800" dirty="0" spc="3" kern="0">
+              <a:t> khai,</a:t>
+            </a:r>
+            <a:r>
+              <a:rPr lang="en-US" sz="1650" dirty="0" spc="0" kern="0">
                 <a:solidFill>
                   <a:srgbClr val="D8D3C4"/>
                 </a:solidFill>
@@ -5260,10 +5163,10 @@
                 <a:ea typeface="Be Vietnam Pro" pitchFamily="34" charset="-122"/>
                 <a:cs typeface="Be Vietnam Pro" pitchFamily="34" charset="-120"/>
               </a:rPr>
-              <a:t> của</a:t>
-            </a:r>
-            <a:r>
-              <a:rPr lang="en-US" sz="1800" dirty="0" spc="0" kern="0">
+              <a:t> TLS</a:t>
+            </a:r>
+            <a:r>
+              <a:rPr lang="en-US" sz="1650" dirty="0" spc="2" kern="0">
                 <a:solidFill>
                   <a:srgbClr val="D8D3C4"/>
                 </a:solidFill>
@@ -5271,10 +5174,10 @@
                 <a:ea typeface="Be Vietnam Pro" pitchFamily="34" charset="-122"/>
                 <a:cs typeface="Be Vietnam Pro" pitchFamily="34" charset="-120"/>
               </a:rPr>
-              <a:t> TLS</a:t>
-            </a:r>
-            <a:r>
-              <a:rPr lang="en-US" sz="1800" dirty="0" spc="2" kern="0">
+              <a:t> cũ</a:t>
+            </a:r>
+            <a:r>
+              <a:rPr lang="en-US" sz="1650" dirty="0" spc="0" kern="0">
                 <a:solidFill>
                   <a:srgbClr val="D8D3C4"/>
                 </a:solidFill>
@@ -5282,26 +5185,26 @@
                 <a:ea typeface="Be Vietnam Pro" pitchFamily="34" charset="-122"/>
                 <a:cs typeface="Be Vietnam Pro" pitchFamily="34" charset="-120"/>
               </a:rPr>
-              <a:t> 1.3</a:t>
-            </a:r>
-            <a:endParaRPr lang="en-US" sz="1800" dirty="0"/>
+              <a:t> dùng</a:t>
+            </a:r>
+            <a:endParaRPr lang="en-US" sz="1650" dirty="0"/>
           </a:p>
         </p:txBody>
       </p:sp>
       <p:sp>
         <p:nvSpPr>
-          <p:cNvPr id="28" name="Shape 26"/>
-          <p:cNvSpPr/>
-          <p:nvPr/>
-        </p:nvSpPr>
-        <p:spPr>
-          <a:xfrm>
-            <a:off x="9296400" y="5105400"/>
-            <a:ext cx="3886200" cy="2247900"/>
+          <p:cNvPr id="27" name="Shape 25"/>
+          <p:cNvSpPr/>
+          <p:nvPr/>
+        </p:nvSpPr>
+        <p:spPr>
+          <a:xfrm>
+            <a:off x="914400" y="5600700"/>
+            <a:ext cx="5384768" cy="1924050"/>
           </a:xfrm>
           <a:prstGeom prst="roundRect">
             <a:avLst>
-              <a:gd name="adj" fmla="val 9322"/>
+              <a:gd name="adj" fmla="val 10891"/>
             </a:avLst>
           </a:prstGeom>
           <a:solidFill>
@@ -5317,14 +5220,14 @@
       </p:sp>
       <p:sp>
         <p:nvSpPr>
-          <p:cNvPr id="29" name="Text 27"/>
-          <p:cNvSpPr/>
-          <p:nvPr/>
-        </p:nvSpPr>
-        <p:spPr>
-          <a:xfrm>
-            <a:off x="9563100" y="5295900"/>
-            <a:ext cx="3352800" cy="571500"/>
+          <p:cNvPr id="28" name="Text 26"/>
+          <p:cNvSpPr/>
+          <p:nvPr/>
+        </p:nvSpPr>
+        <p:spPr>
+          <a:xfrm>
+            <a:off x="1181100" y="5734050"/>
+            <a:ext cx="4851368" cy="419100"/>
           </a:xfrm>
           <a:prstGeom prst="rect">
             <a:avLst/>
@@ -5340,7 +5243,7 @@
               <a:buNone/>
             </a:pPr>
             <a:r>
-              <a:rPr lang="en-US" sz="3450" dirty="0" spc="-83" kern="0">
+              <a:rPr lang="en-US" sz="2550" dirty="0" spc="-17" kern="0">
                 <a:solidFill>
                   <a:srgbClr val="F3EEE3"/>
                 </a:solidFill>
@@ -5348,22 +5251,22 @@
                 <a:ea typeface="Bricolage Grotesque ExtraBold" pitchFamily="34" charset="-122"/>
                 <a:cs typeface="Bricolage Grotesque ExtraBold" pitchFamily="34" charset="-120"/>
               </a:rPr>
-              <a:t>OWASP</a:t>
-            </a:r>
-            <a:endParaRPr lang="en-US" sz="3450" dirty="0"/>
+              <a:t>RFC</a:t>
+            </a:r>
+            <a:endParaRPr lang="en-US" sz="2550" dirty="0"/>
           </a:p>
         </p:txBody>
       </p:sp>
       <p:sp>
         <p:nvSpPr>
-          <p:cNvPr id="30" name="Text 28"/>
-          <p:cNvSpPr/>
-          <p:nvPr/>
-        </p:nvSpPr>
-        <p:spPr>
-          <a:xfrm>
-            <a:off x="9563100" y="5905500"/>
-            <a:ext cx="3352800" cy="590550"/>
+          <p:cNvPr id="29" name="Text 27"/>
+          <p:cNvSpPr/>
+          <p:nvPr/>
+        </p:nvSpPr>
+        <p:spPr>
+          <a:xfrm>
+            <a:off x="1181100" y="6172200"/>
+            <a:ext cx="4851368" cy="552450"/>
           </a:xfrm>
           <a:prstGeom prst="rect">
             <a:avLst/>
@@ -5382,6 +5285,28 @@
               <a:buNone/>
             </a:pPr>
             <a:r>
+              <a:rPr lang="en-US" sz="1650" dirty="0" spc="-14" kern="0">
+                <a:solidFill>
+                  <a:srgbClr val="9A98A0"/>
+                </a:solidFill>
+                <a:latin typeface="Be Vietnam Pro" pitchFamily="34" charset="0"/>
+                <a:ea typeface="Be Vietnam Pro" pitchFamily="34" charset="-122"/>
+                <a:cs typeface="Be Vietnam Pro" pitchFamily="34" charset="-120"/>
+              </a:rPr>
+              <a:t>Request</a:t>
+            </a:r>
+            <a:r>
+              <a:rPr lang="en-US" sz="1650" dirty="0" spc="-13" kern="0">
+                <a:solidFill>
+                  <a:srgbClr val="9A98A0"/>
+                </a:solidFill>
+                <a:latin typeface="Be Vietnam Pro" pitchFamily="34" charset="0"/>
+                <a:ea typeface="Be Vietnam Pro" pitchFamily="34" charset="-122"/>
+                <a:cs typeface="Be Vietnam Pro" pitchFamily="34" charset="-120"/>
+              </a:rPr>
+              <a:t> for</a:t>
+            </a:r>
+            <a:r>
               <a:rPr lang="en-US" sz="1650" dirty="0" spc="-3" kern="0">
                 <a:solidFill>
                   <a:srgbClr val="9A98A0"/>
@@ -5390,51 +5315,7 @@
                 <a:ea typeface="Be Vietnam Pro" pitchFamily="34" charset="-122"/>
                 <a:cs typeface="Be Vietnam Pro" pitchFamily="34" charset="-120"/>
               </a:rPr>
-              <a:t>Open</a:t>
-            </a:r>
-            <a:r>
-              <a:rPr lang="en-US" sz="1650" dirty="0" spc="-8" kern="0">
-                <a:solidFill>
-                  <a:srgbClr val="9A98A0"/>
-                </a:solidFill>
-                <a:latin typeface="Be Vietnam Pro" pitchFamily="34" charset="0"/>
-                <a:ea typeface="Be Vietnam Pro" pitchFamily="34" charset="-122"/>
-                <a:cs typeface="Be Vietnam Pro" pitchFamily="34" charset="-120"/>
-              </a:rPr>
-              <a:t> Worldwide</a:t>
-            </a:r>
-            <a:r>
-              <a:rPr lang="en-US" sz="1650" dirty="0" spc="-4" kern="0">
-                <a:solidFill>
-                  <a:srgbClr val="9A98A0"/>
-                </a:solidFill>
-                <a:latin typeface="Be Vietnam Pro" pitchFamily="34" charset="0"/>
-                <a:ea typeface="Be Vietnam Pro" pitchFamily="34" charset="-122"/>
-                <a:cs typeface="Be Vietnam Pro" pitchFamily="34" charset="-120"/>
-              </a:rPr>
-              <a:t> Application</a:t>
-            </a:r>
-            <a:r>
-              <a:rPr lang="en-US" sz="1650" dirty="0" spc="1" kern="0">
-                <a:solidFill>
-                  <a:srgbClr val="9A98A0"/>
-                </a:solidFill>
-                <a:latin typeface="Be Vietnam Pro" pitchFamily="34" charset="0"/>
-                <a:ea typeface="Be Vietnam Pro" pitchFamily="34" charset="-122"/>
-                <a:cs typeface="Be Vietnam Pro" pitchFamily="34" charset="-120"/>
-              </a:rPr>
-              <a:t> Security</a:t>
-            </a:r>
-            <a:r>
-              <a:rPr lang="en-US" sz="1650" dirty="0" spc="-16" kern="0">
-                <a:solidFill>
-                  <a:srgbClr val="9A98A0"/>
-                </a:solidFill>
-                <a:latin typeface="Be Vietnam Pro" pitchFamily="34" charset="0"/>
-                <a:ea typeface="Be Vietnam Pro" pitchFamily="34" charset="-122"/>
-                <a:cs typeface="Be Vietnam Pro" pitchFamily="34" charset="-120"/>
-              </a:rPr>
-              <a:t> Project</a:t>
+              <a:t> Comments</a:t>
             </a:r>
             <a:endParaRPr lang="en-US" sz="1650" dirty="0"/>
           </a:p>
@@ -5442,14 +5323,14 @@
       </p:sp>
       <p:sp>
         <p:nvSpPr>
-          <p:cNvPr id="31" name="Text 29"/>
-          <p:cNvSpPr/>
-          <p:nvPr/>
-        </p:nvSpPr>
-        <p:spPr>
-          <a:xfrm>
-            <a:off x="9563100" y="6572250"/>
-            <a:ext cx="3352800" cy="628650"/>
+          <p:cNvPr id="30" name="Text 28"/>
+          <p:cNvSpPr/>
+          <p:nvPr/>
+        </p:nvSpPr>
+        <p:spPr>
+          <a:xfrm>
+            <a:off x="1181100" y="6781800"/>
+            <a:ext cx="4851368" cy="571500"/>
           </a:xfrm>
           <a:prstGeom prst="rect">
             <a:avLst/>
@@ -5458,17 +5339,17 @@
           <a:ln/>
         </p:spPr>
         <p:txBody>
-          <a:bodyPr wrap="square" lIns="0" tIns="9716" rIns="0" bIns="-9716" rtlCol="0" anchor="t"/>
+          <a:bodyPr wrap="square" lIns="0" tIns="8906" rIns="0" bIns="-8906" rtlCol="0" anchor="t"/>
           <a:lstStyle/>
           <a:p>
             <a:pPr algn="l" indent="0" marL="0">
               <a:lnSpc>
-                <a:spcPts val="2340"/>
+                <a:spcPts val="2145"/>
               </a:lnSpc>
               <a:buNone/>
             </a:pPr>
             <a:r>
-              <a:rPr lang="en-US" sz="1800" dirty="0" spc="-21" kern="0">
+              <a:rPr lang="en-US" sz="1650" dirty="0" spc="-9" kern="0">
                 <a:solidFill>
                   <a:srgbClr val="D8D3C4"/>
                 </a:solidFill>
@@ -5476,10 +5357,10 @@
                 <a:ea typeface="Be Vietnam Pro" pitchFamily="34" charset="-122"/>
                 <a:cs typeface="Be Vietnam Pro" pitchFamily="34" charset="-120"/>
               </a:rPr>
-              <a:t>tổ</a:t>
-            </a:r>
-            <a:r>
-              <a:rPr lang="en-US" sz="1800" dirty="0" spc="7" kern="0">
+              <a:t>tài</a:t>
+            </a:r>
+            <a:r>
+              <a:rPr lang="en-US" sz="1650" dirty="0" spc="0" kern="0">
                 <a:solidFill>
                   <a:srgbClr val="D8D3C4"/>
                 </a:solidFill>
@@ -5487,10 +5368,10 @@
                 <a:ea typeface="Be Vietnam Pro" pitchFamily="34" charset="-122"/>
                 <a:cs typeface="Be Vietnam Pro" pitchFamily="34" charset="-120"/>
               </a:rPr>
-              <a:t> chức</a:t>
-            </a:r>
-            <a:r>
-              <a:rPr lang="en-US" sz="1800" dirty="0" spc="-1" kern="0">
+              <a:t> liệu</a:t>
+            </a:r>
+            <a:r>
+              <a:rPr lang="en-US" sz="1650" dirty="0" spc="3" kern="0">
                 <a:solidFill>
                   <a:srgbClr val="D8D3C4"/>
                 </a:solidFill>
@@ -5498,10 +5379,10 @@
                 <a:ea typeface="Be Vietnam Pro" pitchFamily="34" charset="-122"/>
                 <a:cs typeface="Be Vietnam Pro" pitchFamily="34" charset="-120"/>
               </a:rPr>
-              <a:t> cộng</a:t>
-            </a:r>
-            <a:r>
-              <a:rPr lang="en-US" sz="1800" dirty="0" spc="5" kern="0">
+              <a:t> kỹ</a:t>
+            </a:r>
+            <a:r>
+              <a:rPr lang="en-US" sz="1650" dirty="0" spc="-3" kern="0">
                 <a:solidFill>
                   <a:srgbClr val="D8D3C4"/>
                 </a:solidFill>
@@ -5509,10 +5390,10 @@
                 <a:ea typeface="Be Vietnam Pro" pitchFamily="34" charset="-122"/>
                 <a:cs typeface="Be Vietnam Pro" pitchFamily="34" charset="-120"/>
               </a:rPr>
-              <a:t> đồng</a:t>
-            </a:r>
-            <a:r>
-              <a:rPr lang="en-US" sz="1800" dirty="0" spc="-12" kern="0">
+              <a:t> thuật</a:t>
+            </a:r>
+            <a:r>
+              <a:rPr lang="en-US" sz="1650" dirty="0" spc="8" kern="0">
                 <a:solidFill>
                   <a:srgbClr val="D8D3C4"/>
                 </a:solidFill>
@@ -5520,10 +5401,10 @@
                 <a:ea typeface="Be Vietnam Pro" pitchFamily="34" charset="-122"/>
                 <a:cs typeface="Be Vietnam Pro" pitchFamily="34" charset="-120"/>
               </a:rPr>
-              <a:t> về</a:t>
-            </a:r>
-            <a:r>
-              <a:rPr lang="en-US" sz="1800" dirty="0" spc="-1" kern="0">
+              <a:t> đánh</a:t>
+            </a:r>
+            <a:r>
+              <a:rPr lang="en-US" sz="1650" dirty="0" spc="-4" kern="0">
                 <a:solidFill>
                   <a:srgbClr val="D8D3C4"/>
                 </a:solidFill>
@@ -5531,10 +5412,10 @@
                 <a:ea typeface="Be Vietnam Pro" pitchFamily="34" charset="-122"/>
                 <a:cs typeface="Be Vietnam Pro" pitchFamily="34" charset="-120"/>
               </a:rPr>
-              <a:t> bảo</a:t>
-            </a:r>
-            <a:r>
-              <a:rPr lang="en-US" sz="1800" dirty="0" spc="-11" kern="0">
+              <a:t> số</a:t>
+            </a:r>
+            <a:r>
+              <a:rPr lang="en-US" sz="1650" dirty="0" spc="0" kern="0">
                 <a:solidFill>
                   <a:srgbClr val="D8D3C4"/>
                 </a:solidFill>
@@ -5542,10 +5423,10 @@
                 <a:ea typeface="Be Vietnam Pro" pitchFamily="34" charset="-122"/>
                 <a:cs typeface="Be Vietnam Pro" pitchFamily="34" charset="-120"/>
               </a:rPr>
-              <a:t> mật</a:t>
-            </a:r>
-            <a:r>
-              <a:rPr lang="en-US" sz="1800" dirty="0" spc="16" kern="0">
+              <a:t> của</a:t>
+            </a:r>
+            <a:r>
+              <a:rPr lang="en-US" sz="1650" dirty="0" spc="-8" kern="0">
                 <a:solidFill>
                   <a:srgbClr val="D8D3C4"/>
                 </a:solidFill>
@@ -5553,37 +5434,26 @@
                 <a:ea typeface="Be Vietnam Pro" pitchFamily="34" charset="-122"/>
                 <a:cs typeface="Be Vietnam Pro" pitchFamily="34" charset="-120"/>
               </a:rPr>
-              <a:t> ứng</a:t>
-            </a:r>
-            <a:r>
-              <a:rPr lang="en-US" sz="1800" dirty="0" spc="-2" kern="0">
-                <a:solidFill>
-                  <a:srgbClr val="D8D3C4"/>
-                </a:solidFill>
-                <a:latin typeface="Be Vietnam Pro" pitchFamily="34" charset="0"/>
-                <a:ea typeface="Be Vietnam Pro" pitchFamily="34" charset="-122"/>
-                <a:cs typeface="Be Vietnam Pro" pitchFamily="34" charset="-120"/>
-              </a:rPr>
-              <a:t> dụng</a:t>
-            </a:r>
-            <a:endParaRPr lang="en-US" sz="1800" dirty="0"/>
+              <a:t> Internet</a:t>
+            </a:r>
+            <a:endParaRPr lang="en-US" sz="1650" dirty="0"/>
           </a:p>
         </p:txBody>
       </p:sp>
       <p:sp>
         <p:nvSpPr>
-          <p:cNvPr id="32" name="Shape 30"/>
-          <p:cNvSpPr/>
-          <p:nvPr/>
-        </p:nvSpPr>
-        <p:spPr>
-          <a:xfrm>
-            <a:off x="13487400" y="5105400"/>
-            <a:ext cx="3886200" cy="2247900"/>
+          <p:cNvPr id="31" name="Shape 29"/>
+          <p:cNvSpPr/>
+          <p:nvPr/>
+        </p:nvSpPr>
+        <p:spPr>
+          <a:xfrm>
+            <a:off x="6451568" y="5600700"/>
+            <a:ext cx="5384768" cy="1924050"/>
           </a:xfrm>
           <a:prstGeom prst="roundRect">
             <a:avLst>
-              <a:gd name="adj" fmla="val 9322"/>
+              <a:gd name="adj" fmla="val 10891"/>
             </a:avLst>
           </a:prstGeom>
           <a:solidFill>
@@ -5599,14 +5469,14 @@
       </p:sp>
       <p:sp>
         <p:nvSpPr>
-          <p:cNvPr id="33" name="Text 31"/>
-          <p:cNvSpPr/>
-          <p:nvPr/>
-        </p:nvSpPr>
-        <p:spPr>
-          <a:xfrm>
-            <a:off x="13754100" y="5295900"/>
-            <a:ext cx="3352800" cy="571500"/>
+          <p:cNvPr id="32" name="Text 30"/>
+          <p:cNvSpPr/>
+          <p:nvPr/>
+        </p:nvSpPr>
+        <p:spPr>
+          <a:xfrm>
+            <a:off x="6718268" y="5734050"/>
+            <a:ext cx="4851368" cy="419100"/>
           </a:xfrm>
           <a:prstGeom prst="rect">
             <a:avLst/>
@@ -5622,7 +5492,7 @@
               <a:buNone/>
             </a:pPr>
             <a:r>
-              <a:rPr lang="en-US" sz="3450" dirty="0" spc="-1" kern="0">
+              <a:rPr lang="en-US" sz="2550" dirty="0" spc="-62" kern="0">
                 <a:solidFill>
                   <a:srgbClr val="F3EEE3"/>
                 </a:solidFill>
@@ -5630,22 +5500,22 @@
                 <a:ea typeface="Bricolage Grotesque ExtraBold" pitchFamily="34" charset="-122"/>
                 <a:cs typeface="Bricolage Grotesque ExtraBold" pitchFamily="34" charset="-120"/>
               </a:rPr>
-              <a:t>MDN</a:t>
-            </a:r>
-            <a:endParaRPr lang="en-US" sz="3450" dirty="0"/>
+              <a:t>OWASP</a:t>
+            </a:r>
+            <a:endParaRPr lang="en-US" sz="2550" dirty="0"/>
           </a:p>
         </p:txBody>
       </p:sp>
       <p:sp>
         <p:nvSpPr>
-          <p:cNvPr id="34" name="Text 32"/>
-          <p:cNvSpPr/>
-          <p:nvPr/>
-        </p:nvSpPr>
-        <p:spPr>
-          <a:xfrm>
-            <a:off x="13754100" y="5905500"/>
-            <a:ext cx="3352800" cy="590550"/>
+          <p:cNvPr id="33" name="Text 31"/>
+          <p:cNvSpPr/>
+          <p:nvPr/>
+        </p:nvSpPr>
+        <p:spPr>
+          <a:xfrm>
+            <a:off x="6718268" y="6172200"/>
+            <a:ext cx="4851368" cy="552450"/>
           </a:xfrm>
           <a:prstGeom prst="rect">
             <a:avLst/>
@@ -5672,10 +5542,10 @@
                 <a:ea typeface="Be Vietnam Pro" pitchFamily="34" charset="-122"/>
                 <a:cs typeface="Be Vietnam Pro" pitchFamily="34" charset="-120"/>
               </a:rPr>
-              <a:t>Mozilla</a:t>
-            </a:r>
-            <a:r>
-              <a:rPr lang="en-US" sz="1650" dirty="0" spc="-7" kern="0">
+              <a:t>Open</a:t>
+            </a:r>
+            <a:r>
+              <a:rPr lang="en-US" sz="1650" dirty="0" spc="-8" kern="0">
                 <a:solidFill>
                   <a:srgbClr val="9A98A0"/>
                 </a:solidFill>
@@ -5683,10 +5553,10 @@
                 <a:ea typeface="Be Vietnam Pro" pitchFamily="34" charset="-122"/>
                 <a:cs typeface="Be Vietnam Pro" pitchFamily="34" charset="-120"/>
               </a:rPr>
-              <a:t> Developer</a:t>
-            </a:r>
-            <a:r>
-              <a:rPr lang="en-US" sz="1650" dirty="0" spc="-6" kern="0">
+              <a:t> Worldwide</a:t>
+            </a:r>
+            <a:r>
+              <a:rPr lang="en-US" sz="1650" dirty="0" spc="-4" kern="0">
                 <a:solidFill>
                   <a:srgbClr val="9A98A0"/>
                 </a:solidFill>
@@ -5694,7 +5564,29 @@
                 <a:ea typeface="Be Vietnam Pro" pitchFamily="34" charset="-122"/>
                 <a:cs typeface="Be Vietnam Pro" pitchFamily="34" charset="-120"/>
               </a:rPr>
-              <a:t> Network</a:t>
+              <a:t> Application</a:t>
+            </a:r>
+            <a:r>
+              <a:rPr lang="en-US" sz="1650" dirty="0" spc="1" kern="0">
+                <a:solidFill>
+                  <a:srgbClr val="9A98A0"/>
+                </a:solidFill>
+                <a:latin typeface="Be Vietnam Pro" pitchFamily="34" charset="0"/>
+                <a:ea typeface="Be Vietnam Pro" pitchFamily="34" charset="-122"/>
+                <a:cs typeface="Be Vietnam Pro" pitchFamily="34" charset="-120"/>
+              </a:rPr>
+              <a:t> Security</a:t>
+            </a:r>
+            <a:r>
+              <a:rPr lang="en-US" sz="1650" dirty="0" spc="-16" kern="0">
+                <a:solidFill>
+                  <a:srgbClr val="9A98A0"/>
+                </a:solidFill>
+                <a:latin typeface="Be Vietnam Pro" pitchFamily="34" charset="0"/>
+                <a:ea typeface="Be Vietnam Pro" pitchFamily="34" charset="-122"/>
+                <a:cs typeface="Be Vietnam Pro" pitchFamily="34" charset="-120"/>
+              </a:rPr>
+              <a:t> Project</a:t>
             </a:r>
             <a:endParaRPr lang="en-US" sz="1650" dirty="0"/>
           </a:p>
@@ -5702,14 +5594,14 @@
       </p:sp>
       <p:sp>
         <p:nvSpPr>
-          <p:cNvPr id="35" name="Text 33"/>
-          <p:cNvSpPr/>
-          <p:nvPr/>
-        </p:nvSpPr>
-        <p:spPr>
-          <a:xfrm>
-            <a:off x="13754100" y="6572250"/>
-            <a:ext cx="3352800" cy="628650"/>
+          <p:cNvPr id="34" name="Text 32"/>
+          <p:cNvSpPr/>
+          <p:nvPr/>
+        </p:nvSpPr>
+        <p:spPr>
+          <a:xfrm>
+            <a:off x="6718268" y="6781800"/>
+            <a:ext cx="4851368" cy="571500"/>
           </a:xfrm>
           <a:prstGeom prst="rect">
             <a:avLst/>
@@ -5718,17 +5610,17 @@
           <a:ln/>
         </p:spPr>
         <p:txBody>
-          <a:bodyPr wrap="square" lIns="0" tIns="9716" rIns="0" bIns="-9716" rtlCol="0" anchor="t"/>
+          <a:bodyPr wrap="square" lIns="0" tIns="8906" rIns="0" bIns="-8906" rtlCol="0" anchor="t"/>
           <a:lstStyle/>
           <a:p>
             <a:pPr algn="l" indent="0" marL="0">
               <a:lnSpc>
-                <a:spcPts val="2340"/>
+                <a:spcPts val="2145"/>
               </a:lnSpc>
               <a:buNone/>
             </a:pPr>
             <a:r>
-              <a:rPr lang="en-US" sz="1800" dirty="0" spc="-6" kern="0">
+              <a:rPr lang="en-US" sz="1650" dirty="0" spc="-13" kern="0">
                 <a:solidFill>
                   <a:srgbClr val="D8D3C4"/>
                 </a:solidFill>
@@ -5736,10 +5628,10 @@
                 <a:ea typeface="Be Vietnam Pro" pitchFamily="34" charset="-122"/>
                 <a:cs typeface="Be Vietnam Pro" pitchFamily="34" charset="-120"/>
               </a:rPr>
-              <a:t>bộ</a:t>
-            </a:r>
-            <a:r>
-              <a:rPr lang="en-US" sz="1800" dirty="0" spc="-10" kern="0">
+              <a:t>tổ</a:t>
+            </a:r>
+            <a:r>
+              <a:rPr lang="en-US" sz="1650" dirty="0" spc="5" kern="0">
                 <a:solidFill>
                   <a:srgbClr val="D8D3C4"/>
                 </a:solidFill>
@@ -5747,10 +5639,10 @@
                 <a:ea typeface="Be Vietnam Pro" pitchFamily="34" charset="-122"/>
                 <a:cs typeface="Be Vietnam Pro" pitchFamily="34" charset="-120"/>
               </a:rPr>
-              <a:t> tài</a:t>
-            </a:r>
-            <a:r>
-              <a:rPr lang="en-US" sz="1800" dirty="0" spc="-2" kern="0">
+              <a:t> chức</a:t>
+            </a:r>
+            <a:r>
+              <a:rPr lang="en-US" sz="1650" dirty="0" spc="0" kern="0">
                 <a:solidFill>
                   <a:srgbClr val="D8D3C4"/>
                 </a:solidFill>
@@ -5758,10 +5650,10 @@
                 <a:ea typeface="Be Vietnam Pro" pitchFamily="34" charset="-122"/>
                 <a:cs typeface="Be Vietnam Pro" pitchFamily="34" charset="-120"/>
               </a:rPr>
-              <a:t> liệu</a:t>
-            </a:r>
-            <a:r>
-              <a:rPr lang="en-US" sz="1800" dirty="0" spc="-16" kern="0">
+              <a:t> cộng</a:t>
+            </a:r>
+            <a:r>
+              <a:rPr lang="en-US" sz="1650" dirty="0" spc="7" kern="0">
                 <a:solidFill>
                   <a:srgbClr val="D8D3C4"/>
                 </a:solidFill>
@@ -5769,10 +5661,10 @@
                 <a:ea typeface="Be Vietnam Pro" pitchFamily="34" charset="-122"/>
                 <a:cs typeface="Be Vietnam Pro" pitchFamily="34" charset="-120"/>
               </a:rPr>
-              <a:t> tra</a:t>
-            </a:r>
-            <a:r>
-              <a:rPr lang="en-US" sz="1800" dirty="0" spc="13" kern="0">
+              <a:t> đồng</a:t>
+            </a:r>
+            <a:r>
+              <a:rPr lang="en-US" sz="1650" dirty="0" spc="0" kern="0">
                 <a:solidFill>
                   <a:srgbClr val="D8D3C4"/>
                 </a:solidFill>
@@ -5780,10 +5672,10 @@
                 <a:ea typeface="Be Vietnam Pro" pitchFamily="34" charset="-122"/>
                 <a:cs typeface="Be Vietnam Pro" pitchFamily="34" charset="-120"/>
               </a:rPr>
-              <a:t> cứu</a:t>
-            </a:r>
-            <a:r>
-              <a:rPr lang="en-US" sz="1800" dirty="0" spc="-1" kern="0">
+              <a:t> bảo</a:t>
+            </a:r>
+            <a:r>
+              <a:rPr lang="en-US" sz="1650" dirty="0" spc="-6" kern="0">
                 <a:solidFill>
                   <a:srgbClr val="D8D3C4"/>
                 </a:solidFill>
@@ -5791,10 +5683,10 @@
                 <a:ea typeface="Be Vietnam Pro" pitchFamily="34" charset="-122"/>
                 <a:cs typeface="Be Vietnam Pro" pitchFamily="34" charset="-120"/>
               </a:rPr>
-              <a:t> công</a:t>
-            </a:r>
-            <a:r>
-              <a:rPr lang="en-US" sz="1800" dirty="0" spc="-3" kern="0">
+              <a:t> mật</a:t>
+            </a:r>
+            <a:r>
+              <a:rPr lang="en-US" sz="1650" dirty="0" spc="16" kern="0">
                 <a:solidFill>
                   <a:srgbClr val="D8D3C4"/>
                 </a:solidFill>
@@ -5802,10 +5694,10 @@
                 <a:ea typeface="Be Vietnam Pro" pitchFamily="34" charset="-122"/>
                 <a:cs typeface="Be Vietnam Pro" pitchFamily="34" charset="-120"/>
               </a:rPr>
-              <a:t> nghệ</a:t>
-            </a:r>
-            <a:r>
-              <a:rPr lang="en-US" sz="1800" dirty="0" spc="-7" kern="0">
+              <a:t> ứng</a:t>
+            </a:r>
+            <a:r>
+              <a:rPr lang="en-US" sz="1650" dirty="0" spc="0" kern="0">
                 <a:solidFill>
                   <a:srgbClr val="D8D3C4"/>
                 </a:solidFill>
@@ -5813,22 +5705,49 @@
                 <a:ea typeface="Be Vietnam Pro" pitchFamily="34" charset="-122"/>
                 <a:cs typeface="Be Vietnam Pro" pitchFamily="34" charset="-120"/>
               </a:rPr>
-              <a:t> web</a:t>
-            </a:r>
-            <a:endParaRPr lang="en-US" sz="1800" dirty="0"/>
+              <a:t> dụng</a:t>
+            </a:r>
+            <a:endParaRPr lang="en-US" sz="1650" dirty="0"/>
           </a:p>
         </p:txBody>
       </p:sp>
       <p:sp>
         <p:nvSpPr>
+          <p:cNvPr id="35" name="Shape 33"/>
+          <p:cNvSpPr/>
+          <p:nvPr/>
+        </p:nvSpPr>
+        <p:spPr>
+          <a:xfrm>
+            <a:off x="11988737" y="5600700"/>
+            <a:ext cx="5384768" cy="1924050"/>
+          </a:xfrm>
+          <a:prstGeom prst="roundRect">
+            <a:avLst>
+              <a:gd name="adj" fmla="val 10891"/>
+            </a:avLst>
+          </a:prstGeom>
+          <a:solidFill>
+            <a:srgbClr val="1E212B"/>
+          </a:solidFill>
+          <a:ln w="19050">
+            <a:solidFill>
+              <a:srgbClr val="2A2D38"/>
+            </a:solidFill>
+            <a:prstDash val="solid"/>
+          </a:ln>
+        </p:spPr>
+      </p:sp>
+      <p:sp>
+        <p:nvSpPr>
           <p:cNvPr id="36" name="Text 34"/>
           <p:cNvSpPr/>
           <p:nvPr/>
         </p:nvSpPr>
         <p:spPr>
           <a:xfrm>
-            <a:off x="914400" y="7696200"/>
-            <a:ext cx="6667500" cy="285750"/>
+            <a:off x="12255437" y="5734050"/>
+            <a:ext cx="4851368" cy="419100"/>
           </a:xfrm>
           <a:prstGeom prst="rect">
             <a:avLst/>
@@ -5844,37 +5763,79 @@
               <a:buNone/>
             </a:pPr>
             <a:r>
-              <a:rPr lang="en-US" sz="1650" b="1" spc="227" kern="0" dirty="0">
-                <a:solidFill>
-                  <a:srgbClr val="7C93FF"/>
-                </a:solidFill>
-                <a:latin typeface="Be Vietnam Pro" pitchFamily="34" charset="0"/>
-                <a:ea typeface="Be Vietnam Pro" pitchFamily="34" charset="-122"/>
-                <a:cs typeface="Be Vietnam Pro" pitchFamily="34" charset="-120"/>
-              </a:rPr>
-              <a:t>NGUỒN</a:t>
-            </a:r>
-            <a:r>
-              <a:rPr lang="en-US" sz="1650" b="1" spc="229" kern="0" dirty="0">
-                <a:solidFill>
-                  <a:srgbClr val="7C93FF"/>
-                </a:solidFill>
-                <a:latin typeface="Be Vietnam Pro" pitchFamily="34" charset="0"/>
-                <a:ea typeface="Be Vietnam Pro" pitchFamily="34" charset="-122"/>
-                <a:cs typeface="Be Vietnam Pro" pitchFamily="34" charset="-120"/>
-              </a:rPr>
-              <a:t> ĐỐI</a:t>
-            </a:r>
-            <a:r>
-              <a:rPr lang="en-US" sz="1650" b="1" spc="227" kern="0" dirty="0">
-                <a:solidFill>
-                  <a:srgbClr val="7C93FF"/>
-                </a:solidFill>
-                <a:latin typeface="Be Vietnam Pro" pitchFamily="34" charset="0"/>
-                <a:ea typeface="Be Vietnam Pro" pitchFamily="34" charset="-122"/>
-                <a:cs typeface="Be Vietnam Pro" pitchFamily="34" charset="-120"/>
-              </a:rPr>
-              <a:t> CHIẾU</a:t>
+              <a:rPr lang="en-US" sz="2550" dirty="0" spc="-4" kern="0">
+                <a:solidFill>
+                  <a:srgbClr val="F3EEE3"/>
+                </a:solidFill>
+                <a:latin typeface="Bricolage Grotesque ExtraBold" pitchFamily="34" charset="0"/>
+                <a:ea typeface="Bricolage Grotesque ExtraBold" pitchFamily="34" charset="-122"/>
+                <a:cs typeface="Bricolage Grotesque ExtraBold" pitchFamily="34" charset="-120"/>
+              </a:rPr>
+              <a:t>MDN</a:t>
+            </a:r>
+            <a:endParaRPr lang="en-US" sz="2550" dirty="0"/>
+          </a:p>
+        </p:txBody>
+      </p:sp>
+      <p:sp>
+        <p:nvSpPr>
+          <p:cNvPr id="37" name="Text 35"/>
+          <p:cNvSpPr/>
+          <p:nvPr/>
+        </p:nvSpPr>
+        <p:spPr>
+          <a:xfrm>
+            <a:off x="12255437" y="6172200"/>
+            <a:ext cx="4851368" cy="552450"/>
+          </a:xfrm>
+          <a:prstGeom prst="rect">
+            <a:avLst/>
+          </a:prstGeom>
+          <a:noFill/>
+          <a:ln/>
+        </p:spPr>
+        <p:txBody>
+          <a:bodyPr wrap="square" lIns="0" tIns="11509" rIns="0" bIns="-11509" rtlCol="0" anchor="t"/>
+          <a:lstStyle/>
+          <a:p>
+            <a:pPr algn="l" indent="0" marL="0">
+              <a:lnSpc>
+                <a:spcPts val="2063"/>
+              </a:lnSpc>
+              <a:buNone/>
+            </a:pPr>
+            <a:r>
+              <a:rPr lang="en-US" sz="1650" dirty="0" spc="-3" kern="0">
+                <a:solidFill>
+                  <a:srgbClr val="9A98A0"/>
+                </a:solidFill>
+                <a:latin typeface="Be Vietnam Pro" pitchFamily="34" charset="0"/>
+                <a:ea typeface="Be Vietnam Pro" pitchFamily="34" charset="-122"/>
+                <a:cs typeface="Be Vietnam Pro" pitchFamily="34" charset="-120"/>
+              </a:rPr>
+              <a:t>Mozilla</a:t>
+            </a:r>
+            <a:r>
+              <a:rPr lang="en-US" sz="1650" dirty="0" spc="-7" kern="0">
+                <a:solidFill>
+                  <a:srgbClr val="9A98A0"/>
+                </a:solidFill>
+                <a:latin typeface="Be Vietnam Pro" pitchFamily="34" charset="0"/>
+                <a:ea typeface="Be Vietnam Pro" pitchFamily="34" charset="-122"/>
+                <a:cs typeface="Be Vietnam Pro" pitchFamily="34" charset="-120"/>
+              </a:rPr>
+              <a:t> Developer</a:t>
+            </a:r>
+            <a:r>
+              <a:rPr lang="en-US" sz="1650" dirty="0" spc="-6" kern="0">
+                <a:solidFill>
+                  <a:srgbClr val="9A98A0"/>
+                </a:solidFill>
+                <a:latin typeface="Be Vietnam Pro" pitchFamily="34" charset="0"/>
+                <a:ea typeface="Be Vietnam Pro" pitchFamily="34" charset="-122"/>
+                <a:cs typeface="Be Vietnam Pro" pitchFamily="34" charset="-120"/>
+              </a:rPr>
+              <a:t> Network</a:t>
             </a:r>
             <a:endParaRPr lang="en-US" sz="1650" dirty="0"/>
           </a:p>
@@ -5882,14 +5843,122 @@
       </p:sp>
       <p:sp>
         <p:nvSpPr>
-          <p:cNvPr id="37" name="Text 35"/>
-          <p:cNvSpPr/>
-          <p:nvPr/>
-        </p:nvSpPr>
-        <p:spPr>
-          <a:xfrm>
-            <a:off x="914400" y="8058150"/>
-            <a:ext cx="16459200" cy="381000"/>
+          <p:cNvPr id="38" name="Text 36"/>
+          <p:cNvSpPr/>
+          <p:nvPr/>
+        </p:nvSpPr>
+        <p:spPr>
+          <a:xfrm>
+            <a:off x="12255437" y="6781800"/>
+            <a:ext cx="4851368" cy="571500"/>
+          </a:xfrm>
+          <a:prstGeom prst="rect">
+            <a:avLst/>
+          </a:prstGeom>
+          <a:noFill/>
+          <a:ln/>
+        </p:spPr>
+        <p:txBody>
+          <a:bodyPr wrap="square" lIns="0" tIns="8906" rIns="0" bIns="-8906" rtlCol="0" anchor="t"/>
+          <a:lstStyle/>
+          <a:p>
+            <a:pPr algn="l" indent="0" marL="0">
+              <a:lnSpc>
+                <a:spcPts val="2145"/>
+              </a:lnSpc>
+              <a:buNone/>
+            </a:pPr>
+            <a:r>
+              <a:rPr lang="en-US" sz="1650" dirty="0" spc="-3" kern="0">
+                <a:solidFill>
+                  <a:srgbClr val="D8D3C4"/>
+                </a:solidFill>
+                <a:latin typeface="Be Vietnam Pro" pitchFamily="34" charset="0"/>
+                <a:ea typeface="Be Vietnam Pro" pitchFamily="34" charset="-122"/>
+                <a:cs typeface="Be Vietnam Pro" pitchFamily="34" charset="-120"/>
+              </a:rPr>
+              <a:t>bộ</a:t>
+            </a:r>
+            <a:r>
+              <a:rPr lang="en-US" sz="1650" dirty="0" spc="-6" kern="0">
+                <a:solidFill>
+                  <a:srgbClr val="D8D3C4"/>
+                </a:solidFill>
+                <a:latin typeface="Be Vietnam Pro" pitchFamily="34" charset="0"/>
+                <a:ea typeface="Be Vietnam Pro" pitchFamily="34" charset="-122"/>
+                <a:cs typeface="Be Vietnam Pro" pitchFamily="34" charset="-120"/>
+              </a:rPr>
+              <a:t> tài</a:t>
+            </a:r>
+            <a:r>
+              <a:rPr lang="en-US" sz="1650" dirty="0" spc="0" kern="0">
+                <a:solidFill>
+                  <a:srgbClr val="D8D3C4"/>
+                </a:solidFill>
+                <a:latin typeface="Be Vietnam Pro" pitchFamily="34" charset="0"/>
+                <a:ea typeface="Be Vietnam Pro" pitchFamily="34" charset="-122"/>
+                <a:cs typeface="Be Vietnam Pro" pitchFamily="34" charset="-120"/>
+              </a:rPr>
+              <a:t> liệu</a:t>
+            </a:r>
+            <a:r>
+              <a:rPr lang="en-US" sz="1650" dirty="0" spc="-15" kern="0">
+                <a:solidFill>
+                  <a:srgbClr val="D8D3C4"/>
+                </a:solidFill>
+                <a:latin typeface="Be Vietnam Pro" pitchFamily="34" charset="0"/>
+                <a:ea typeface="Be Vietnam Pro" pitchFamily="34" charset="-122"/>
+                <a:cs typeface="Be Vietnam Pro" pitchFamily="34" charset="-120"/>
+              </a:rPr>
+              <a:t> tra</a:t>
+            </a:r>
+            <a:r>
+              <a:rPr lang="en-US" sz="1650" dirty="0" spc="12" kern="0">
+                <a:solidFill>
+                  <a:srgbClr val="D8D3C4"/>
+                </a:solidFill>
+                <a:latin typeface="Be Vietnam Pro" pitchFamily="34" charset="0"/>
+                <a:ea typeface="Be Vietnam Pro" pitchFamily="34" charset="-122"/>
+                <a:cs typeface="Be Vietnam Pro" pitchFamily="34" charset="-120"/>
+              </a:rPr>
+              <a:t> cứu</a:t>
+            </a:r>
+            <a:r>
+              <a:rPr lang="en-US" sz="1650" dirty="0" spc="0" kern="0">
+                <a:solidFill>
+                  <a:srgbClr val="D8D3C4"/>
+                </a:solidFill>
+                <a:latin typeface="Be Vietnam Pro" pitchFamily="34" charset="0"/>
+                <a:ea typeface="Be Vietnam Pro" pitchFamily="34" charset="-122"/>
+                <a:cs typeface="Be Vietnam Pro" pitchFamily="34" charset="-120"/>
+              </a:rPr>
+              <a:t> công nghệ</a:t>
+            </a:r>
+            <a:r>
+              <a:rPr lang="en-US" sz="1650" dirty="0" spc="-7" kern="0">
+                <a:solidFill>
+                  <a:srgbClr val="D8D3C4"/>
+                </a:solidFill>
+                <a:latin typeface="Be Vietnam Pro" pitchFamily="34" charset="0"/>
+                <a:ea typeface="Be Vietnam Pro" pitchFamily="34" charset="-122"/>
+                <a:cs typeface="Be Vietnam Pro" pitchFamily="34" charset="-120"/>
+              </a:rPr>
+              <a:t> web</a:t>
+            </a:r>
+            <a:endParaRPr lang="en-US" sz="1650" dirty="0"/>
+          </a:p>
+        </p:txBody>
+      </p:sp>
+      <p:sp>
+        <p:nvSpPr>
+          <p:cNvPr id="39" name="Text 37"/>
+          <p:cNvSpPr/>
+          <p:nvPr/>
+        </p:nvSpPr>
+        <p:spPr>
+          <a:xfrm>
+            <a:off x="914400" y="7867650"/>
+            <a:ext cx="6667500" cy="285750"/>
           </a:xfrm>
           <a:prstGeom prst="rect">
             <a:avLst/>
@@ -5905,195 +5974,52 @@
               <a:buNone/>
             </a:pPr>
             <a:r>
-              <a:rPr lang="en-US" sz="1800" dirty="0" spc="-4" kern="0">
-                <a:solidFill>
-                  <a:srgbClr val="D8D3C4"/>
-                </a:solidFill>
-                <a:latin typeface="Be Vietnam Pro" pitchFamily="34" charset="0"/>
-                <a:ea typeface="Be Vietnam Pro" pitchFamily="34" charset="-122"/>
-                <a:cs typeface="Be Vietnam Pro" pitchFamily="34" charset="-120"/>
-              </a:rPr>
-              <a:t>ByteByteGo</a:t>
-            </a:r>
-            <a:r>
-              <a:rPr lang="en-US" sz="1800" dirty="0" spc="0" kern="0">
-                <a:solidFill>
-                  <a:srgbClr val="D8D3C4"/>
-                </a:solidFill>
-                <a:latin typeface="Be Vietnam Pro" pitchFamily="34" charset="0"/>
-                <a:ea typeface="Be Vietnam Pro" pitchFamily="34" charset="-122"/>
-                <a:cs typeface="Be Vietnam Pro" pitchFamily="34" charset="-120"/>
-              </a:rPr>
-              <a:t> (bài</a:t>
-            </a:r>
-            <a:r>
-              <a:rPr lang="en-US" sz="1800" dirty="0" spc="-3" kern="0">
-                <a:solidFill>
-                  <a:srgbClr val="D8D3C4"/>
-                </a:solidFill>
-                <a:latin typeface="Be Vietnam Pro" pitchFamily="34" charset="0"/>
-                <a:ea typeface="Be Vietnam Pro" pitchFamily="34" charset="-122"/>
-                <a:cs typeface="Be Vietnam Pro" pitchFamily="34" charset="-120"/>
-              </a:rPr>
-              <a:t> nguồn)</a:t>
-            </a:r>
-            <a:r>
-              <a:rPr lang="en-US" sz="1800" dirty="0" spc="-2" kern="0">
-                <a:solidFill>
-                  <a:srgbClr val="D8D3C4"/>
-                </a:solidFill>
-                <a:latin typeface="Be Vietnam Pro" pitchFamily="34" charset="0"/>
-                <a:ea typeface="Be Vietnam Pro" pitchFamily="34" charset="-122"/>
-                <a:cs typeface="Be Vietnam Pro" pitchFamily="34" charset="-120"/>
-              </a:rPr>
-              <a:t> ·</a:t>
-            </a:r>
-            <a:r>
-              <a:rPr lang="en-US" sz="1800" dirty="0" spc="1" kern="0">
-                <a:solidFill>
-                  <a:srgbClr val="D8D3C4"/>
-                </a:solidFill>
-                <a:latin typeface="Be Vietnam Pro" pitchFamily="34" charset="0"/>
-                <a:ea typeface="Be Vietnam Pro" pitchFamily="34" charset="-122"/>
-                <a:cs typeface="Be Vietnam Pro" pitchFamily="34" charset="-120"/>
-              </a:rPr>
-              <a:t> MDN</a:t>
-            </a:r>
-            <a:r>
-              <a:rPr lang="en-US" sz="1800" dirty="0" spc="-2" kern="0">
-                <a:solidFill>
-                  <a:srgbClr val="D8D3C4"/>
-                </a:solidFill>
-                <a:latin typeface="Be Vietnam Pro" pitchFamily="34" charset="0"/>
-                <a:ea typeface="Be Vietnam Pro" pitchFamily="34" charset="-122"/>
-                <a:cs typeface="Be Vietnam Pro" pitchFamily="34" charset="-120"/>
-              </a:rPr>
-              <a:t> ·</a:t>
-            </a:r>
-            <a:r>
-              <a:rPr lang="en-US" sz="1800" dirty="0" spc="-39" kern="0">
-                <a:solidFill>
-                  <a:srgbClr val="D8D3C4"/>
-                </a:solidFill>
-                <a:latin typeface="Be Vietnam Pro" pitchFamily="34" charset="0"/>
-                <a:ea typeface="Be Vietnam Pro" pitchFamily="34" charset="-122"/>
-                <a:cs typeface="Be Vietnam Pro" pitchFamily="34" charset="-120"/>
-              </a:rPr>
-              <a:t> OWASP</a:t>
-            </a:r>
-            <a:r>
-              <a:rPr lang="en-US" sz="1800" dirty="0" spc="-1" kern="0">
-                <a:solidFill>
-                  <a:srgbClr val="D8D3C4"/>
-                </a:solidFill>
-                <a:latin typeface="Be Vietnam Pro" pitchFamily="34" charset="0"/>
-                <a:ea typeface="Be Vietnam Pro" pitchFamily="34" charset="-122"/>
-                <a:cs typeface="Be Vietnam Pro" pitchFamily="34" charset="-120"/>
-              </a:rPr>
-              <a:t> ·</a:t>
-            </a:r>
-            <a:r>
-              <a:rPr lang="en-US" sz="1800" dirty="0" spc="4" kern="0">
-                <a:solidFill>
-                  <a:srgbClr val="D8D3C4"/>
-                </a:solidFill>
-                <a:latin typeface="Be Vietnam Pro" pitchFamily="34" charset="0"/>
-                <a:ea typeface="Be Vietnam Pro" pitchFamily="34" charset="-122"/>
-                <a:cs typeface="Be Vietnam Pro" pitchFamily="34" charset="-120"/>
-              </a:rPr>
-              <a:t> Python</a:t>
-            </a:r>
-            <a:r>
-              <a:rPr lang="en-US" sz="1800" dirty="0" spc="-2" kern="0">
-                <a:solidFill>
-                  <a:srgbClr val="D8D3C4"/>
-                </a:solidFill>
-                <a:latin typeface="Be Vietnam Pro" pitchFamily="34" charset="0"/>
-                <a:ea typeface="Be Vietnam Pro" pitchFamily="34" charset="-122"/>
-                <a:cs typeface="Be Vietnam Pro" pitchFamily="34" charset="-120"/>
-              </a:rPr>
-              <a:t> (mô-đun</a:t>
-            </a:r>
-            <a:r>
-              <a:rPr lang="en-US" sz="1800" dirty="0" spc="1" kern="0">
-                <a:solidFill>
-                  <a:srgbClr val="D8D3C4"/>
-                </a:solidFill>
-                <a:latin typeface="Be Vietnam Pro" pitchFamily="34" charset="0"/>
-                <a:ea typeface="Be Vietnam Pro" pitchFamily="34" charset="-122"/>
-                <a:cs typeface="Be Vietnam Pro" pitchFamily="34" charset="-120"/>
-              </a:rPr>
-              <a:t> ssl)</a:t>
-            </a:r>
-            <a:r>
-              <a:rPr lang="en-US" sz="1800" dirty="0" spc="-1" kern="0">
-                <a:solidFill>
-                  <a:srgbClr val="D8D3C4"/>
-                </a:solidFill>
-                <a:latin typeface="Be Vietnam Pro" pitchFamily="34" charset="0"/>
-                <a:ea typeface="Be Vietnam Pro" pitchFamily="34" charset="-122"/>
-                <a:cs typeface="Be Vietnam Pro" pitchFamily="34" charset="-120"/>
-              </a:rPr>
-              <a:t> ·</a:t>
-            </a:r>
-            <a:r>
-              <a:rPr lang="en-US" sz="1800" dirty="0" spc="0" kern="0">
-                <a:solidFill>
-                  <a:srgbClr val="D8D3C4"/>
-                </a:solidFill>
-                <a:latin typeface="Be Vietnam Pro" pitchFamily="34" charset="0"/>
-                <a:ea typeface="Be Vietnam Pro" pitchFamily="34" charset="-122"/>
-                <a:cs typeface="Be Vietnam Pro" pitchFamily="34" charset="-120"/>
-              </a:rPr>
-              <a:t> OpenSSL</a:t>
-            </a:r>
-            <a:r>
-              <a:rPr lang="en-US" sz="1800" dirty="0" spc="-3" kern="0">
-                <a:solidFill>
-                  <a:srgbClr val="D8D3C4"/>
-                </a:solidFill>
-                <a:latin typeface="Be Vietnam Pro" pitchFamily="34" charset="0"/>
-                <a:ea typeface="Be Vietnam Pro" pitchFamily="34" charset="-122"/>
-                <a:cs typeface="Be Vietnam Pro" pitchFamily="34" charset="-120"/>
-              </a:rPr>
-              <a:t> (s_client) ·</a:t>
-            </a:r>
-            <a:r>
-              <a:rPr lang="en-US" sz="1800" dirty="0" spc="-22" kern="0">
-                <a:solidFill>
-                  <a:srgbClr val="D8D3C4"/>
-                </a:solidFill>
-                <a:latin typeface="Be Vietnam Pro" pitchFamily="34" charset="0"/>
-                <a:ea typeface="Be Vietnam Pro" pitchFamily="34" charset="-122"/>
-                <a:cs typeface="Be Vietnam Pro" pitchFamily="34" charset="-120"/>
-              </a:rPr>
-              <a:t> pyca/cryptography</a:t>
-            </a:r>
-            <a:r>
-              <a:rPr lang="en-US" sz="1800" dirty="0" spc="2" kern="0">
-                <a:solidFill>
-                  <a:srgbClr val="D8D3C4"/>
-                </a:solidFill>
-                <a:latin typeface="Be Vietnam Pro" pitchFamily="34" charset="0"/>
-                <a:ea typeface="Be Vietnam Pro" pitchFamily="34" charset="-122"/>
-                <a:cs typeface="Be Vietnam Pro" pitchFamily="34" charset="-120"/>
-              </a:rPr>
-              <a:t> (x509)</a:t>
-            </a:r>
-            <a:endParaRPr lang="en-US" sz="1800" dirty="0"/>
+              <a:rPr lang="en-US" sz="1650" b="1" spc="227" kern="0" dirty="0">
+                <a:solidFill>
+                  <a:srgbClr val="7C93FF"/>
+                </a:solidFill>
+                <a:latin typeface="Be Vietnam Pro" pitchFamily="34" charset="0"/>
+                <a:ea typeface="Be Vietnam Pro" pitchFamily="34" charset="-122"/>
+                <a:cs typeface="Be Vietnam Pro" pitchFamily="34" charset="-120"/>
+              </a:rPr>
+              <a:t>NGUỒN</a:t>
+            </a:r>
+            <a:r>
+              <a:rPr lang="en-US" sz="1650" b="1" spc="229" kern="0" dirty="0">
+                <a:solidFill>
+                  <a:srgbClr val="7C93FF"/>
+                </a:solidFill>
+                <a:latin typeface="Be Vietnam Pro" pitchFamily="34" charset="0"/>
+                <a:ea typeface="Be Vietnam Pro" pitchFamily="34" charset="-122"/>
+                <a:cs typeface="Be Vietnam Pro" pitchFamily="34" charset="-120"/>
+              </a:rPr>
+              <a:t> ĐỐI</a:t>
+            </a:r>
+            <a:r>
+              <a:rPr lang="en-US" sz="1650" b="1" spc="227" kern="0" dirty="0">
+                <a:solidFill>
+                  <a:srgbClr val="7C93FF"/>
+                </a:solidFill>
+                <a:latin typeface="Be Vietnam Pro" pitchFamily="34" charset="0"/>
+                <a:ea typeface="Be Vietnam Pro" pitchFamily="34" charset="-122"/>
+                <a:cs typeface="Be Vietnam Pro" pitchFamily="34" charset="-120"/>
+              </a:rPr>
+              <a:t> CHIẾU</a:t>
+            </a:r>
+            <a:endParaRPr lang="en-US" sz="1650" dirty="0"/>
           </a:p>
         </p:txBody>
       </p:sp>
       <p:sp>
         <p:nvSpPr>
-          <p:cNvPr id="38" name="Text 36"/>
-          <p:cNvSpPr/>
-          <p:nvPr/>
-        </p:nvSpPr>
-        <p:spPr>
-          <a:xfrm>
-            <a:off x="914400" y="8553450"/>
-            <a:ext cx="16459200" cy="381000"/>
+          <p:cNvPr id="40" name="Text 38"/>
+          <p:cNvSpPr/>
+          <p:nvPr/>
+        </p:nvSpPr>
+        <p:spPr>
+          <a:xfrm>
+            <a:off x="914400" y="8229600"/>
+            <a:ext cx="16459200" cy="342900"/>
           </a:xfrm>
           <a:prstGeom prst="rect">
             <a:avLst/>
@@ -6109,136 +6035,180 @@
               <a:buNone/>
             </a:pPr>
             <a:r>
-              <a:rPr lang="en-US" sz="1800" dirty="0" spc="3" kern="0">
-                <a:solidFill>
-                  <a:srgbClr val="9A98A0"/>
-                </a:solidFill>
-                <a:latin typeface="Be Vietnam Pro" pitchFamily="34" charset="0"/>
-                <a:ea typeface="Be Vietnam Pro" pitchFamily="34" charset="-122"/>
-                <a:cs typeface="Be Vietnam Pro" pitchFamily="34" charset="-120"/>
-              </a:rPr>
-              <a:t>Đã</a:t>
-            </a:r>
-            <a:r>
-              <a:rPr lang="en-US" sz="1800" dirty="0" spc="10" kern="0">
-                <a:solidFill>
-                  <a:srgbClr val="9A98A0"/>
-                </a:solidFill>
-                <a:latin typeface="Be Vietnam Pro" pitchFamily="34" charset="0"/>
-                <a:ea typeface="Be Vietnam Pro" pitchFamily="34" charset="-122"/>
-                <a:cs typeface="Be Vietnam Pro" pitchFamily="34" charset="-120"/>
-              </a:rPr>
-              <a:t> đối</a:t>
+              <a:rPr lang="en-US" sz="1800" dirty="0" spc="-4" kern="0">
+                <a:solidFill>
+                  <a:srgbClr val="D8D3C4"/>
+                </a:solidFill>
+                <a:latin typeface="Be Vietnam Pro" pitchFamily="34" charset="0"/>
+                <a:ea typeface="Be Vietnam Pro" pitchFamily="34" charset="-122"/>
+                <a:cs typeface="Be Vietnam Pro" pitchFamily="34" charset="-120"/>
+              </a:rPr>
+              <a:t>ByteByteGo</a:t>
+            </a:r>
+            <a:r>
+              <a:rPr lang="en-US" sz="1800" dirty="0" spc="0" kern="0">
+                <a:solidFill>
+                  <a:srgbClr val="D8D3C4"/>
+                </a:solidFill>
+                <a:latin typeface="Be Vietnam Pro" pitchFamily="34" charset="0"/>
+                <a:ea typeface="Be Vietnam Pro" pitchFamily="34" charset="-122"/>
+                <a:cs typeface="Be Vietnam Pro" pitchFamily="34" charset="-120"/>
+              </a:rPr>
+              <a:t> (bài</a:t>
+            </a:r>
+            <a:r>
+              <a:rPr lang="en-US" sz="1800" dirty="0" spc="-3" kern="0">
+                <a:solidFill>
+                  <a:srgbClr val="D8D3C4"/>
+                </a:solidFill>
+                <a:latin typeface="Be Vietnam Pro" pitchFamily="34" charset="0"/>
+                <a:ea typeface="Be Vietnam Pro" pitchFamily="34" charset="-122"/>
+                <a:cs typeface="Be Vietnam Pro" pitchFamily="34" charset="-120"/>
+              </a:rPr>
+              <a:t> nguồn)</a:t>
+            </a:r>
+            <a:r>
+              <a:rPr lang="en-US" sz="1800" dirty="0" spc="-2" kern="0">
+                <a:solidFill>
+                  <a:srgbClr val="D8D3C4"/>
+                </a:solidFill>
+                <a:latin typeface="Be Vietnam Pro" pitchFamily="34" charset="0"/>
+                <a:ea typeface="Be Vietnam Pro" pitchFamily="34" charset="-122"/>
+                <a:cs typeface="Be Vietnam Pro" pitchFamily="34" charset="-120"/>
+              </a:rPr>
+              <a:t> ·</a:t>
+            </a:r>
+            <a:r>
+              <a:rPr lang="en-US" sz="1800" dirty="0" spc="1" kern="0">
+                <a:solidFill>
+                  <a:srgbClr val="D8D3C4"/>
+                </a:solidFill>
+                <a:latin typeface="Be Vietnam Pro" pitchFamily="34" charset="0"/>
+                <a:ea typeface="Be Vietnam Pro" pitchFamily="34" charset="-122"/>
+                <a:cs typeface="Be Vietnam Pro" pitchFamily="34" charset="-120"/>
+              </a:rPr>
+              <a:t> MDN</a:t>
+            </a:r>
+            <a:r>
+              <a:rPr lang="en-US" sz="1800" dirty="0" spc="-2" kern="0">
+                <a:solidFill>
+                  <a:srgbClr val="D8D3C4"/>
+                </a:solidFill>
+                <a:latin typeface="Be Vietnam Pro" pitchFamily="34" charset="0"/>
+                <a:ea typeface="Be Vietnam Pro" pitchFamily="34" charset="-122"/>
+                <a:cs typeface="Be Vietnam Pro" pitchFamily="34" charset="-120"/>
+              </a:rPr>
+              <a:t> ·</a:t>
+            </a:r>
+            <a:r>
+              <a:rPr lang="en-US" sz="1800" dirty="0" spc="-39" kern="0">
+                <a:solidFill>
+                  <a:srgbClr val="D8D3C4"/>
+                </a:solidFill>
+                <a:latin typeface="Be Vietnam Pro" pitchFamily="34" charset="0"/>
+                <a:ea typeface="Be Vietnam Pro" pitchFamily="34" charset="-122"/>
+                <a:cs typeface="Be Vietnam Pro" pitchFamily="34" charset="-120"/>
+              </a:rPr>
+              <a:t> OWASP</a:t>
             </a:r>
             <a:r>
               <a:rPr lang="en-US" sz="1800" dirty="0" spc="-1" kern="0">
                 <a:solidFill>
-                  <a:srgbClr val="9A98A0"/>
-                </a:solidFill>
-                <a:latin typeface="Be Vietnam Pro" pitchFamily="34" charset="0"/>
-                <a:ea typeface="Be Vietnam Pro" pitchFamily="34" charset="-122"/>
-                <a:cs typeface="Be Vietnam Pro" pitchFamily="34" charset="-120"/>
-              </a:rPr>
-              <a:t> chiếu</a:t>
-            </a:r>
-            <a:r>
-              <a:rPr lang="en-US" sz="1800" dirty="0" spc="-14" kern="0">
-                <a:solidFill>
-                  <a:srgbClr val="9A98A0"/>
-                </a:solidFill>
-                <a:latin typeface="Be Vietnam Pro" pitchFamily="34" charset="0"/>
-                <a:ea typeface="Be Vietnam Pro" pitchFamily="34" charset="-122"/>
-                <a:cs typeface="Be Vietnam Pro" pitchFamily="34" charset="-120"/>
-              </a:rPr>
-              <a:t> ngày</a:t>
+                  <a:srgbClr val="D8D3C4"/>
+                </a:solidFill>
+                <a:latin typeface="Be Vietnam Pro" pitchFamily="34" charset="0"/>
+                <a:ea typeface="Be Vietnam Pro" pitchFamily="34" charset="-122"/>
+                <a:cs typeface="Be Vietnam Pro" pitchFamily="34" charset="-120"/>
+              </a:rPr>
+              <a:t> ·</a:t>
+            </a:r>
+            <a:r>
+              <a:rPr lang="en-US" sz="1800" dirty="0" spc="4" kern="0">
+                <a:solidFill>
+                  <a:srgbClr val="D8D3C4"/>
+                </a:solidFill>
+                <a:latin typeface="Be Vietnam Pro" pitchFamily="34" charset="0"/>
+                <a:ea typeface="Be Vietnam Pro" pitchFamily="34" charset="-122"/>
+                <a:cs typeface="Be Vietnam Pro" pitchFamily="34" charset="-120"/>
+              </a:rPr>
+              <a:t> Python</a:t>
+            </a:r>
+            <a:r>
+              <a:rPr lang="en-US" sz="1800" dirty="0" spc="-2" kern="0">
+                <a:solidFill>
+                  <a:srgbClr val="D8D3C4"/>
+                </a:solidFill>
+                <a:latin typeface="Be Vietnam Pro" pitchFamily="34" charset="0"/>
+                <a:ea typeface="Be Vietnam Pro" pitchFamily="34" charset="-122"/>
+                <a:cs typeface="Be Vietnam Pro" pitchFamily="34" charset="-120"/>
+              </a:rPr>
+              <a:t> (mô-đun</a:t>
             </a:r>
             <a:r>
               <a:rPr lang="en-US" sz="1800" dirty="0" spc="1" kern="0">
                 <a:solidFill>
-                  <a:srgbClr val="9A98A0"/>
-                </a:solidFill>
-                <a:latin typeface="Be Vietnam Pro" pitchFamily="34" charset="0"/>
-                <a:ea typeface="Be Vietnam Pro" pitchFamily="34" charset="-122"/>
-                <a:cs typeface="Be Vietnam Pro" pitchFamily="34" charset="-120"/>
-              </a:rPr>
-              <a:t> 2026-10-18.</a:t>
-            </a:r>
-            <a:r>
-              <a:rPr lang="en-US" sz="1800" dirty="0" spc="-2" kern="0">
-                <a:solidFill>
-                  <a:srgbClr val="9A98A0"/>
-                </a:solidFill>
-                <a:latin typeface="Be Vietnam Pro" pitchFamily="34" charset="0"/>
-                <a:ea typeface="Be Vietnam Pro" pitchFamily="34" charset="-122"/>
-                <a:cs typeface="Be Vietnam Pro" pitchFamily="34" charset="-120"/>
-              </a:rPr>
-              <a:t> Hình</a:t>
+                  <a:srgbClr val="D8D3C4"/>
+                </a:solidFill>
+                <a:latin typeface="Be Vietnam Pro" pitchFamily="34" charset="0"/>
+                <a:ea typeface="Be Vietnam Pro" pitchFamily="34" charset="-122"/>
+                <a:cs typeface="Be Vietnam Pro" pitchFamily="34" charset="-120"/>
+              </a:rPr>
+              <a:t> ssl)</a:t>
+            </a:r>
+            <a:r>
+              <a:rPr lang="en-US" sz="1800" dirty="0" spc="-1" kern="0">
+                <a:solidFill>
+                  <a:srgbClr val="D8D3C4"/>
+                </a:solidFill>
+                <a:latin typeface="Be Vietnam Pro" pitchFamily="34" charset="0"/>
+                <a:ea typeface="Be Vietnam Pro" pitchFamily="34" charset="-122"/>
+                <a:cs typeface="Be Vietnam Pro" pitchFamily="34" charset="-120"/>
+              </a:rPr>
+              <a:t> ·</a:t>
+            </a:r>
+            <a:r>
+              <a:rPr lang="en-US" sz="1800" dirty="0" spc="0" kern="0">
+                <a:solidFill>
+                  <a:srgbClr val="D8D3C4"/>
+                </a:solidFill>
+                <a:latin typeface="Be Vietnam Pro" pitchFamily="34" charset="0"/>
+                <a:ea typeface="Be Vietnam Pro" pitchFamily="34" charset="-122"/>
+                <a:cs typeface="Be Vietnam Pro" pitchFamily="34" charset="-120"/>
+              </a:rPr>
+              <a:t> OpenSSL</a:t>
             </a:r>
             <a:r>
               <a:rPr lang="en-US" sz="1800" dirty="0" spc="-3" kern="0">
                 <a:solidFill>
-                  <a:srgbClr val="9A98A0"/>
-                </a:solidFill>
-                <a:latin typeface="Be Vietnam Pro" pitchFamily="34" charset="0"/>
-                <a:ea typeface="Be Vietnam Pro" pitchFamily="34" charset="-122"/>
-                <a:cs typeface="Be Vietnam Pro" pitchFamily="34" charset="-120"/>
-              </a:rPr>
-              <a:t> minh</a:t>
-            </a:r>
-            <a:r>
-              <a:rPr lang="en-US" sz="1800" dirty="0" spc="0" kern="0">
-                <a:solidFill>
-                  <a:srgbClr val="9A98A0"/>
-                </a:solidFill>
-                <a:latin typeface="Be Vietnam Pro" pitchFamily="34" charset="0"/>
-                <a:ea typeface="Be Vietnam Pro" pitchFamily="34" charset="-122"/>
-                <a:cs typeface="Be Vietnam Pro" pitchFamily="34" charset="-120"/>
-              </a:rPr>
-              <a:t> họa</a:t>
-            </a:r>
-            <a:r>
-              <a:rPr lang="en-US" sz="1800" dirty="0" spc="-1" kern="0">
-                <a:solidFill>
-                  <a:srgbClr val="9A98A0"/>
-                </a:solidFill>
-                <a:latin typeface="Be Vietnam Pro" pitchFamily="34" charset="0"/>
-                <a:ea typeface="Be Vietnam Pro" pitchFamily="34" charset="-122"/>
-                <a:cs typeface="Be Vietnam Pro" pitchFamily="34" charset="-120"/>
-              </a:rPr>
-              <a:t> là</a:t>
-            </a:r>
-            <a:r>
-              <a:rPr lang="en-US" sz="1800" dirty="0" spc="-5" kern="0">
-                <a:solidFill>
-                  <a:srgbClr val="9A98A0"/>
-                </a:solidFill>
-                <a:latin typeface="Be Vietnam Pro" pitchFamily="34" charset="0"/>
-                <a:ea typeface="Be Vietnam Pro" pitchFamily="34" charset="-122"/>
-                <a:cs typeface="Be Vietnam Pro" pitchFamily="34" charset="-120"/>
-              </a:rPr>
-              <a:t> thiết</a:t>
-            </a:r>
-            <a:r>
-              <a:rPr lang="en-US" sz="1800" dirty="0" spc="-28" kern="0">
-                <a:solidFill>
-                  <a:srgbClr val="9A98A0"/>
-                </a:solidFill>
-                <a:latin typeface="Be Vietnam Pro" pitchFamily="34" charset="0"/>
-                <a:ea typeface="Be Vietnam Pro" pitchFamily="34" charset="-122"/>
-                <a:cs typeface="Be Vietnam Pro" pitchFamily="34" charset="-120"/>
-              </a:rPr>
-              <a:t> kế</a:t>
-            </a:r>
-            <a:r>
-              <a:rPr lang="en-US" sz="1800" dirty="0" spc="-1" kern="0">
-                <a:solidFill>
-                  <a:srgbClr val="9A98A0"/>
-                </a:solidFill>
-                <a:latin typeface="Be Vietnam Pro" pitchFamily="34" charset="0"/>
-                <a:ea typeface="Be Vietnam Pro" pitchFamily="34" charset="-122"/>
-                <a:cs typeface="Be Vietnam Pro" pitchFamily="34" charset="-120"/>
-              </a:rPr>
-              <a:t> mới.</a:t>
+                  <a:srgbClr val="D8D3C4"/>
+                </a:solidFill>
+                <a:latin typeface="Be Vietnam Pro" pitchFamily="34" charset="0"/>
+                <a:ea typeface="Be Vietnam Pro" pitchFamily="34" charset="-122"/>
+                <a:cs typeface="Be Vietnam Pro" pitchFamily="34" charset="-120"/>
+              </a:rPr>
+              <a:t> (s_client) ·</a:t>
+            </a:r>
+            <a:r>
+              <a:rPr lang="en-US" sz="1800" dirty="0" spc="-22" kern="0">
+                <a:solidFill>
+                  <a:srgbClr val="D8D3C4"/>
+                </a:solidFill>
+                <a:latin typeface="Be Vietnam Pro" pitchFamily="34" charset="0"/>
+                <a:ea typeface="Be Vietnam Pro" pitchFamily="34" charset="-122"/>
+                <a:cs typeface="Be Vietnam Pro" pitchFamily="34" charset="-120"/>
+              </a:rPr>
+              <a:t> pyca/cryptography</a:t>
+            </a:r>
+            <a:r>
+              <a:rPr lang="en-US" sz="1800" dirty="0" spc="2" kern="0">
+                <a:solidFill>
+                  <a:srgbClr val="D8D3C4"/>
+                </a:solidFill>
+                <a:latin typeface="Be Vietnam Pro" pitchFamily="34" charset="0"/>
+                <a:ea typeface="Be Vietnam Pro" pitchFamily="34" charset="-122"/>
+                <a:cs typeface="Be Vietnam Pro" pitchFamily="34" charset="-120"/>
+              </a:rPr>
+              <a:t> (x509)</a:t>
             </a:r>
             <a:endParaRPr lang="en-US" sz="1800" dirty="0"/>
           </a:p>
@@ -6246,7 +6216,145 @@
       </p:sp>
       <p:sp>
         <p:nvSpPr>
-          <p:cNvPr id="39" name="Connector line-1792367682702-43995417"/>
+          <p:cNvPr id="41" name="Text 39"/>
+          <p:cNvSpPr/>
+          <p:nvPr/>
+        </p:nvSpPr>
+        <p:spPr>
+          <a:xfrm>
+            <a:off x="914400" y="8667750"/>
+            <a:ext cx="16459200" cy="323850"/>
+          </a:xfrm>
+          <a:prstGeom prst="rect">
+            <a:avLst/>
+          </a:prstGeom>
+          <a:noFill/>
+          <a:ln/>
+        </p:spPr>
+        <p:txBody>
+          <a:bodyPr wrap="square" lIns="0" tIns="0" rIns="0" bIns="0" rtlCol="0" anchor="t"/>
+          <a:lstStyle/>
+          <a:p>
+            <a:pPr algn="l" indent="0" marL="0">
+              <a:buNone/>
+            </a:pPr>
+            <a:r>
+              <a:rPr lang="en-US" sz="1650" dirty="0" spc="1" kern="0">
+                <a:solidFill>
+                  <a:srgbClr val="9A98A0"/>
+                </a:solidFill>
+                <a:latin typeface="Be Vietnam Pro" pitchFamily="34" charset="0"/>
+                <a:ea typeface="Be Vietnam Pro" pitchFamily="34" charset="-122"/>
+                <a:cs typeface="Be Vietnam Pro" pitchFamily="34" charset="-120"/>
+              </a:rPr>
+              <a:t>Đã</a:t>
+            </a:r>
+            <a:r>
+              <a:rPr lang="en-US" sz="1650" dirty="0" spc="10" kern="0">
+                <a:solidFill>
+                  <a:srgbClr val="9A98A0"/>
+                </a:solidFill>
+                <a:latin typeface="Be Vietnam Pro" pitchFamily="34" charset="0"/>
+                <a:ea typeface="Be Vietnam Pro" pitchFamily="34" charset="-122"/>
+                <a:cs typeface="Be Vietnam Pro" pitchFamily="34" charset="-120"/>
+              </a:rPr>
+              <a:t> đối</a:t>
+            </a:r>
+            <a:r>
+              <a:rPr lang="en-US" sz="1650" dirty="0" spc="1" kern="0">
+                <a:solidFill>
+                  <a:srgbClr val="9A98A0"/>
+                </a:solidFill>
+                <a:latin typeface="Be Vietnam Pro" pitchFamily="34" charset="0"/>
+                <a:ea typeface="Be Vietnam Pro" pitchFamily="34" charset="-122"/>
+                <a:cs typeface="Be Vietnam Pro" pitchFamily="34" charset="-120"/>
+              </a:rPr>
+              <a:t> chiếu</a:t>
+            </a:r>
+            <a:r>
+              <a:rPr lang="en-US" sz="1650" dirty="0" spc="-12" kern="0">
+                <a:solidFill>
+                  <a:srgbClr val="9A98A0"/>
+                </a:solidFill>
+                <a:latin typeface="Be Vietnam Pro" pitchFamily="34" charset="0"/>
+                <a:ea typeface="Be Vietnam Pro" pitchFamily="34" charset="-122"/>
+                <a:cs typeface="Be Vietnam Pro" pitchFamily="34" charset="-120"/>
+              </a:rPr>
+              <a:t> ngày</a:t>
+            </a:r>
+            <a:r>
+              <a:rPr lang="en-US" sz="1650" dirty="0" spc="0" kern="0">
+                <a:solidFill>
+                  <a:srgbClr val="9A98A0"/>
+                </a:solidFill>
+                <a:latin typeface="Be Vietnam Pro" pitchFamily="34" charset="0"/>
+                <a:ea typeface="Be Vietnam Pro" pitchFamily="34" charset="-122"/>
+                <a:cs typeface="Be Vietnam Pro" pitchFamily="34" charset="-120"/>
+              </a:rPr>
+              <a:t> 2026-10-18. Hình</a:t>
+            </a:r>
+            <a:r>
+              <a:rPr lang="en-US" sz="1650" dirty="0" spc="-1" kern="0">
+                <a:solidFill>
+                  <a:srgbClr val="9A98A0"/>
+                </a:solidFill>
+                <a:latin typeface="Be Vietnam Pro" pitchFamily="34" charset="0"/>
+                <a:ea typeface="Be Vietnam Pro" pitchFamily="34" charset="-122"/>
+                <a:cs typeface="Be Vietnam Pro" pitchFamily="34" charset="-120"/>
+              </a:rPr>
+              <a:t> minh họa</a:t>
+            </a:r>
+            <a:r>
+              <a:rPr lang="en-US" sz="1650" dirty="0" spc="1" kern="0">
+                <a:solidFill>
+                  <a:srgbClr val="9A98A0"/>
+                </a:solidFill>
+                <a:latin typeface="Be Vietnam Pro" pitchFamily="34" charset="0"/>
+                <a:ea typeface="Be Vietnam Pro" pitchFamily="34" charset="-122"/>
+                <a:cs typeface="Be Vietnam Pro" pitchFamily="34" charset="-120"/>
+              </a:rPr>
+              <a:t> là</a:t>
+            </a:r>
+            <a:r>
+              <a:rPr lang="en-US" sz="1650" dirty="0" spc="0" kern="0">
+                <a:solidFill>
+                  <a:srgbClr val="9A98A0"/>
+                </a:solidFill>
+                <a:latin typeface="Be Vietnam Pro" pitchFamily="34" charset="0"/>
+                <a:ea typeface="Be Vietnam Pro" pitchFamily="34" charset="-122"/>
+                <a:cs typeface="Be Vietnam Pro" pitchFamily="34" charset="-120"/>
+              </a:rPr>
+              <a:t> thiết</a:t>
+            </a:r>
+            <a:r>
+              <a:rPr lang="en-US" sz="1650" dirty="0" spc="-20" kern="0">
+                <a:solidFill>
+                  <a:srgbClr val="9A98A0"/>
+                </a:solidFill>
+                <a:latin typeface="Be Vietnam Pro" pitchFamily="34" charset="0"/>
+                <a:ea typeface="Be Vietnam Pro" pitchFamily="34" charset="-122"/>
+                <a:cs typeface="Be Vietnam Pro" pitchFamily="34" charset="-120"/>
+              </a:rPr>
+              <a:t> kế</a:t>
+            </a:r>
+            <a:r>
+              <a:rPr lang="en-US" sz="1650" dirty="0" spc="0" kern="0">
+                <a:solidFill>
+                  <a:srgbClr val="9A98A0"/>
+                </a:solidFill>
+                <a:latin typeface="Be Vietnam Pro" pitchFamily="34" charset="0"/>
+                <a:ea typeface="Be Vietnam Pro" pitchFamily="34" charset="-122"/>
+                <a:cs typeface="Be Vietnam Pro" pitchFamily="34" charset="-120"/>
+              </a:rPr>
+              <a:t> mới.</a:t>
+            </a:r>
+            <a:endParaRPr lang="en-US" sz="1650" dirty="0"/>
+          </a:p>
+        </p:txBody>
+      </p:sp>
+      <p:sp>
+        <p:nvSpPr>
+          <p:cNvPr id="42" name="Connector line-1792387917241-990794490"/>
           <p:cNvSpPr/>
           <p:nvPr/>
         </p:nvSpPr>
@@ -6273,7 +6381,7 @@
       </p:sp>
       <p:sp>
         <p:nvSpPr>
-          <p:cNvPr id="40" name="Shape 38"/>
+          <p:cNvPr id="43" name="Shape 41"/>
           <p:cNvSpPr/>
           <p:nvPr/>
         </p:nvSpPr>
@@ -6293,7 +6401,7 @@
       </p:sp>
       <p:sp>
         <p:nvSpPr>
-          <p:cNvPr id="41" name="Shape 39"/>
+          <p:cNvPr id="44" name="Shape 42"/>
           <p:cNvSpPr/>
           <p:nvPr/>
         </p:nvSpPr>
@@ -6313,7 +6421,7 @@
       </p:sp>
       <p:sp>
         <p:nvSpPr>
-          <p:cNvPr id="42" name="Shape 40"/>
+          <p:cNvPr id="45" name="Shape 43"/>
           <p:cNvSpPr/>
           <p:nvPr/>
         </p:nvSpPr>
@@ -6333,7 +6441,7 @@
       </p:sp>
       <p:sp>
         <p:nvSpPr>
-          <p:cNvPr id="43" name="Shape 41"/>
+          <p:cNvPr id="46" name="Shape 44"/>
           <p:cNvSpPr/>
           <p:nvPr/>
         </p:nvSpPr>
@@ -6353,7 +6461,7 @@
       </p:sp>
       <p:sp>
         <p:nvSpPr>
-          <p:cNvPr id="44" name="Shape 42"/>
+          <p:cNvPr id="47" name="Shape 45"/>
           <p:cNvSpPr/>
           <p:nvPr/>
         </p:nvSpPr>
@@ -6373,7 +6481,7 @@
       </p:sp>
       <p:sp>
         <p:nvSpPr>
-          <p:cNvPr id="45" name="Shape 43"/>
+          <p:cNvPr id="48" name="Shape 46"/>
           <p:cNvSpPr/>
           <p:nvPr/>
         </p:nvSpPr>
@@ -6393,7 +6501,7 @@
       </p:sp>
       <p:sp>
         <p:nvSpPr>
-          <p:cNvPr id="46" name="Shape 44"/>
+          <p:cNvPr id="49" name="Shape 47"/>
           <p:cNvSpPr/>
           <p:nvPr/>
         </p:nvSpPr>
@@ -6413,7 +6521,7 @@
       </p:sp>
       <p:sp>
         <p:nvSpPr>
-          <p:cNvPr id="47" name="Shape 45"/>
+          <p:cNvPr id="50" name="Shape 48"/>
           <p:cNvSpPr/>
           <p:nvPr/>
         </p:nvSpPr>
@@ -6433,7 +6541,7 @@
       </p:sp>
       <p:sp>
         <p:nvSpPr>
-          <p:cNvPr id="48" name="Shape 46"/>
+          <p:cNvPr id="51" name="Shape 49"/>
           <p:cNvSpPr/>
           <p:nvPr/>
         </p:nvSpPr>
@@ -6453,7 +6561,7 @@
       </p:sp>
       <p:sp>
         <p:nvSpPr>
-          <p:cNvPr id="49" name="Shape 47"/>
+          <p:cNvPr id="52" name="Shape 50"/>
           <p:cNvSpPr/>
           <p:nvPr/>
         </p:nvSpPr>
@@ -6473,7 +6581,7 @@
       </p:sp>
       <p:sp>
         <p:nvSpPr>
-          <p:cNvPr id="50" name="Text 48"/>
+          <p:cNvPr id="53" name="Text 51"/>
           <p:cNvSpPr/>
           <p:nvPr/>
         </p:nvSpPr>
@@ -6578,7 +6686,7 @@
       </p:sp>
       <p:sp>
         <p:nvSpPr>
-          <p:cNvPr id="51" name="Shape 49"/>
+          <p:cNvPr id="54" name="Shape 52"/>
           <p:cNvSpPr/>
           <p:nvPr/>
         </p:nvSpPr>
@@ -6602,7 +6710,7 @@
       </p:sp>
       <p:pic>
         <p:nvPicPr>
-          <p:cNvPr id="52" name="Moda image moda-export-watermark-775c1219-a801-4c03-be97-048c2daff4c5" descr="">    </p:cNvPr>
+          <p:cNvPr id="55" name="Moda image moda-export-watermark-775c1219-a801-4c03-be97-048c2daff4c5" descr="">    </p:cNvPr>
           <p:cNvPicPr>
             <a:picLocks noChangeAspect="1"/>
           </p:cNvPicPr>

</xml_diff>

<commit_message>
System Design vi: sd-14-021 deck qualifies what trusting a CA makes acceptable
Co-Authored-By: Claude Sonnet 5.5 <noreply@anthropic.com>
Claude-Session: https://claude.ai/code/session_01WnjciXNJBLEd8jy3HrG49S
</commit_message>
<xml_diff>
--- a/system-design-101/vi/lessons/sd-14-021/slides/sd-14-021.pptx
+++ b/system-design-101/vi/lessons/sd-14-021/slides/sd-14-021.pptx
@@ -17501,7 +17501,7 @@
         <p:spPr>
           <a:xfrm>
             <a:off x="914400" y="4476750"/>
-            <a:ext cx="7048500" cy="1238250"/>
+            <a:ext cx="7048500" cy="1428750"/>
           </a:xfrm>
           <a:prstGeom prst="rect">
             <a:avLst/>
@@ -17561,7 +17561,7 @@
                 <a:ea typeface="Be Vietnam Pro" pitchFamily="34" charset="-122"/>
                 <a:cs typeface="Be Vietnam Pro" pitchFamily="34" charset="-120"/>
               </a:rPr>
-              <a:t> là tin mọi</a:t>
+              <a:t> là tin</a:t>
             </a:r>
             <a:r>
               <a:rPr lang="en-US" sz="2550" dirty="0" spc="16" kern="0">
@@ -17597,6 +17597,17 @@
               <a:t> nó</a:t>
             </a:r>
             <a:r>
+              <a:rPr lang="en-US" sz="2550" dirty="0" spc="0" kern="0">
+                <a:solidFill>
+                  <a:srgbClr val="14161C"/>
+                </a:solidFill>
+                <a:latin typeface="Be Vietnam Pro" pitchFamily="34" charset="0"/>
+                <a:ea typeface="Be Vietnam Pro" pitchFamily="34" charset="-122"/>
+                <a:cs typeface="Be Vietnam Pro" pitchFamily="34" charset="-120"/>
+              </a:rPr>
+              <a:t> ký,</a:t>
+            </a:r>
+            <a:r>
               <a:rPr lang="en-US" sz="2550" dirty="0" spc="1" kern="0">
                 <a:solidFill>
                   <a:srgbClr val="14161C"/>
@@ -17605,7 +17616,73 @@
                 <a:ea typeface="Be Vietnam Pro" pitchFamily="34" charset="-122"/>
                 <a:cs typeface="Be Vietnam Pro" pitchFamily="34" charset="-120"/>
               </a:rPr>
-              <a:t> ký.</a:t>
+              <a:t> nếu</a:t>
+            </a:r>
+            <a:r>
+              <a:rPr lang="en-US" sz="2550" dirty="0" spc="2" kern="0">
+                <a:solidFill>
+                  <a:srgbClr val="14161C"/>
+                </a:solidFill>
+                <a:latin typeface="Be Vietnam Pro" pitchFamily="34" charset="0"/>
+                <a:ea typeface="Be Vietnam Pro" pitchFamily="34" charset="-122"/>
+                <a:cs typeface="Be Vietnam Pro" pitchFamily="34" charset="-120"/>
+              </a:rPr>
+              <a:t> qua</a:t>
+            </a:r>
+            <a:r>
+              <a:rPr lang="en-US" sz="2550" dirty="0" spc="0" kern="0">
+                <a:solidFill>
+                  <a:srgbClr val="14161C"/>
+                </a:solidFill>
+                <a:latin typeface="Be Vietnam Pro" pitchFamily="34" charset="0"/>
+                <a:ea typeface="Be Vietnam Pro" pitchFamily="34" charset="-122"/>
+                <a:cs typeface="Be Vietnam Pro" pitchFamily="34" charset="-120"/>
+              </a:rPr>
+              <a:t> các</a:t>
+            </a:r>
+            <a:r>
+              <a:rPr lang="en-US" sz="2550" dirty="0" spc="1" kern="0">
+                <a:solidFill>
+                  <a:srgbClr val="14161C"/>
+                </a:solidFill>
+                <a:latin typeface="Be Vietnam Pro" pitchFamily="34" charset="0"/>
+                <a:ea typeface="Be Vietnam Pro" pitchFamily="34" charset="-122"/>
+                <a:cs typeface="Be Vietnam Pro" pitchFamily="34" charset="-120"/>
+              </a:rPr>
+              <a:t> kiểm</a:t>
+            </a:r>
+            <a:r>
+              <a:rPr lang="en-US" sz="2550" dirty="0" spc="-25" kern="0">
+                <a:solidFill>
+                  <a:srgbClr val="14161C"/>
+                </a:solidFill>
+                <a:latin typeface="Be Vietnam Pro" pitchFamily="34" charset="0"/>
+                <a:ea typeface="Be Vietnam Pro" pitchFamily="34" charset="-122"/>
+                <a:cs typeface="Be Vietnam Pro" pitchFamily="34" charset="-120"/>
+              </a:rPr>
+              <a:t> tra</a:t>
+            </a:r>
+            <a:r>
+              <a:rPr lang="en-US" sz="2550" dirty="0" spc="0" kern="0">
+                <a:solidFill>
+                  <a:srgbClr val="14161C"/>
+                </a:solidFill>
+                <a:latin typeface="Be Vietnam Pro" pitchFamily="34" charset="0"/>
+                <a:ea typeface="Be Vietnam Pro" pitchFamily="34" charset="-122"/>
+                <a:cs typeface="Be Vietnam Pro" pitchFamily="34" charset="-120"/>
+              </a:rPr>
+              <a:t> còn</a:t>
+            </a:r>
+            <a:r>
+              <a:rPr lang="en-US" sz="2550" dirty="0" spc="1" kern="0">
+                <a:solidFill>
+                  <a:srgbClr val="14161C"/>
+                </a:solidFill>
+                <a:latin typeface="Be Vietnam Pro" pitchFamily="34" charset="0"/>
+                <a:ea typeface="Be Vietnam Pro" pitchFamily="34" charset="-122"/>
+                <a:cs typeface="Be Vietnam Pro" pitchFamily="34" charset="-120"/>
+              </a:rPr>
+              <a:t> lại.</a:t>
             </a:r>
             <a:endParaRPr lang="en-US" sz="2550" dirty="0"/>
           </a:p>

</xml_diff>

<commit_message>
System Design vi: sd-14-021 deck says RSA key exchange encrypts a premaster secret
Co-Authored-By: Claude Sonnet 5.5 <noreply@anthropic.com>
Claude-Session: https://claude.ai/code/session_01WnjciXNJBLEd8jy3HrG49S
</commit_message>
<xml_diff>
--- a/system-design-101/vi/lessons/sd-14-021/slides/sd-14-021.pptx
+++ b/system-design-101/vi/lessons/sd-14-021/slides/sd-14-021.pptx
@@ -20624,6 +20624,61 @@
               <a:t> hóa</a:t>
             </a:r>
             <a:r>
+              <a:rPr lang="en-US" sz="2550" dirty="0" spc="-5" kern="0">
+                <a:solidFill>
+                  <a:srgbClr val="D8D3C4"/>
+                </a:solidFill>
+                <a:latin typeface="Be Vietnam Pro" pitchFamily="34" charset="0"/>
+                <a:ea typeface="Be Vietnam Pro" pitchFamily="34" charset="-122"/>
+                <a:cs typeface="Be Vietnam Pro" pitchFamily="34" charset="-120"/>
+              </a:rPr>
+              <a:t> một</a:t>
+            </a:r>
+            <a:r>
+              <a:rPr lang="en-US" sz="2550" dirty="0" spc="1" kern="0">
+                <a:solidFill>
+                  <a:srgbClr val="D8D3C4"/>
+                </a:solidFill>
+                <a:latin typeface="Be Vietnam Pro" pitchFamily="34" charset="0"/>
+                <a:ea typeface="Be Vietnam Pro" pitchFamily="34" charset="-122"/>
+                <a:cs typeface="Be Vietnam Pro" pitchFamily="34" charset="-120"/>
+              </a:rPr>
+              <a:t> bí</a:t>
+            </a:r>
+            <a:r>
+              <a:rPr lang="en-US" sz="2550" dirty="0" spc="-10" kern="0">
+                <a:solidFill>
+                  <a:srgbClr val="D8D3C4"/>
+                </a:solidFill>
+                <a:latin typeface="Be Vietnam Pro" pitchFamily="34" charset="0"/>
+                <a:ea typeface="Be Vietnam Pro" pitchFamily="34" charset="-122"/>
+                <a:cs typeface="Be Vietnam Pro" pitchFamily="34" charset="-120"/>
+              </a:rPr>
+              <a:t> mật</a:t>
+            </a:r>
+            <a:r>
+              <a:rPr lang="en-US" sz="2550" dirty="0" spc="-1" kern="0">
+                <a:solidFill>
+                  <a:srgbClr val="D8D3C4"/>
+                </a:solidFill>
+                <a:latin typeface="Be Vietnam Pro" pitchFamily="34" charset="0"/>
+                <a:ea typeface="Be Vietnam Pro" pitchFamily="34" charset="-122"/>
+                <a:cs typeface="Be Vietnam Pro" pitchFamily="34" charset="-120"/>
+              </a:rPr>
+              <a:t> khởi</a:t>
+            </a:r>
+            <a:r>
+              <a:rPr lang="en-US" sz="2550" dirty="0" spc="-11" kern="0">
+                <a:solidFill>
+                  <a:srgbClr val="D8D3C4"/>
+                </a:solidFill>
+                <a:latin typeface="Be Vietnam Pro" pitchFamily="34" charset="0"/>
+                <a:ea typeface="Be Vietnam Pro" pitchFamily="34" charset="-122"/>
+                <a:cs typeface="Be Vietnam Pro" pitchFamily="34" charset="-120"/>
+              </a:rPr>
+              <a:t> tạo</a:t>
+            </a:r>
+            <a:r>
               <a:rPr lang="en-US" sz="2550" dirty="0" spc="-2" kern="0">
                 <a:solidFill>
                   <a:srgbClr val="D8D3C4"/>
@@ -20632,9 +20687,75 @@
                 <a:ea typeface="Be Vietnam Pro" pitchFamily="34" charset="-122"/>
                 <a:cs typeface="Be Vietnam Pro" pitchFamily="34" charset="-120"/>
               </a:rPr>
+              <a:t> bằng khóa</a:t>
+            </a:r>
+            <a:r>
+              <a:rPr lang="en-US" sz="2550" dirty="0" spc="0" kern="0">
+                <a:solidFill>
+                  <a:srgbClr val="D8D3C4"/>
+                </a:solidFill>
+                <a:latin typeface="Be Vietnam Pro" pitchFamily="34" charset="0"/>
+                <a:ea typeface="Be Vietnam Pro" pitchFamily="34" charset="-122"/>
+                <a:cs typeface="Be Vietnam Pro" pitchFamily="34" charset="-120"/>
+              </a:rPr>
+              <a:t> công</a:t>
+            </a:r>
+            <a:r>
+              <a:rPr lang="en-US" sz="2550" dirty="0" spc="-1" kern="0">
+                <a:solidFill>
+                  <a:srgbClr val="D8D3C4"/>
+                </a:solidFill>
+                <a:latin typeface="Be Vietnam Pro" pitchFamily="34" charset="0"/>
+                <a:ea typeface="Be Vietnam Pro" pitchFamily="34" charset="-122"/>
+                <a:cs typeface="Be Vietnam Pro" pitchFamily="34" charset="-120"/>
+              </a:rPr>
+              <a:t> khai; hai</a:t>
+            </a:r>
+            <a:r>
+              <a:rPr lang="en-US" sz="2550" dirty="0" spc="-3" kern="0">
+                <a:solidFill>
+                  <a:srgbClr val="D8D3C4"/>
+                </a:solidFill>
+                <a:latin typeface="Be Vietnam Pro" pitchFamily="34" charset="0"/>
+                <a:ea typeface="Be Vietnam Pro" pitchFamily="34" charset="-122"/>
+                <a:cs typeface="Be Vietnam Pro" pitchFamily="34" charset="-120"/>
+              </a:rPr>
+              <a:t> bên</a:t>
+            </a:r>
+            <a:r>
+              <a:rPr lang="en-US" sz="2550" dirty="0" spc="1" kern="0">
+                <a:solidFill>
+                  <a:srgbClr val="D8D3C4"/>
+                </a:solidFill>
+                <a:latin typeface="Be Vietnam Pro" pitchFamily="34" charset="0"/>
+                <a:ea typeface="Be Vietnam Pro" pitchFamily="34" charset="-122"/>
+                <a:cs typeface="Be Vietnam Pro" pitchFamily="34" charset="-120"/>
+              </a:rPr>
+              <a:t> tính</a:t>
+            </a:r>
+            <a:r>
+              <a:rPr lang="en-US" sz="2550" dirty="0" spc="-2" kern="0">
+                <a:solidFill>
+                  <a:srgbClr val="D8D3C4"/>
+                </a:solidFill>
+                <a:latin typeface="Be Vietnam Pro" pitchFamily="34" charset="0"/>
+                <a:ea typeface="Be Vietnam Pro" pitchFamily="34" charset="-122"/>
+                <a:cs typeface="Be Vietnam Pro" pitchFamily="34" charset="-120"/>
+              </a:rPr>
               <a:t> khóa</a:t>
             </a:r>
             <a:r>
+              <a:rPr lang="en-US" sz="2550" dirty="0" spc="-1" kern="0">
+                <a:solidFill>
+                  <a:srgbClr val="D8D3C4"/>
+                </a:solidFill>
+                <a:latin typeface="Be Vietnam Pro" pitchFamily="34" charset="0"/>
+                <a:ea typeface="Be Vietnam Pro" pitchFamily="34" charset="-122"/>
+                <a:cs typeface="Be Vietnam Pro" pitchFamily="34" charset="-120"/>
+              </a:rPr>
+              <a:t> phiên</a:t>
+            </a:r>
+            <a:r>
               <a:rPr lang="en-US" sz="2550" dirty="0" spc="0" kern="0">
                 <a:solidFill>
                   <a:srgbClr val="D8D3C4"/>
@@ -20643,10 +20764,10 @@
                 <a:ea typeface="Be Vietnam Pro" pitchFamily="34" charset="-122"/>
                 <a:cs typeface="Be Vietnam Pro" pitchFamily="34" charset="-120"/>
               </a:rPr>
-              <a:t> phiên</a:t>
-            </a:r>
-            <a:r>
-              <a:rPr lang="en-US" sz="2550" dirty="0" spc="-2" kern="0">
+              <a:t> từ</a:t>
+            </a:r>
+            <a:r>
+              <a:rPr lang="en-US" sz="2550" dirty="0" spc="14" kern="0">
                 <a:solidFill>
                   <a:srgbClr val="D8D3C4"/>
                 </a:solidFill>
@@ -20654,117 +20775,7 @@
                 <a:ea typeface="Be Vietnam Pro" pitchFamily="34" charset="-122"/>
                 <a:cs typeface="Be Vietnam Pro" pitchFamily="34" charset="-120"/>
               </a:rPr>
-              <a:t> bằng</a:t>
-            </a:r>
-            <a:r>
-              <a:rPr lang="en-US" sz="2550" dirty="0" spc="-3" kern="0">
-                <a:solidFill>
-                  <a:srgbClr val="D8D3C4"/>
-                </a:solidFill>
-                <a:latin typeface="Be Vietnam Pro" pitchFamily="34" charset="0"/>
-                <a:ea typeface="Be Vietnam Pro" pitchFamily="34" charset="-122"/>
-                <a:cs typeface="Be Vietnam Pro" pitchFamily="34" charset="-120"/>
-              </a:rPr>
-              <a:t> khóa</a:t>
-            </a:r>
-            <a:r>
-              <a:rPr lang="en-US" sz="2550" dirty="0" spc="0" kern="0">
-                <a:solidFill>
-                  <a:srgbClr val="D8D3C4"/>
-                </a:solidFill>
-                <a:latin typeface="Be Vietnam Pro" pitchFamily="34" charset="0"/>
-                <a:ea typeface="Be Vietnam Pro" pitchFamily="34" charset="-122"/>
-                <a:cs typeface="Be Vietnam Pro" pitchFamily="34" charset="-120"/>
-              </a:rPr>
-              <a:t> công</a:t>
-            </a:r>
-            <a:r>
-              <a:rPr lang="en-US" sz="2550" dirty="0" spc="1" kern="0">
-                <a:solidFill>
-                  <a:srgbClr val="D8D3C4"/>
-                </a:solidFill>
-                <a:latin typeface="Be Vietnam Pro" pitchFamily="34" charset="0"/>
-                <a:ea typeface="Be Vietnam Pro" pitchFamily="34" charset="-122"/>
-                <a:cs typeface="Be Vietnam Pro" pitchFamily="34" charset="-120"/>
-              </a:rPr>
-              <a:t> khai.</a:t>
-            </a:r>
-            <a:r>
-              <a:rPr lang="en-US" sz="2550" dirty="0" spc="-27" kern="0">
-                <a:solidFill>
-                  <a:srgbClr val="D8D3C4"/>
-                </a:solidFill>
-                <a:latin typeface="Be Vietnam Pro" pitchFamily="34" charset="0"/>
-                <a:ea typeface="Be Vietnam Pro" pitchFamily="34" charset="-122"/>
-                <a:cs typeface="Be Vietnam Pro" pitchFamily="34" charset="-120"/>
-              </a:rPr>
-              <a:t> Relay</a:t>
-            </a:r>
-            <a:r>
-              <a:rPr lang="en-US" sz="2550" dirty="0" spc="0" kern="0">
-                <a:solidFill>
-                  <a:srgbClr val="D8D3C4"/>
-                </a:solidFill>
-                <a:latin typeface="Be Vietnam Pro" pitchFamily="34" charset="0"/>
-                <a:ea typeface="Be Vietnam Pro" pitchFamily="34" charset="-122"/>
-                <a:cs typeface="Be Vietnam Pro" pitchFamily="34" charset="-120"/>
-              </a:rPr>
-              <a:t> giải</a:t>
-            </a:r>
-            <a:r>
-              <a:rPr lang="en-US" sz="2550" dirty="0" spc="1" kern="0">
-                <a:solidFill>
-                  <a:srgbClr val="D8D3C4"/>
-                </a:solidFill>
-                <a:latin typeface="Be Vietnam Pro" pitchFamily="34" charset="0"/>
-                <a:ea typeface="Be Vietnam Pro" pitchFamily="34" charset="-122"/>
-                <a:cs typeface="Be Vietnam Pro" pitchFamily="34" charset="-120"/>
-              </a:rPr>
-              <a:t> mã</a:t>
-            </a:r>
-            <a:r>
-              <a:rPr lang="en-US" sz="2550" dirty="0" spc="-26" kern="0">
-                <a:solidFill>
-                  <a:srgbClr val="D8D3C4"/>
-                </a:solidFill>
-                <a:latin typeface="Be Vietnam Pro" pitchFamily="34" charset="0"/>
-                <a:ea typeface="Be Vietnam Pro" pitchFamily="34" charset="-122"/>
-                <a:cs typeface="Be Vietnam Pro" pitchFamily="34" charset="-120"/>
-              </a:rPr>
-              <a:t> rồi</a:t>
-            </a:r>
-            <a:r>
-              <a:rPr lang="en-US" sz="2550" dirty="0" spc="1" kern="0">
-                <a:solidFill>
-                  <a:srgbClr val="D8D3C4"/>
-                </a:solidFill>
-                <a:latin typeface="Be Vietnam Pro" pitchFamily="34" charset="0"/>
-                <a:ea typeface="Be Vietnam Pro" pitchFamily="34" charset="-122"/>
-                <a:cs typeface="Be Vietnam Pro" pitchFamily="34" charset="-120"/>
-              </a:rPr>
-              <a:t> mã</a:t>
-            </a:r>
-            <a:r>
-              <a:rPr lang="en-US" sz="2550" dirty="0" spc="-4" kern="0">
-                <a:solidFill>
-                  <a:srgbClr val="D8D3C4"/>
-                </a:solidFill>
-                <a:latin typeface="Be Vietnam Pro" pitchFamily="34" charset="0"/>
-                <a:ea typeface="Be Vietnam Pro" pitchFamily="34" charset="-122"/>
-                <a:cs typeface="Be Vietnam Pro" pitchFamily="34" charset="-120"/>
-              </a:rPr>
-              <a:t> hóa</a:t>
-            </a:r>
-            <a:r>
-              <a:rPr lang="en-US" sz="2550" dirty="0" spc="1" kern="0">
-                <a:solidFill>
-                  <a:srgbClr val="D8D3C4"/>
-                </a:solidFill>
-                <a:latin typeface="Be Vietnam Pro" pitchFamily="34" charset="0"/>
-                <a:ea typeface="Be Vietnam Pro" pitchFamily="34" charset="-122"/>
-                <a:cs typeface="Be Vietnam Pro" pitchFamily="34" charset="-120"/>
-              </a:rPr>
-              <a:t> lại.</a:t>
+              <a:t> đó.</a:t>
             </a:r>
             <a:endParaRPr lang="en-US" sz="2550" dirty="0"/>
           </a:p>
@@ -22736,7 +22747,7 @@
               <a:t> mã</a:t>
             </a:r>
             <a:r>
-              <a:rPr lang="en-US" sz="1950" dirty="0" spc="-4" kern="0">
+              <a:rPr lang="en-US" sz="1950" dirty="0" spc="-20" kern="0">
                 <a:solidFill>
                   <a:srgbClr val="F3EEE3"/>
                 </a:solidFill>
@@ -22744,7 +22755,7 @@
                 <a:ea typeface="Be Vietnam Pro" pitchFamily="34" charset="-122"/>
                 <a:cs typeface="Be Vietnam Pro" pitchFamily="34" charset="-120"/>
               </a:rPr>
-              <a:t> khóa</a:t>
+              <a:t> rồi</a:t>
             </a:r>
             <a:r>
               <a:rPr lang="en-US" sz="1950" dirty="0" spc="0" kern="0">
@@ -22755,10 +22766,10 @@
                 <a:ea typeface="Be Vietnam Pro" pitchFamily="34" charset="-122"/>
                 <a:cs typeface="Be Vietnam Pro" pitchFamily="34" charset="-120"/>
               </a:rPr>
-              <a:t> phiên</a:t>
-            </a:r>
-            <a:r>
-              <a:rPr lang="en-US" sz="1950" dirty="0" spc="-19" kern="0">
+              <a:t> mã</a:t>
+            </a:r>
+            <a:r>
+              <a:rPr lang="en-US" sz="1950" dirty="0" spc="-3" kern="0">
                 <a:solidFill>
                   <a:srgbClr val="F3EEE3"/>
                 </a:solidFill>
@@ -22766,10 +22777,10 @@
                 <a:ea typeface="Be Vietnam Pro" pitchFamily="34" charset="-122"/>
                 <a:cs typeface="Be Vietnam Pro" pitchFamily="34" charset="-120"/>
               </a:rPr>
-              <a:t> rồi</a:t>
-            </a:r>
-            <a:r>
-              <a:rPr lang="en-US" sz="1950" dirty="0" spc="0" kern="0">
+              <a:t> hóa</a:t>
+            </a:r>
+            <a:r>
+              <a:rPr lang="en-US" sz="1950" dirty="0" spc="-1" kern="0">
                 <a:solidFill>
                   <a:srgbClr val="F3EEE3"/>
                 </a:solidFill>
@@ -22777,10 +22788,10 @@
                 <a:ea typeface="Be Vietnam Pro" pitchFamily="34" charset="-122"/>
                 <a:cs typeface="Be Vietnam Pro" pitchFamily="34" charset="-120"/>
               </a:rPr>
-              <a:t> mã</a:t>
-            </a:r>
-            <a:r>
-              <a:rPr lang="en-US" sz="1950" dirty="0" spc="-4" kern="0">
+              <a:t> lại</a:t>
+            </a:r>
+            <a:r>
+              <a:rPr lang="en-US" sz="1950" dirty="0" spc="-6" kern="0">
                 <a:solidFill>
                   <a:srgbClr val="F3EEE3"/>
                 </a:solidFill>
@@ -22788,7 +22799,7 @@
                 <a:ea typeface="Be Vietnam Pro" pitchFamily="34" charset="-122"/>
                 <a:cs typeface="Be Vietnam Pro" pitchFamily="34" charset="-120"/>
               </a:rPr>
-              <a:t> hóa</a:t>
+              <a:t> một</a:t>
             </a:r>
             <a:r>
               <a:rPr lang="en-US" sz="1950" dirty="0" spc="-1" kern="0">
@@ -22799,7 +22810,18 @@
                 <a:ea typeface="Be Vietnam Pro" pitchFamily="34" charset="-122"/>
                 <a:cs typeface="Be Vietnam Pro" pitchFamily="34" charset="-120"/>
               </a:rPr>
-              <a:t> lại. Nó</a:t>
+              <a:t> bí</a:t>
+            </a:r>
+            <a:r>
+              <a:rPr lang="en-US" sz="1950" dirty="0" spc="-9" kern="0">
+                <a:solidFill>
+                  <a:srgbClr val="F3EEE3"/>
+                </a:solidFill>
+                <a:latin typeface="Be Vietnam Pro" pitchFamily="34" charset="0"/>
+                <a:ea typeface="Be Vietnam Pro" pitchFamily="34" charset="-122"/>
+                <a:cs typeface="Be Vietnam Pro" pitchFamily="34" charset="-120"/>
+              </a:rPr>
+              <a:t> mật.</a:t>
             </a:r>
             <a:r>
               <a:rPr lang="en-US" sz="1950" dirty="0" spc="-2" kern="0">
@@ -22810,7 +22832,29 @@
                 <a:ea typeface="Be Vietnam Pro" pitchFamily="34" charset="-122"/>
                 <a:cs typeface="Be Vietnam Pro" pitchFamily="34" charset="-120"/>
               </a:rPr>
-              <a:t> chỉ là</a:t>
+              <a:t> Nó</a:t>
+            </a:r>
+            <a:r>
+              <a:rPr lang="en-US" sz="1950" dirty="0" spc="-1" kern="0">
+                <a:solidFill>
+                  <a:srgbClr val="F3EEE3"/>
+                </a:solidFill>
+                <a:latin typeface="Be Vietnam Pro" pitchFamily="34" charset="0"/>
+                <a:ea typeface="Be Vietnam Pro" pitchFamily="34" charset="-122"/>
+                <a:cs typeface="Be Vietnam Pro" pitchFamily="34" charset="-120"/>
+              </a:rPr>
+              <a:t> chỉ</a:t>
+            </a:r>
+            <a:r>
+              <a:rPr lang="en-US" sz="1950" dirty="0" spc="-2" kern="0">
+                <a:solidFill>
+                  <a:srgbClr val="F3EEE3"/>
+                </a:solidFill>
+                <a:latin typeface="Be Vietnam Pro" pitchFamily="34" charset="0"/>
+                <a:ea typeface="Be Vietnam Pro" pitchFamily="34" charset="-122"/>
+                <a:cs typeface="Be Vietnam Pro" pitchFamily="34" charset="-120"/>
+              </a:rPr>
+              <a:t> là</a:t>
             </a:r>
             <a:r>
               <a:rPr lang="en-US" sz="1950" dirty="0" spc="-6" kern="0">
@@ -22846,7 +22890,7 @@
               <a:t> TLS</a:t>
             </a:r>
             <a:r>
-              <a:rPr lang="en-US" sz="1950" dirty="0" spc="-2" kern="0">
+              <a:rPr lang="en-US" sz="1950" dirty="0" spc="-3" kern="0">
                 <a:solidFill>
                   <a:srgbClr val="F3EEE3"/>
                 </a:solidFill>

</xml_diff>